<commit_message>
docs: polish daily status report layout
Co-authored-by: 程序员鱼皮 <592789970@qq.com>
</commit_message>
<xml_diff>
--- a/docs/reports/project-status-2026-06-03.pptx
+++ b/docs/reports/project-status-2026-06-03.pptx
@@ -3796,6 +3796,388 @@
           </a:p>
         </p:txBody>
       </p:sp>
+      <p:sp>
+        <p:nvSpPr>
+          <p:cNvPr id="20" name="Rectangle 19"/>
+          <p:cNvSpPr/>
+          <p:nvPr/>
+        </p:nvSpPr>
+        <p:spPr>
+          <a:xfrm>
+            <a:off x="7635240" y="960120"/>
+            <a:ext cx="3337560" cy="3246120"/>
+          </a:xfrm>
+          <a:prstGeom prst="rect">
+            <a:avLst/>
+          </a:prstGeom>
+          <a:solidFill>
+            <a:srgbClr val="21295C"/>
+          </a:solidFill>
+          <a:ln>
+            <a:noFill/>
+          </a:ln>
+        </p:spPr>
+        <p:style>
+          <a:lnRef idx="1">
+            <a:schemeClr val="accent1"/>
+          </a:lnRef>
+          <a:fillRef idx="3">
+            <a:schemeClr val="accent1"/>
+          </a:fillRef>
+          <a:effectRef idx="2">
+            <a:schemeClr val="accent1"/>
+          </a:effectRef>
+          <a:fontRef idx="minor">
+            <a:schemeClr val="lt1"/>
+          </a:fontRef>
+        </p:style>
+        <p:txBody>
+          <a:bodyPr rtlCol="0" anchor="ctr"/>
+          <a:lstStyle/>
+          <a:p>
+            <a:pPr algn="ctr"/>
+          </a:p>
+        </p:txBody>
+      </p:sp>
+      <p:sp>
+        <p:nvSpPr>
+          <p:cNvPr id="21" name="Rounded Rectangle 20"/>
+          <p:cNvSpPr/>
+          <p:nvPr/>
+        </p:nvSpPr>
+        <p:spPr>
+          <a:xfrm>
+            <a:off x="7845552" y="1115568"/>
+            <a:ext cx="2788920" cy="676656"/>
+          </a:xfrm>
+          <a:prstGeom prst="roundRect">
+            <a:avLst/>
+          </a:prstGeom>
+          <a:solidFill>
+            <a:srgbClr val="028090"/>
+          </a:solidFill>
+          <a:ln>
+            <a:noFill/>
+          </a:ln>
+        </p:spPr>
+        <p:style>
+          <a:lnRef idx="1">
+            <a:schemeClr val="accent1"/>
+          </a:lnRef>
+          <a:fillRef idx="3">
+            <a:schemeClr val="accent1"/>
+          </a:fillRef>
+          <a:effectRef idx="2">
+            <a:schemeClr val="accent1"/>
+          </a:effectRef>
+          <a:fontRef idx="minor">
+            <a:schemeClr val="lt1"/>
+          </a:fontRef>
+        </p:style>
+        <p:txBody>
+          <a:bodyPr rtlCol="0" anchor="ctr"/>
+          <a:lstStyle/>
+          <a:p>
+            <a:pPr algn="ctr"/>
+          </a:p>
+        </p:txBody>
+      </p:sp>
+      <p:sp>
+        <p:nvSpPr>
+          <p:cNvPr id="22" name="TextBox 21"/>
+          <p:cNvSpPr txBox="1"/>
+          <p:nvPr/>
+        </p:nvSpPr>
+        <p:spPr>
+          <a:xfrm>
+            <a:off x="8101583" y="1252728"/>
+            <a:ext cx="822960" cy="164592"/>
+          </a:xfrm>
+          <a:prstGeom prst="rect">
+            <a:avLst/>
+          </a:prstGeom>
+          <a:noFill/>
+        </p:spPr>
+        <p:txBody>
+          <a:bodyPr wrap="square" lIns="0" rIns="0" tIns="0" bIns="0" anchor="t">
+            <a:spAutoFit/>
+          </a:bodyPr>
+          <a:lstStyle/>
+          <a:p>
+            <a:pPr algn="l"/>
+            <a:r>
+              <a:rPr sz="950" b="1">
+                <a:solidFill>
+                  <a:srgbClr val="D6F4EF"/>
+                </a:solidFill>
+                <a:latin typeface="Calibri"/>
+              </a:rPr>
+              <a:t>代码生成</a:t>
+            </a:r>
+          </a:p>
+        </p:txBody>
+      </p:sp>
+      <p:sp>
+        <p:nvSpPr>
+          <p:cNvPr id="23" name="TextBox 22"/>
+          <p:cNvSpPr txBox="1"/>
+          <p:nvPr/>
+        </p:nvSpPr>
+        <p:spPr>
+          <a:xfrm>
+            <a:off x="8961120" y="1234440"/>
+            <a:ext cx="1417320" cy="219456"/>
+          </a:xfrm>
+          <a:prstGeom prst="rect">
+            <a:avLst/>
+          </a:prstGeom>
+          <a:noFill/>
+        </p:spPr>
+        <p:txBody>
+          <a:bodyPr wrap="square" lIns="0" rIns="0" tIns="0" bIns="0" anchor="t">
+            <a:spAutoFit/>
+          </a:bodyPr>
+          <a:lstStyle/>
+          <a:p>
+            <a:pPr algn="l"/>
+            <a:r>
+              <a:rPr sz="1500" b="1">
+                <a:solidFill>
+                  <a:srgbClr val="FFFFFF"/>
+                </a:solidFill>
+                <a:latin typeface="Calibri"/>
+              </a:rPr>
+              <a:t>AI 工具链</a:t>
+            </a:r>
+          </a:p>
+        </p:txBody>
+      </p:sp>
+      <p:sp>
+        <p:nvSpPr>
+          <p:cNvPr id="24" name="Rounded Rectangle 23"/>
+          <p:cNvSpPr/>
+          <p:nvPr/>
+        </p:nvSpPr>
+        <p:spPr>
+          <a:xfrm>
+            <a:off x="7845552" y="2075688"/>
+            <a:ext cx="2788920" cy="676656"/>
+          </a:xfrm>
+          <a:prstGeom prst="roundRect">
+            <a:avLst/>
+          </a:prstGeom>
+          <a:solidFill>
+            <a:srgbClr val="1C7293"/>
+          </a:solidFill>
+          <a:ln>
+            <a:noFill/>
+          </a:ln>
+        </p:spPr>
+        <p:style>
+          <a:lnRef idx="1">
+            <a:schemeClr val="accent1"/>
+          </a:lnRef>
+          <a:fillRef idx="3">
+            <a:schemeClr val="accent1"/>
+          </a:fillRef>
+          <a:effectRef idx="2">
+            <a:schemeClr val="accent1"/>
+          </a:effectRef>
+          <a:fontRef idx="minor">
+            <a:schemeClr val="lt1"/>
+          </a:fontRef>
+        </p:style>
+        <p:txBody>
+          <a:bodyPr rtlCol="0" anchor="ctr"/>
+          <a:lstStyle/>
+          <a:p>
+            <a:pPr algn="ctr"/>
+          </a:p>
+        </p:txBody>
+      </p:sp>
+      <p:sp>
+        <p:nvSpPr>
+          <p:cNvPr id="25" name="TextBox 24"/>
+          <p:cNvSpPr txBox="1"/>
+          <p:nvPr/>
+        </p:nvSpPr>
+        <p:spPr>
+          <a:xfrm>
+            <a:off x="8101583" y="2212848"/>
+            <a:ext cx="822960" cy="164592"/>
+          </a:xfrm>
+          <a:prstGeom prst="rect">
+            <a:avLst/>
+          </a:prstGeom>
+          <a:noFill/>
+        </p:spPr>
+        <p:txBody>
+          <a:bodyPr wrap="square" lIns="0" rIns="0" tIns="0" bIns="0" anchor="t">
+            <a:spAutoFit/>
+          </a:bodyPr>
+          <a:lstStyle/>
+          <a:p>
+            <a:pPr algn="l"/>
+            <a:r>
+              <a:rPr sz="950" b="1">
+                <a:solidFill>
+                  <a:srgbClr val="D6F4EF"/>
+                </a:solidFill>
+                <a:latin typeface="Calibri"/>
+              </a:rPr>
+              <a:t>架构阶段</a:t>
+            </a:r>
+          </a:p>
+        </p:txBody>
+      </p:sp>
+      <p:sp>
+        <p:nvSpPr>
+          <p:cNvPr id="26" name="TextBox 25"/>
+          <p:cNvSpPr txBox="1"/>
+          <p:nvPr/>
+        </p:nvSpPr>
+        <p:spPr>
+          <a:xfrm>
+            <a:off x="8961120" y="2194560"/>
+            <a:ext cx="1417320" cy="219456"/>
+          </a:xfrm>
+          <a:prstGeom prst="rect">
+            <a:avLst/>
+          </a:prstGeom>
+          <a:noFill/>
+        </p:spPr>
+        <p:txBody>
+          <a:bodyPr wrap="square" lIns="0" rIns="0" tIns="0" bIns="0" anchor="t">
+            <a:spAutoFit/>
+          </a:bodyPr>
+          <a:lstStyle/>
+          <a:p>
+            <a:pPr algn="l"/>
+            <a:r>
+              <a:rPr sz="1500" b="1">
+                <a:solidFill>
+                  <a:srgbClr val="FFFFFF"/>
+                </a:solidFill>
+                <a:latin typeface="Calibri"/>
+              </a:rPr>
+              <a:t>微服务完成态</a:t>
+            </a:r>
+          </a:p>
+        </p:txBody>
+      </p:sp>
+      <p:sp>
+        <p:nvSpPr>
+          <p:cNvPr id="27" name="Rounded Rectangle 26"/>
+          <p:cNvSpPr/>
+          <p:nvPr/>
+        </p:nvSpPr>
+        <p:spPr>
+          <a:xfrm>
+            <a:off x="7845552" y="3035808"/>
+            <a:ext cx="2788920" cy="676656"/>
+          </a:xfrm>
+          <a:prstGeom prst="roundRect">
+            <a:avLst/>
+          </a:prstGeom>
+          <a:solidFill>
+            <a:srgbClr val="02C39A"/>
+          </a:solidFill>
+          <a:ln>
+            <a:noFill/>
+          </a:ln>
+        </p:spPr>
+        <p:style>
+          <a:lnRef idx="1">
+            <a:schemeClr val="accent1"/>
+          </a:lnRef>
+          <a:fillRef idx="3">
+            <a:schemeClr val="accent1"/>
+          </a:fillRef>
+          <a:effectRef idx="2">
+            <a:schemeClr val="accent1"/>
+          </a:effectRef>
+          <a:fontRef idx="minor">
+            <a:schemeClr val="lt1"/>
+          </a:fontRef>
+        </p:style>
+        <p:txBody>
+          <a:bodyPr rtlCol="0" anchor="ctr"/>
+          <a:lstStyle/>
+          <a:p>
+            <a:pPr algn="ctr"/>
+          </a:p>
+        </p:txBody>
+      </p:sp>
+      <p:sp>
+        <p:nvSpPr>
+          <p:cNvPr id="28" name="TextBox 27"/>
+          <p:cNvSpPr txBox="1"/>
+          <p:nvPr/>
+        </p:nvSpPr>
+        <p:spPr>
+          <a:xfrm>
+            <a:off x="8101583" y="3172968"/>
+            <a:ext cx="822960" cy="164592"/>
+          </a:xfrm>
+          <a:prstGeom prst="rect">
+            <a:avLst/>
+          </a:prstGeom>
+          <a:noFill/>
+        </p:spPr>
+        <p:txBody>
+          <a:bodyPr wrap="square" lIns="0" rIns="0" tIns="0" bIns="0" anchor="t">
+            <a:spAutoFit/>
+          </a:bodyPr>
+          <a:lstStyle/>
+          <a:p>
+            <a:pPr algn="l"/>
+            <a:r>
+              <a:rPr sz="950" b="1">
+                <a:solidFill>
+                  <a:srgbClr val="D6F4EF"/>
+                </a:solidFill>
+                <a:latin typeface="Calibri"/>
+              </a:rPr>
+              <a:t>验证重点</a:t>
+            </a:r>
+          </a:p>
+        </p:txBody>
+      </p:sp>
+      <p:sp>
+        <p:nvSpPr>
+          <p:cNvPr id="29" name="TextBox 28"/>
+          <p:cNvSpPr txBox="1"/>
+          <p:nvPr/>
+        </p:nvSpPr>
+        <p:spPr>
+          <a:xfrm>
+            <a:off x="8961120" y="3154680"/>
+            <a:ext cx="1417320" cy="219456"/>
+          </a:xfrm>
+          <a:prstGeom prst="rect">
+            <a:avLst/>
+          </a:prstGeom>
+          <a:noFill/>
+        </p:spPr>
+        <p:txBody>
+          <a:bodyPr wrap="square" lIns="0" rIns="0" tIns="0" bIns="0" anchor="t">
+            <a:spAutoFit/>
+          </a:bodyPr>
+          <a:lstStyle/>
+          <a:p>
+            <a:pPr algn="l"/>
+            <a:r>
+              <a:rPr sz="1500" b="1">
+                <a:solidFill>
+                  <a:srgbClr val="FFFFFF"/>
+                </a:solidFill>
+                <a:latin typeface="Calibri"/>
+              </a:rPr>
+              <a:t>质量与可运行性</a:t>
+            </a:r>
+          </a:p>
+        </p:txBody>
+      </p:sp>
     </p:spTree>
   </p:cSld>
   <p:clrMapOvr>
@@ -4508,6 +4890,595 @@
           </a:p>
         </p:txBody>
       </p:sp>
+      <p:sp>
+        <p:nvSpPr>
+          <p:cNvPr id="20" name="Rectangle 19"/>
+          <p:cNvSpPr/>
+          <p:nvPr/>
+        </p:nvSpPr>
+        <p:spPr>
+          <a:xfrm>
+            <a:off x="777240" y="1691640"/>
+            <a:ext cx="10332720" cy="4526280"/>
+          </a:xfrm>
+          <a:prstGeom prst="rect">
+            <a:avLst/>
+          </a:prstGeom>
+          <a:solidFill>
+            <a:srgbClr val="21295C"/>
+          </a:solidFill>
+          <a:ln>
+            <a:noFill/>
+          </a:ln>
+        </p:spPr>
+        <p:style>
+          <a:lnRef idx="1">
+            <a:schemeClr val="accent1"/>
+          </a:lnRef>
+          <a:fillRef idx="3">
+            <a:schemeClr val="accent1"/>
+          </a:fillRef>
+          <a:effectRef idx="2">
+            <a:schemeClr val="accent1"/>
+          </a:effectRef>
+          <a:fontRef idx="minor">
+            <a:schemeClr val="lt1"/>
+          </a:fontRef>
+        </p:style>
+        <p:txBody>
+          <a:bodyPr rtlCol="0" anchor="ctr"/>
+          <a:lstStyle/>
+          <a:p>
+            <a:pPr algn="ctr"/>
+          </a:p>
+        </p:txBody>
+      </p:sp>
+      <p:sp>
+        <p:nvSpPr>
+          <p:cNvPr id="21" name="Rounded Rectangle 20"/>
+          <p:cNvSpPr/>
+          <p:nvPr/>
+        </p:nvSpPr>
+        <p:spPr>
+          <a:xfrm>
+            <a:off x="914400" y="1874519"/>
+            <a:ext cx="9966960" cy="676656"/>
+          </a:xfrm>
+          <a:prstGeom prst="roundRect">
+            <a:avLst/>
+          </a:prstGeom>
+          <a:solidFill>
+            <a:srgbClr val="FFFFFF"/>
+          </a:solidFill>
+          <a:ln>
+            <a:noFill/>
+          </a:ln>
+        </p:spPr>
+        <p:style>
+          <a:lnRef idx="1">
+            <a:schemeClr val="accent1"/>
+          </a:lnRef>
+          <a:fillRef idx="3">
+            <a:schemeClr val="accent1"/>
+          </a:fillRef>
+          <a:effectRef idx="2">
+            <a:schemeClr val="accent1"/>
+          </a:effectRef>
+          <a:fontRef idx="minor">
+            <a:schemeClr val="lt1"/>
+          </a:fontRef>
+        </p:style>
+        <p:txBody>
+          <a:bodyPr rtlCol="0" anchor="ctr"/>
+          <a:lstStyle/>
+          <a:p>
+            <a:pPr algn="ctr"/>
+          </a:p>
+        </p:txBody>
+      </p:sp>
+      <p:sp>
+        <p:nvSpPr>
+          <p:cNvPr id="22" name="Rounded Rectangle 21"/>
+          <p:cNvSpPr/>
+          <p:nvPr/>
+        </p:nvSpPr>
+        <p:spPr>
+          <a:xfrm>
+            <a:off x="1078992" y="2039112"/>
+            <a:ext cx="640080" cy="292608"/>
+          </a:xfrm>
+          <a:prstGeom prst="roundRect">
+            <a:avLst/>
+          </a:prstGeom>
+          <a:solidFill>
+            <a:srgbClr val="02C39A"/>
+          </a:solidFill>
+          <a:ln>
+            <a:noFill/>
+          </a:ln>
+        </p:spPr>
+        <p:style>
+          <a:lnRef idx="1">
+            <a:schemeClr val="accent1"/>
+          </a:lnRef>
+          <a:fillRef idx="3">
+            <a:schemeClr val="accent1"/>
+          </a:fillRef>
+          <a:effectRef idx="2">
+            <a:schemeClr val="accent1"/>
+          </a:effectRef>
+          <a:fontRef idx="minor">
+            <a:schemeClr val="lt1"/>
+          </a:fontRef>
+        </p:style>
+        <p:txBody>
+          <a:bodyPr rtlCol="0" anchor="ctr"/>
+          <a:lstStyle/>
+          <a:p>
+            <a:pPr algn="ctr"/>
+          </a:p>
+        </p:txBody>
+      </p:sp>
+      <p:sp>
+        <p:nvSpPr>
+          <p:cNvPr id="23" name="TextBox 22"/>
+          <p:cNvSpPr txBox="1"/>
+          <p:nvPr/>
+        </p:nvSpPr>
+        <p:spPr>
+          <a:xfrm>
+            <a:off x="1197864" y="2112263"/>
+            <a:ext cx="402336" cy="109728"/>
+          </a:xfrm>
+          <a:prstGeom prst="rect">
+            <a:avLst/>
+          </a:prstGeom>
+          <a:noFill/>
+        </p:spPr>
+        <p:txBody>
+          <a:bodyPr wrap="square" lIns="0" rIns="0" tIns="0" bIns="0" anchor="t">
+            <a:spAutoFit/>
+          </a:bodyPr>
+          <a:lstStyle/>
+          <a:p>
+            <a:pPr algn="ctr"/>
+            <a:r>
+              <a:rPr sz="1050" b="1">
+                <a:solidFill>
+                  <a:srgbClr val="FFFFFF"/>
+                </a:solidFill>
+                <a:latin typeface="Georgia"/>
+              </a:rPr>
+              <a:t>能力</a:t>
+            </a:r>
+          </a:p>
+        </p:txBody>
+      </p:sp>
+      <p:sp>
+        <p:nvSpPr>
+          <p:cNvPr id="24" name="TextBox 23"/>
+          <p:cNvSpPr txBox="1"/>
+          <p:nvPr/>
+        </p:nvSpPr>
+        <p:spPr>
+          <a:xfrm>
+            <a:off x="1938528" y="2075688"/>
+            <a:ext cx="8092440" cy="182880"/>
+          </a:xfrm>
+          <a:prstGeom prst="rect">
+            <a:avLst/>
+          </a:prstGeom>
+          <a:noFill/>
+        </p:spPr>
+        <p:txBody>
+          <a:bodyPr wrap="square" lIns="0" rIns="0" tIns="0" bIns="0" anchor="t">
+            <a:spAutoFit/>
+          </a:bodyPr>
+          <a:lstStyle/>
+          <a:p>
+            <a:pPr algn="l"/>
+            <a:r>
+              <a:rPr sz="1300" b="0">
+                <a:solidFill>
+                  <a:srgbClr val="17324D"/>
+                </a:solidFill>
+                <a:latin typeface="Calibri"/>
+              </a:rPr>
+              <a:t>AI 生成、编辑、部署、管理闭环已具备雏形，适合围绕用户主路径继续打磨体验。</a:t>
+            </a:r>
+          </a:p>
+        </p:txBody>
+      </p:sp>
+      <p:sp>
+        <p:nvSpPr>
+          <p:cNvPr id="25" name="Rounded Rectangle 24"/>
+          <p:cNvSpPr/>
+          <p:nvPr/>
+        </p:nvSpPr>
+        <p:spPr>
+          <a:xfrm>
+            <a:off x="914400" y="2825496"/>
+            <a:ext cx="9966960" cy="676656"/>
+          </a:xfrm>
+          <a:prstGeom prst="roundRect">
+            <a:avLst/>
+          </a:prstGeom>
+          <a:solidFill>
+            <a:srgbClr val="FFFFFF"/>
+          </a:solidFill>
+          <a:ln>
+            <a:noFill/>
+          </a:ln>
+        </p:spPr>
+        <p:style>
+          <a:lnRef idx="1">
+            <a:schemeClr val="accent1"/>
+          </a:lnRef>
+          <a:fillRef idx="3">
+            <a:schemeClr val="accent1"/>
+          </a:fillRef>
+          <a:effectRef idx="2">
+            <a:schemeClr val="accent1"/>
+          </a:effectRef>
+          <a:fontRef idx="minor">
+            <a:schemeClr val="lt1"/>
+          </a:fontRef>
+        </p:style>
+        <p:txBody>
+          <a:bodyPr rtlCol="0" anchor="ctr"/>
+          <a:lstStyle/>
+          <a:p>
+            <a:pPr algn="ctr"/>
+          </a:p>
+        </p:txBody>
+      </p:sp>
+      <p:sp>
+        <p:nvSpPr>
+          <p:cNvPr id="26" name="Rounded Rectangle 25"/>
+          <p:cNvSpPr/>
+          <p:nvPr/>
+        </p:nvSpPr>
+        <p:spPr>
+          <a:xfrm>
+            <a:off x="1078992" y="2990088"/>
+            <a:ext cx="640080" cy="292608"/>
+          </a:xfrm>
+          <a:prstGeom prst="roundRect">
+            <a:avLst/>
+          </a:prstGeom>
+          <a:solidFill>
+            <a:srgbClr val="1C7293"/>
+          </a:solidFill>
+          <a:ln>
+            <a:noFill/>
+          </a:ln>
+        </p:spPr>
+        <p:style>
+          <a:lnRef idx="1">
+            <a:schemeClr val="accent1"/>
+          </a:lnRef>
+          <a:fillRef idx="3">
+            <a:schemeClr val="accent1"/>
+          </a:fillRef>
+          <a:effectRef idx="2">
+            <a:schemeClr val="accent1"/>
+          </a:effectRef>
+          <a:fontRef idx="minor">
+            <a:schemeClr val="lt1"/>
+          </a:fontRef>
+        </p:style>
+        <p:txBody>
+          <a:bodyPr rtlCol="0" anchor="ctr"/>
+          <a:lstStyle/>
+          <a:p>
+            <a:pPr algn="ctr"/>
+          </a:p>
+        </p:txBody>
+      </p:sp>
+      <p:sp>
+        <p:nvSpPr>
+          <p:cNvPr id="27" name="TextBox 26"/>
+          <p:cNvSpPr txBox="1"/>
+          <p:nvPr/>
+        </p:nvSpPr>
+        <p:spPr>
+          <a:xfrm>
+            <a:off x="1197864" y="3063239"/>
+            <a:ext cx="402336" cy="109728"/>
+          </a:xfrm>
+          <a:prstGeom prst="rect">
+            <a:avLst/>
+          </a:prstGeom>
+          <a:noFill/>
+        </p:spPr>
+        <p:txBody>
+          <a:bodyPr wrap="square" lIns="0" rIns="0" tIns="0" bIns="0" anchor="t">
+            <a:spAutoFit/>
+          </a:bodyPr>
+          <a:lstStyle/>
+          <a:p>
+            <a:pPr algn="ctr"/>
+            <a:r>
+              <a:rPr sz="1050" b="1">
+                <a:solidFill>
+                  <a:srgbClr val="FFFFFF"/>
+                </a:solidFill>
+                <a:latin typeface="Georgia"/>
+              </a:rPr>
+              <a:t>架构</a:t>
+            </a:r>
+          </a:p>
+        </p:txBody>
+      </p:sp>
+      <p:sp>
+        <p:nvSpPr>
+          <p:cNvPr id="28" name="TextBox 27"/>
+          <p:cNvSpPr txBox="1"/>
+          <p:nvPr/>
+        </p:nvSpPr>
+        <p:spPr>
+          <a:xfrm>
+            <a:off x="1938528" y="3026664"/>
+            <a:ext cx="8092440" cy="182880"/>
+          </a:xfrm>
+          <a:prstGeom prst="rect">
+            <a:avLst/>
+          </a:prstGeom>
+          <a:noFill/>
+        </p:spPr>
+        <p:txBody>
+          <a:bodyPr wrap="square" lIns="0" rIns="0" tIns="0" bIns="0" anchor="t">
+            <a:spAutoFit/>
+          </a:bodyPr>
+          <a:lstStyle/>
+          <a:p>
+            <a:pPr algn="l"/>
+            <a:r>
+              <a:rPr sz="1300" b="0">
+                <a:solidFill>
+                  <a:srgbClr val="17324D"/>
+                </a:solidFill>
+                <a:latin typeface="Calibri"/>
+              </a:rPr>
+              <a:t>微服务拆分已经形成，需用文档、CI 与集成测试降低多依赖协作成本。</a:t>
+            </a:r>
+          </a:p>
+        </p:txBody>
+      </p:sp>
+      <p:sp>
+        <p:nvSpPr>
+          <p:cNvPr id="29" name="Rounded Rectangle 28"/>
+          <p:cNvSpPr/>
+          <p:nvPr/>
+        </p:nvSpPr>
+        <p:spPr>
+          <a:xfrm>
+            <a:off x="914400" y="3776472"/>
+            <a:ext cx="9966960" cy="676656"/>
+          </a:xfrm>
+          <a:prstGeom prst="roundRect">
+            <a:avLst/>
+          </a:prstGeom>
+          <a:solidFill>
+            <a:srgbClr val="FFFFFF"/>
+          </a:solidFill>
+          <a:ln>
+            <a:noFill/>
+          </a:ln>
+        </p:spPr>
+        <p:style>
+          <a:lnRef idx="1">
+            <a:schemeClr val="accent1"/>
+          </a:lnRef>
+          <a:fillRef idx="3">
+            <a:schemeClr val="accent1"/>
+          </a:fillRef>
+          <a:effectRef idx="2">
+            <a:schemeClr val="accent1"/>
+          </a:effectRef>
+          <a:fontRef idx="minor">
+            <a:schemeClr val="lt1"/>
+          </a:fontRef>
+        </p:style>
+        <p:txBody>
+          <a:bodyPr rtlCol="0" anchor="ctr"/>
+          <a:lstStyle/>
+          <a:p>
+            <a:pPr algn="ctr"/>
+          </a:p>
+        </p:txBody>
+      </p:sp>
+      <p:sp>
+        <p:nvSpPr>
+          <p:cNvPr id="30" name="Rounded Rectangle 29"/>
+          <p:cNvSpPr/>
+          <p:nvPr/>
+        </p:nvSpPr>
+        <p:spPr>
+          <a:xfrm>
+            <a:off x="1078992" y="3941063"/>
+            <a:ext cx="640080" cy="292608"/>
+          </a:xfrm>
+          <a:prstGeom prst="roundRect">
+            <a:avLst/>
+          </a:prstGeom>
+          <a:solidFill>
+            <a:srgbClr val="F6A94A"/>
+          </a:solidFill>
+          <a:ln>
+            <a:noFill/>
+          </a:ln>
+        </p:spPr>
+        <p:style>
+          <a:lnRef idx="1">
+            <a:schemeClr val="accent1"/>
+          </a:lnRef>
+          <a:fillRef idx="3">
+            <a:schemeClr val="accent1"/>
+          </a:fillRef>
+          <a:effectRef idx="2">
+            <a:schemeClr val="accent1"/>
+          </a:effectRef>
+          <a:fontRef idx="minor">
+            <a:schemeClr val="lt1"/>
+          </a:fontRef>
+        </p:style>
+        <p:txBody>
+          <a:bodyPr rtlCol="0" anchor="ctr"/>
+          <a:lstStyle/>
+          <a:p>
+            <a:pPr algn="ctr"/>
+          </a:p>
+        </p:txBody>
+      </p:sp>
+      <p:sp>
+        <p:nvSpPr>
+          <p:cNvPr id="31" name="TextBox 30"/>
+          <p:cNvSpPr txBox="1"/>
+          <p:nvPr/>
+        </p:nvSpPr>
+        <p:spPr>
+          <a:xfrm>
+            <a:off x="1197864" y="4014215"/>
+            <a:ext cx="402336" cy="109728"/>
+          </a:xfrm>
+          <a:prstGeom prst="rect">
+            <a:avLst/>
+          </a:prstGeom>
+          <a:noFill/>
+        </p:spPr>
+        <p:txBody>
+          <a:bodyPr wrap="square" lIns="0" rIns="0" tIns="0" bIns="0" anchor="t">
+            <a:spAutoFit/>
+          </a:bodyPr>
+          <a:lstStyle/>
+          <a:p>
+            <a:pPr algn="ctr"/>
+            <a:r>
+              <a:rPr sz="1050" b="1">
+                <a:solidFill>
+                  <a:srgbClr val="FFFFFF"/>
+                </a:solidFill>
+                <a:latin typeface="Georgia"/>
+              </a:rPr>
+              <a:t>重点</a:t>
+            </a:r>
+          </a:p>
+        </p:txBody>
+      </p:sp>
+      <p:sp>
+        <p:nvSpPr>
+          <p:cNvPr id="32" name="TextBox 31"/>
+          <p:cNvSpPr txBox="1"/>
+          <p:nvPr/>
+        </p:nvSpPr>
+        <p:spPr>
+          <a:xfrm>
+            <a:off x="1938528" y="3977639"/>
+            <a:ext cx="8092440" cy="182880"/>
+          </a:xfrm>
+          <a:prstGeom prst="rect">
+            <a:avLst/>
+          </a:prstGeom>
+          <a:noFill/>
+        </p:spPr>
+        <p:txBody>
+          <a:bodyPr wrap="square" lIns="0" rIns="0" tIns="0" bIns="0" anchor="t">
+            <a:spAutoFit/>
+          </a:bodyPr>
+          <a:lstStyle/>
+          <a:p>
+            <a:pPr algn="l"/>
+            <a:r>
+              <a:rPr sz="1300" b="0">
+                <a:solidFill>
+                  <a:srgbClr val="17324D"/>
+                </a:solidFill>
+                <a:latin typeface="Calibri"/>
+              </a:rPr>
+              <a:t>优先补齐配置治理、自动化验证、监控告警与运行指标采集。</a:t>
+            </a:r>
+          </a:p>
+        </p:txBody>
+      </p:sp>
+      <p:sp>
+        <p:nvSpPr>
+          <p:cNvPr id="33" name="Rounded Rectangle 32"/>
+          <p:cNvSpPr/>
+          <p:nvPr/>
+        </p:nvSpPr>
+        <p:spPr>
+          <a:xfrm>
+            <a:off x="914400" y="5623560"/>
+            <a:ext cx="6675120" cy="402336"/>
+          </a:xfrm>
+          <a:prstGeom prst="roundRect">
+            <a:avLst/>
+          </a:prstGeom>
+          <a:solidFill>
+            <a:srgbClr val="065A82"/>
+          </a:solidFill>
+          <a:ln>
+            <a:noFill/>
+          </a:ln>
+        </p:spPr>
+        <p:style>
+          <a:lnRef idx="1">
+            <a:schemeClr val="accent1"/>
+          </a:lnRef>
+          <a:fillRef idx="3">
+            <a:schemeClr val="accent1"/>
+          </a:fillRef>
+          <a:effectRef idx="2">
+            <a:schemeClr val="accent1"/>
+          </a:effectRef>
+          <a:fontRef idx="minor">
+            <a:schemeClr val="lt1"/>
+          </a:fontRef>
+        </p:style>
+        <p:txBody>
+          <a:bodyPr rtlCol="0" anchor="ctr"/>
+          <a:lstStyle/>
+          <a:p>
+            <a:pPr algn="ctr"/>
+          </a:p>
+        </p:txBody>
+      </p:sp>
+      <p:sp>
+        <p:nvSpPr>
+          <p:cNvPr id="34" name="TextBox 33"/>
+          <p:cNvSpPr txBox="1"/>
+          <p:nvPr/>
+        </p:nvSpPr>
+        <p:spPr>
+          <a:xfrm>
+            <a:off x="1078992" y="5751576"/>
+            <a:ext cx="6217920" cy="109728"/>
+          </a:xfrm>
+          <a:prstGeom prst="rect">
+            <a:avLst/>
+          </a:prstGeom>
+          <a:noFill/>
+        </p:spPr>
+        <p:txBody>
+          <a:bodyPr wrap="square" lIns="0" rIns="0" tIns="0" bIns="0" anchor="t">
+            <a:spAutoFit/>
+          </a:bodyPr>
+          <a:lstStyle/>
+          <a:p>
+            <a:pPr algn="l"/>
+            <a:r>
+              <a:rPr sz="1150" b="0">
+                <a:solidFill>
+                  <a:srgbClr val="FFFFFF"/>
+                </a:solidFill>
+                <a:latin typeface="Calibri"/>
+              </a:rPr>
+              <a:t>报告文件：docs/reports/project-status-2026-06-03.pptx</a:t>
+            </a:r>
+          </a:p>
+        </p:txBody>
+      </p:sp>
     </p:spTree>
   </p:cSld>
   <p:clrMapOvr>
@@ -5895,6 +6866,955 @@
           </a:p>
         </p:txBody>
       </p:sp>
+      <p:sp>
+        <p:nvSpPr>
+          <p:cNvPr id="35" name="Rectangle 34"/>
+          <p:cNvSpPr/>
+          <p:nvPr/>
+        </p:nvSpPr>
+        <p:spPr>
+          <a:xfrm>
+            <a:off x="6199632" y="1719072"/>
+            <a:ext cx="2697480" cy="1508760"/>
+          </a:xfrm>
+          <a:prstGeom prst="rect">
+            <a:avLst/>
+          </a:prstGeom>
+          <a:solidFill>
+            <a:srgbClr val="F6FBFC"/>
+          </a:solidFill>
+          <a:ln>
+            <a:noFill/>
+          </a:ln>
+        </p:spPr>
+        <p:style>
+          <a:lnRef idx="1">
+            <a:schemeClr val="accent1"/>
+          </a:lnRef>
+          <a:fillRef idx="3">
+            <a:schemeClr val="accent1"/>
+          </a:fillRef>
+          <a:effectRef idx="2">
+            <a:schemeClr val="accent1"/>
+          </a:effectRef>
+          <a:fontRef idx="minor">
+            <a:schemeClr val="lt1"/>
+          </a:fontRef>
+        </p:style>
+        <p:txBody>
+          <a:bodyPr rtlCol="0" anchor="ctr"/>
+          <a:lstStyle/>
+          <a:p>
+            <a:pPr algn="ctr"/>
+          </a:p>
+        </p:txBody>
+      </p:sp>
+      <p:sp>
+        <p:nvSpPr>
+          <p:cNvPr id="36" name="Rounded Rectangle 35"/>
+          <p:cNvSpPr/>
+          <p:nvPr/>
+        </p:nvSpPr>
+        <p:spPr>
+          <a:xfrm>
+            <a:off x="6291072" y="1810512"/>
+            <a:ext cx="2487168" cy="1325880"/>
+          </a:xfrm>
+          <a:prstGeom prst="roundRect">
+            <a:avLst/>
+          </a:prstGeom>
+          <a:solidFill>
+            <a:srgbClr val="FFFFFF"/>
+          </a:solidFill>
+          <a:ln w="12700">
+            <a:solidFill>
+              <a:srgbClr val="DCEBED"/>
+            </a:solidFill>
+          </a:ln>
+        </p:spPr>
+        <p:style>
+          <a:lnRef idx="1">
+            <a:schemeClr val="accent1"/>
+          </a:lnRef>
+          <a:fillRef idx="3">
+            <a:schemeClr val="accent1"/>
+          </a:fillRef>
+          <a:effectRef idx="2">
+            <a:schemeClr val="accent1"/>
+          </a:effectRef>
+          <a:fontRef idx="minor">
+            <a:schemeClr val="lt1"/>
+          </a:fontRef>
+        </p:style>
+        <p:txBody>
+          <a:bodyPr rtlCol="0" anchor="ctr"/>
+          <a:lstStyle/>
+          <a:p>
+            <a:pPr algn="ctr"/>
+          </a:p>
+        </p:txBody>
+      </p:sp>
+      <p:sp>
+        <p:nvSpPr>
+          <p:cNvPr id="37" name="Rounded Rectangle 36"/>
+          <p:cNvSpPr/>
+          <p:nvPr/>
+        </p:nvSpPr>
+        <p:spPr>
+          <a:xfrm>
+            <a:off x="6291072" y="1810512"/>
+            <a:ext cx="109728" cy="1325880"/>
+          </a:xfrm>
+          <a:prstGeom prst="roundRect">
+            <a:avLst/>
+          </a:prstGeom>
+          <a:solidFill>
+            <a:srgbClr val="00A896"/>
+          </a:solidFill>
+          <a:ln>
+            <a:noFill/>
+          </a:ln>
+        </p:spPr>
+        <p:style>
+          <a:lnRef idx="1">
+            <a:schemeClr val="accent1"/>
+          </a:lnRef>
+          <a:fillRef idx="3">
+            <a:schemeClr val="accent1"/>
+          </a:fillRef>
+          <a:effectRef idx="2">
+            <a:schemeClr val="accent1"/>
+          </a:effectRef>
+          <a:fontRef idx="minor">
+            <a:schemeClr val="lt1"/>
+          </a:fontRef>
+        </p:style>
+        <p:txBody>
+          <a:bodyPr rtlCol="0" anchor="ctr"/>
+          <a:lstStyle/>
+          <a:p>
+            <a:pPr algn="ctr"/>
+          </a:p>
+        </p:txBody>
+      </p:sp>
+      <p:sp>
+        <p:nvSpPr>
+          <p:cNvPr id="38" name="TextBox 37"/>
+          <p:cNvSpPr txBox="1"/>
+          <p:nvPr/>
+        </p:nvSpPr>
+        <p:spPr>
+          <a:xfrm>
+            <a:off x="6565392" y="1993392"/>
+            <a:ext cx="1463040" cy="310896"/>
+          </a:xfrm>
+          <a:prstGeom prst="rect">
+            <a:avLst/>
+          </a:prstGeom>
+          <a:noFill/>
+        </p:spPr>
+        <p:txBody>
+          <a:bodyPr wrap="square" lIns="0" rIns="0" tIns="0" bIns="0" anchor="t">
+            <a:spAutoFit/>
+          </a:bodyPr>
+          <a:lstStyle/>
+          <a:p>
+            <a:pPr algn="l"/>
+            <a:r>
+              <a:rPr sz="2800" b="1">
+                <a:solidFill>
+                  <a:srgbClr val="00A896"/>
+                </a:solidFill>
+                <a:latin typeface="Georgia"/>
+              </a:rPr>
+              <a:t>7</a:t>
+            </a:r>
+          </a:p>
+        </p:txBody>
+      </p:sp>
+      <p:sp>
+        <p:nvSpPr>
+          <p:cNvPr id="39" name="TextBox 38"/>
+          <p:cNvSpPr txBox="1"/>
+          <p:nvPr/>
+        </p:nvSpPr>
+        <p:spPr>
+          <a:xfrm>
+            <a:off x="6565392" y="2487168"/>
+            <a:ext cx="1280160" cy="164592"/>
+          </a:xfrm>
+          <a:prstGeom prst="rect">
+            <a:avLst/>
+          </a:prstGeom>
+          <a:noFill/>
+        </p:spPr>
+        <p:txBody>
+          <a:bodyPr wrap="square" lIns="0" rIns="0" tIns="0" bIns="0" anchor="t">
+            <a:spAutoFit/>
+          </a:bodyPr>
+          <a:lstStyle/>
+          <a:p>
+            <a:pPr algn="l"/>
+            <a:r>
+              <a:rPr sz="1250" b="1">
+                <a:solidFill>
+                  <a:srgbClr val="5B6B7A"/>
+                </a:solidFill>
+                <a:latin typeface="Calibri"/>
+              </a:rPr>
+              <a:t>微服务模块</a:t>
+            </a:r>
+          </a:p>
+        </p:txBody>
+      </p:sp>
+      <p:sp>
+        <p:nvSpPr>
+          <p:cNvPr id="40" name="TextBox 39"/>
+          <p:cNvSpPr txBox="1"/>
+          <p:nvPr/>
+        </p:nvSpPr>
+        <p:spPr>
+          <a:xfrm>
+            <a:off x="6565392" y="2807208"/>
+            <a:ext cx="1874519" cy="329184"/>
+          </a:xfrm>
+          <a:prstGeom prst="rect">
+            <a:avLst/>
+          </a:prstGeom>
+          <a:noFill/>
+        </p:spPr>
+        <p:txBody>
+          <a:bodyPr wrap="square" lIns="0" rIns="0" tIns="0" bIns="0" anchor="t">
+            <a:spAutoFit/>
+          </a:bodyPr>
+          <a:lstStyle/>
+          <a:p>
+            <a:pPr algn="l"/>
+            <a:r>
+              <a:rPr sz="919" b="0">
+                <a:solidFill>
+                  <a:srgbClr val="17324D"/>
+                </a:solidFill>
+                <a:latin typeface="Calibri"/>
+              </a:rPr>
+              <a:t>common / model / client / user
+app / ai / screenshot</a:t>
+            </a:r>
+          </a:p>
+        </p:txBody>
+      </p:sp>
+      <p:sp>
+        <p:nvSpPr>
+          <p:cNvPr id="41" name="Rectangle 40"/>
+          <p:cNvSpPr/>
+          <p:nvPr/>
+        </p:nvSpPr>
+        <p:spPr>
+          <a:xfrm>
+            <a:off x="713232" y="3493008"/>
+            <a:ext cx="5349240" cy="2176272"/>
+          </a:xfrm>
+          <a:prstGeom prst="rect">
+            <a:avLst/>
+          </a:prstGeom>
+          <a:solidFill>
+            <a:srgbClr val="E7F3F8"/>
+          </a:solidFill>
+          <a:ln>
+            <a:noFill/>
+          </a:ln>
+        </p:spPr>
+        <p:style>
+          <a:lnRef idx="1">
+            <a:schemeClr val="accent1"/>
+          </a:lnRef>
+          <a:fillRef idx="3">
+            <a:schemeClr val="accent1"/>
+          </a:fillRef>
+          <a:effectRef idx="2">
+            <a:schemeClr val="accent1"/>
+          </a:effectRef>
+          <a:fontRef idx="minor">
+            <a:schemeClr val="lt1"/>
+          </a:fontRef>
+        </p:style>
+        <p:txBody>
+          <a:bodyPr rtlCol="0" anchor="ctr"/>
+          <a:lstStyle/>
+          <a:p>
+            <a:pPr algn="ctr"/>
+          </a:p>
+        </p:txBody>
+      </p:sp>
+      <p:sp>
+        <p:nvSpPr>
+          <p:cNvPr id="42" name="Rounded Rectangle 41"/>
+          <p:cNvSpPr/>
+          <p:nvPr/>
+        </p:nvSpPr>
+        <p:spPr>
+          <a:xfrm>
+            <a:off x="713232" y="3493008"/>
+            <a:ext cx="5349240" cy="2176272"/>
+          </a:xfrm>
+          <a:prstGeom prst="roundRect">
+            <a:avLst/>
+          </a:prstGeom>
+          <a:solidFill>
+            <a:srgbClr val="E7F3F8"/>
+          </a:solidFill>
+          <a:ln>
+            <a:noFill/>
+          </a:ln>
+        </p:spPr>
+        <p:style>
+          <a:lnRef idx="1">
+            <a:schemeClr val="accent1"/>
+          </a:lnRef>
+          <a:fillRef idx="3">
+            <a:schemeClr val="accent1"/>
+          </a:fillRef>
+          <a:effectRef idx="2">
+            <a:schemeClr val="accent1"/>
+          </a:effectRef>
+          <a:fontRef idx="minor">
+            <a:schemeClr val="lt1"/>
+          </a:fontRef>
+        </p:style>
+        <p:txBody>
+          <a:bodyPr rtlCol="0" anchor="ctr"/>
+          <a:lstStyle/>
+          <a:p>
+            <a:pPr algn="ctr"/>
+          </a:p>
+        </p:txBody>
+      </p:sp>
+      <p:sp>
+        <p:nvSpPr>
+          <p:cNvPr id="43" name="TextBox 42"/>
+          <p:cNvSpPr txBox="1"/>
+          <p:nvPr/>
+        </p:nvSpPr>
+        <p:spPr>
+          <a:xfrm>
+            <a:off x="1024128" y="3730752"/>
+            <a:ext cx="2194560" cy="237744"/>
+          </a:xfrm>
+          <a:prstGeom prst="rect">
+            <a:avLst/>
+          </a:prstGeom>
+          <a:noFill/>
+        </p:spPr>
+        <p:txBody>
+          <a:bodyPr wrap="square" lIns="0" rIns="0" tIns="0" bIns="0" anchor="t">
+            <a:spAutoFit/>
+          </a:bodyPr>
+          <a:lstStyle/>
+          <a:p>
+            <a:pPr algn="l"/>
+            <a:r>
+              <a:rPr sz="1800" b="1">
+                <a:solidFill>
+                  <a:srgbClr val="065A82"/>
+                </a:solidFill>
+                <a:latin typeface="Georgia"/>
+              </a:rPr>
+              <a:t>定位</a:t>
+            </a:r>
+          </a:p>
+        </p:txBody>
+      </p:sp>
+      <p:sp>
+        <p:nvSpPr>
+          <p:cNvPr id="44" name="Oval 43"/>
+          <p:cNvSpPr/>
+          <p:nvPr/>
+        </p:nvSpPr>
+        <p:spPr>
+          <a:xfrm>
+            <a:off x="1042416" y="4178807"/>
+            <a:ext cx="109728" cy="109728"/>
+          </a:xfrm>
+          <a:prstGeom prst="ellipse">
+            <a:avLst/>
+          </a:prstGeom>
+          <a:solidFill>
+            <a:srgbClr val="028090"/>
+          </a:solidFill>
+          <a:ln>
+            <a:noFill/>
+          </a:ln>
+        </p:spPr>
+        <p:style>
+          <a:lnRef idx="1">
+            <a:schemeClr val="accent1"/>
+          </a:lnRef>
+          <a:fillRef idx="3">
+            <a:schemeClr val="accent1"/>
+          </a:fillRef>
+          <a:effectRef idx="2">
+            <a:schemeClr val="accent1"/>
+          </a:effectRef>
+          <a:fontRef idx="minor">
+            <a:schemeClr val="lt1"/>
+          </a:fontRef>
+        </p:style>
+        <p:txBody>
+          <a:bodyPr rtlCol="0" anchor="ctr"/>
+          <a:lstStyle/>
+          <a:p>
+            <a:pPr algn="ctr"/>
+          </a:p>
+        </p:txBody>
+      </p:sp>
+      <p:sp>
+        <p:nvSpPr>
+          <p:cNvPr id="45" name="TextBox 44"/>
+          <p:cNvSpPr txBox="1"/>
+          <p:nvPr/>
+        </p:nvSpPr>
+        <p:spPr>
+          <a:xfrm>
+            <a:off x="1243584" y="4142232"/>
+            <a:ext cx="4389120" cy="164592"/>
+          </a:xfrm>
+          <a:prstGeom prst="rect">
+            <a:avLst/>
+          </a:prstGeom>
+          <a:noFill/>
+        </p:spPr>
+        <p:txBody>
+          <a:bodyPr wrap="square" lIns="0" rIns="0" tIns="0" bIns="0" anchor="t">
+            <a:spAutoFit/>
+          </a:bodyPr>
+          <a:lstStyle/>
+          <a:p>
+            <a:pPr algn="l"/>
+            <a:r>
+              <a:rPr sz="1340" b="0">
+                <a:solidFill>
+                  <a:srgbClr val="17324D"/>
+                </a:solidFill>
+                <a:latin typeface="Calibri"/>
+              </a:rPr>
+              <a:t>面向用户提示词的 AI 应用/网站生成平台。</a:t>
+            </a:r>
+          </a:p>
+        </p:txBody>
+      </p:sp>
+      <p:sp>
+        <p:nvSpPr>
+          <p:cNvPr id="46" name="Oval 45"/>
+          <p:cNvSpPr/>
+          <p:nvPr/>
+        </p:nvSpPr>
+        <p:spPr>
+          <a:xfrm>
+            <a:off x="1042416" y="4526279"/>
+            <a:ext cx="109728" cy="109728"/>
+          </a:xfrm>
+          <a:prstGeom prst="ellipse">
+            <a:avLst/>
+          </a:prstGeom>
+          <a:solidFill>
+            <a:srgbClr val="028090"/>
+          </a:solidFill>
+          <a:ln>
+            <a:noFill/>
+          </a:ln>
+        </p:spPr>
+        <p:style>
+          <a:lnRef idx="1">
+            <a:schemeClr val="accent1"/>
+          </a:lnRef>
+          <a:fillRef idx="3">
+            <a:schemeClr val="accent1"/>
+          </a:fillRef>
+          <a:effectRef idx="2">
+            <a:schemeClr val="accent1"/>
+          </a:effectRef>
+          <a:fontRef idx="minor">
+            <a:schemeClr val="lt1"/>
+          </a:fontRef>
+        </p:style>
+        <p:txBody>
+          <a:bodyPr rtlCol="0" anchor="ctr"/>
+          <a:lstStyle/>
+          <a:p>
+            <a:pPr algn="ctr"/>
+          </a:p>
+        </p:txBody>
+      </p:sp>
+      <p:sp>
+        <p:nvSpPr>
+          <p:cNvPr id="47" name="TextBox 46"/>
+          <p:cNvSpPr txBox="1"/>
+          <p:nvPr/>
+        </p:nvSpPr>
+        <p:spPr>
+          <a:xfrm>
+            <a:off x="1243584" y="4489704"/>
+            <a:ext cx="4389120" cy="164592"/>
+          </a:xfrm>
+          <a:prstGeom prst="rect">
+            <a:avLst/>
+          </a:prstGeom>
+          <a:noFill/>
+        </p:spPr>
+        <p:txBody>
+          <a:bodyPr wrap="square" lIns="0" rIns="0" tIns="0" bIns="0" anchor="t">
+            <a:spAutoFit/>
+          </a:bodyPr>
+          <a:lstStyle/>
+          <a:p>
+            <a:pPr algn="l"/>
+            <a:r>
+              <a:rPr sz="1340" b="0">
+                <a:solidFill>
+                  <a:srgbClr val="17324D"/>
+                </a:solidFill>
+                <a:latin typeface="Calibri"/>
+              </a:rPr>
+              <a:t>支持生成、预览、部署分享、源码下载与管理后台。</a:t>
+            </a:r>
+          </a:p>
+        </p:txBody>
+      </p:sp>
+      <p:sp>
+        <p:nvSpPr>
+          <p:cNvPr id="48" name="Oval 47"/>
+          <p:cNvSpPr/>
+          <p:nvPr/>
+        </p:nvSpPr>
+        <p:spPr>
+          <a:xfrm>
+            <a:off x="1042416" y="4873751"/>
+            <a:ext cx="109728" cy="109728"/>
+          </a:xfrm>
+          <a:prstGeom prst="ellipse">
+            <a:avLst/>
+          </a:prstGeom>
+          <a:solidFill>
+            <a:srgbClr val="028090"/>
+          </a:solidFill>
+          <a:ln>
+            <a:noFill/>
+          </a:ln>
+        </p:spPr>
+        <p:style>
+          <a:lnRef idx="1">
+            <a:schemeClr val="accent1"/>
+          </a:lnRef>
+          <a:fillRef idx="3">
+            <a:schemeClr val="accent1"/>
+          </a:fillRef>
+          <a:effectRef idx="2">
+            <a:schemeClr val="accent1"/>
+          </a:effectRef>
+          <a:fontRef idx="minor">
+            <a:schemeClr val="lt1"/>
+          </a:fontRef>
+        </p:style>
+        <p:txBody>
+          <a:bodyPr rtlCol="0" anchor="ctr"/>
+          <a:lstStyle/>
+          <a:p>
+            <a:pPr algn="ctr"/>
+          </a:p>
+        </p:txBody>
+      </p:sp>
+      <p:sp>
+        <p:nvSpPr>
+          <p:cNvPr id="49" name="TextBox 48"/>
+          <p:cNvSpPr txBox="1"/>
+          <p:nvPr/>
+        </p:nvSpPr>
+        <p:spPr>
+          <a:xfrm>
+            <a:off x="1243584" y="4837176"/>
+            <a:ext cx="4389120" cy="164592"/>
+          </a:xfrm>
+          <a:prstGeom prst="rect">
+            <a:avLst/>
+          </a:prstGeom>
+          <a:noFill/>
+        </p:spPr>
+        <p:txBody>
+          <a:bodyPr wrap="square" lIns="0" rIns="0" tIns="0" bIns="0" anchor="t">
+            <a:spAutoFit/>
+          </a:bodyPr>
+          <a:lstStyle/>
+          <a:p>
+            <a:pPr algn="l"/>
+            <a:r>
+              <a:rPr sz="1340" b="0">
+                <a:solidFill>
+                  <a:srgbClr val="17324D"/>
+                </a:solidFill>
+                <a:latin typeface="Calibri"/>
+              </a:rPr>
+              <a:t>覆盖 AI 智能体、工作流、流式输出与企业级后端。</a:t>
+            </a:r>
+          </a:p>
+        </p:txBody>
+      </p:sp>
+      <p:sp>
+        <p:nvSpPr>
+          <p:cNvPr id="50" name="Rectangle 49"/>
+          <p:cNvSpPr/>
+          <p:nvPr/>
+        </p:nvSpPr>
+        <p:spPr>
+          <a:xfrm>
+            <a:off x="6309360" y="3493008"/>
+            <a:ext cx="5166360" cy="2176272"/>
+          </a:xfrm>
+          <a:prstGeom prst="rect">
+            <a:avLst/>
+          </a:prstGeom>
+          <a:solidFill>
+            <a:srgbClr val="FFFFFF"/>
+          </a:solidFill>
+          <a:ln>
+            <a:noFill/>
+          </a:ln>
+        </p:spPr>
+        <p:style>
+          <a:lnRef idx="1">
+            <a:schemeClr val="accent1"/>
+          </a:lnRef>
+          <a:fillRef idx="3">
+            <a:schemeClr val="accent1"/>
+          </a:fillRef>
+          <a:effectRef idx="2">
+            <a:schemeClr val="accent1"/>
+          </a:effectRef>
+          <a:fontRef idx="minor">
+            <a:schemeClr val="lt1"/>
+          </a:fontRef>
+        </p:style>
+        <p:txBody>
+          <a:bodyPr rtlCol="0" anchor="ctr"/>
+          <a:lstStyle/>
+          <a:p>
+            <a:pPr algn="ctr"/>
+          </a:p>
+        </p:txBody>
+      </p:sp>
+      <p:sp>
+        <p:nvSpPr>
+          <p:cNvPr id="51" name="Rounded Rectangle 50"/>
+          <p:cNvSpPr/>
+          <p:nvPr/>
+        </p:nvSpPr>
+        <p:spPr>
+          <a:xfrm>
+            <a:off x="6309360" y="3493008"/>
+            <a:ext cx="5166360" cy="2176272"/>
+          </a:xfrm>
+          <a:prstGeom prst="roundRect">
+            <a:avLst/>
+          </a:prstGeom>
+          <a:solidFill>
+            <a:srgbClr val="FFFFFF"/>
+          </a:solidFill>
+          <a:ln w="12700">
+            <a:solidFill>
+              <a:srgbClr val="CCE8EA"/>
+            </a:solidFill>
+          </a:ln>
+        </p:spPr>
+        <p:style>
+          <a:lnRef idx="1">
+            <a:schemeClr val="accent1"/>
+          </a:lnRef>
+          <a:fillRef idx="3">
+            <a:schemeClr val="accent1"/>
+          </a:fillRef>
+          <a:effectRef idx="2">
+            <a:schemeClr val="accent1"/>
+          </a:effectRef>
+          <a:fontRef idx="minor">
+            <a:schemeClr val="lt1"/>
+          </a:fontRef>
+        </p:style>
+        <p:txBody>
+          <a:bodyPr rtlCol="0" anchor="ctr"/>
+          <a:lstStyle/>
+          <a:p>
+            <a:pPr algn="ctr"/>
+          </a:p>
+        </p:txBody>
+      </p:sp>
+      <p:sp>
+        <p:nvSpPr>
+          <p:cNvPr id="52" name="TextBox 51"/>
+          <p:cNvSpPr txBox="1"/>
+          <p:nvPr/>
+        </p:nvSpPr>
+        <p:spPr>
+          <a:xfrm>
+            <a:off x="6620256" y="3730752"/>
+            <a:ext cx="2194560" cy="237744"/>
+          </a:xfrm>
+          <a:prstGeom prst="rect">
+            <a:avLst/>
+          </a:prstGeom>
+          <a:noFill/>
+        </p:spPr>
+        <p:txBody>
+          <a:bodyPr wrap="square" lIns="0" rIns="0" tIns="0" bIns="0" anchor="t">
+            <a:spAutoFit/>
+          </a:bodyPr>
+          <a:lstStyle/>
+          <a:p>
+            <a:pPr algn="l"/>
+            <a:r>
+              <a:rPr sz="1800" b="1">
+                <a:solidFill>
+                  <a:srgbClr val="065A82"/>
+                </a:solidFill>
+                <a:latin typeface="Georgia"/>
+              </a:rPr>
+              <a:t>当前工程形态</a:t>
+            </a:r>
+          </a:p>
+        </p:txBody>
+      </p:sp>
+      <p:sp>
+        <p:nvSpPr>
+          <p:cNvPr id="53" name="Oval 52"/>
+          <p:cNvSpPr/>
+          <p:nvPr/>
+        </p:nvSpPr>
+        <p:spPr>
+          <a:xfrm>
+            <a:off x="6638544" y="4178807"/>
+            <a:ext cx="109728" cy="109728"/>
+          </a:xfrm>
+          <a:prstGeom prst="ellipse">
+            <a:avLst/>
+          </a:prstGeom>
+          <a:solidFill>
+            <a:srgbClr val="028090"/>
+          </a:solidFill>
+          <a:ln>
+            <a:noFill/>
+          </a:ln>
+        </p:spPr>
+        <p:style>
+          <a:lnRef idx="1">
+            <a:schemeClr val="accent1"/>
+          </a:lnRef>
+          <a:fillRef idx="3">
+            <a:schemeClr val="accent1"/>
+          </a:fillRef>
+          <a:effectRef idx="2">
+            <a:schemeClr val="accent1"/>
+          </a:effectRef>
+          <a:fontRef idx="minor">
+            <a:schemeClr val="lt1"/>
+          </a:fontRef>
+        </p:style>
+        <p:txBody>
+          <a:bodyPr rtlCol="0" anchor="ctr"/>
+          <a:lstStyle/>
+          <a:p>
+            <a:pPr algn="ctr"/>
+          </a:p>
+        </p:txBody>
+      </p:sp>
+      <p:sp>
+        <p:nvSpPr>
+          <p:cNvPr id="54" name="TextBox 53"/>
+          <p:cNvSpPr txBox="1"/>
+          <p:nvPr/>
+        </p:nvSpPr>
+        <p:spPr>
+          <a:xfrm>
+            <a:off x="6839712" y="4142232"/>
+            <a:ext cx="4389120" cy="164592"/>
+          </a:xfrm>
+          <a:prstGeom prst="rect">
+            <a:avLst/>
+          </a:prstGeom>
+          <a:noFill/>
+        </p:spPr>
+        <p:txBody>
+          <a:bodyPr wrap="square" lIns="0" rIns="0" tIns="0" bIns="0" anchor="t">
+            <a:spAutoFit/>
+          </a:bodyPr>
+          <a:lstStyle/>
+          <a:p>
+            <a:pPr algn="l"/>
+            <a:r>
+              <a:rPr sz="1340" b="0">
+                <a:solidFill>
+                  <a:srgbClr val="17324D"/>
+                </a:solidFill>
+                <a:latin typeface="Calibri"/>
+              </a:rPr>
+              <a:t>根目录保留单体 Spring Boot 项目。</a:t>
+            </a:r>
+          </a:p>
+        </p:txBody>
+      </p:sp>
+      <p:sp>
+        <p:nvSpPr>
+          <p:cNvPr id="55" name="Oval 54"/>
+          <p:cNvSpPr/>
+          <p:nvPr/>
+        </p:nvSpPr>
+        <p:spPr>
+          <a:xfrm>
+            <a:off x="6638544" y="4526279"/>
+            <a:ext cx="109728" cy="109728"/>
+          </a:xfrm>
+          <a:prstGeom prst="ellipse">
+            <a:avLst/>
+          </a:prstGeom>
+          <a:solidFill>
+            <a:srgbClr val="028090"/>
+          </a:solidFill>
+          <a:ln>
+            <a:noFill/>
+          </a:ln>
+        </p:spPr>
+        <p:style>
+          <a:lnRef idx="1">
+            <a:schemeClr val="accent1"/>
+          </a:lnRef>
+          <a:fillRef idx="3">
+            <a:schemeClr val="accent1"/>
+          </a:fillRef>
+          <a:effectRef idx="2">
+            <a:schemeClr val="accent1"/>
+          </a:effectRef>
+          <a:fontRef idx="minor">
+            <a:schemeClr val="lt1"/>
+          </a:fontRef>
+        </p:style>
+        <p:txBody>
+          <a:bodyPr rtlCol="0" anchor="ctr"/>
+          <a:lstStyle/>
+          <a:p>
+            <a:pPr algn="ctr"/>
+          </a:p>
+        </p:txBody>
+      </p:sp>
+      <p:sp>
+        <p:nvSpPr>
+          <p:cNvPr id="56" name="TextBox 55"/>
+          <p:cNvSpPr txBox="1"/>
+          <p:nvPr/>
+        </p:nvSpPr>
+        <p:spPr>
+          <a:xfrm>
+            <a:off x="6839712" y="4489704"/>
+            <a:ext cx="4389120" cy="164592"/>
+          </a:xfrm>
+          <a:prstGeom prst="rect">
+            <a:avLst/>
+          </a:prstGeom>
+          <a:noFill/>
+        </p:spPr>
+        <p:txBody>
+          <a:bodyPr wrap="square" lIns="0" rIns="0" tIns="0" bIns="0" anchor="t">
+            <a:spAutoFit/>
+          </a:bodyPr>
+          <a:lstStyle/>
+          <a:p>
+            <a:pPr algn="l"/>
+            <a:r>
+              <a:rPr sz="1340" b="0">
+                <a:solidFill>
+                  <a:srgbClr val="17324D"/>
+                </a:solidFill>
+                <a:latin typeface="Calibri"/>
+              </a:rPr>
+              <a:t>微服务目录已完成模块拆分。</a:t>
+            </a:r>
+          </a:p>
+        </p:txBody>
+      </p:sp>
+      <p:sp>
+        <p:nvSpPr>
+          <p:cNvPr id="57" name="Oval 56"/>
+          <p:cNvSpPr/>
+          <p:nvPr/>
+        </p:nvSpPr>
+        <p:spPr>
+          <a:xfrm>
+            <a:off x="6638544" y="4873751"/>
+            <a:ext cx="109728" cy="109728"/>
+          </a:xfrm>
+          <a:prstGeom prst="ellipse">
+            <a:avLst/>
+          </a:prstGeom>
+          <a:solidFill>
+            <a:srgbClr val="028090"/>
+          </a:solidFill>
+          <a:ln>
+            <a:noFill/>
+          </a:ln>
+        </p:spPr>
+        <p:style>
+          <a:lnRef idx="1">
+            <a:schemeClr val="accent1"/>
+          </a:lnRef>
+          <a:fillRef idx="3">
+            <a:schemeClr val="accent1"/>
+          </a:fillRef>
+          <a:effectRef idx="2">
+            <a:schemeClr val="accent1"/>
+          </a:effectRef>
+          <a:fontRef idx="minor">
+            <a:schemeClr val="lt1"/>
+          </a:fontRef>
+        </p:style>
+        <p:txBody>
+          <a:bodyPr rtlCol="0" anchor="ctr"/>
+          <a:lstStyle/>
+          <a:p>
+            <a:pPr algn="ctr"/>
+          </a:p>
+        </p:txBody>
+      </p:sp>
+      <p:sp>
+        <p:nvSpPr>
+          <p:cNvPr id="58" name="TextBox 57"/>
+          <p:cNvSpPr txBox="1"/>
+          <p:nvPr/>
+        </p:nvSpPr>
+        <p:spPr>
+          <a:xfrm>
+            <a:off x="6839712" y="4837176"/>
+            <a:ext cx="4389120" cy="164592"/>
+          </a:xfrm>
+          <a:prstGeom prst="rect">
+            <a:avLst/>
+          </a:prstGeom>
+          <a:noFill/>
+        </p:spPr>
+        <p:txBody>
+          <a:bodyPr wrap="square" lIns="0" rIns="0" tIns="0" bIns="0" anchor="t">
+            <a:spAutoFit/>
+          </a:bodyPr>
+          <a:lstStyle/>
+          <a:p>
+            <a:pPr algn="l"/>
+            <a:r>
+              <a:rPr sz="1340" b="0">
+                <a:solidFill>
+                  <a:srgbClr val="17324D"/>
+                </a:solidFill>
+                <a:latin typeface="Calibri"/>
+              </a:rPr>
+              <a:t>前端采用 Vue 3 + TypeScript + Ant Design Vue + Vite。</a:t>
+            </a:r>
+          </a:p>
+        </p:txBody>
+      </p:sp>
     </p:spTree>
   </p:cSld>
   <p:clrMapOvr>
@@ -8763,6 +10683,1638 @@
                 <a:latin typeface="Calibri"/>
               </a:rPr>
               <a:t>4</a:t>
+            </a:r>
+          </a:p>
+        </p:txBody>
+      </p:sp>
+      <p:sp>
+        <p:nvSpPr>
+          <p:cNvPr id="49" name="Rectangle 48"/>
+          <p:cNvSpPr/>
+          <p:nvPr/>
+        </p:nvSpPr>
+        <p:spPr>
+          <a:xfrm>
+            <a:off x="457200" y="1508760"/>
+            <a:ext cx="11201400" cy="4005072"/>
+          </a:xfrm>
+          <a:prstGeom prst="rect">
+            <a:avLst/>
+          </a:prstGeom>
+          <a:solidFill>
+            <a:srgbClr val="F6FBFC"/>
+          </a:solidFill>
+          <a:ln>
+            <a:noFill/>
+          </a:ln>
+        </p:spPr>
+        <p:style>
+          <a:lnRef idx="1">
+            <a:schemeClr val="accent1"/>
+          </a:lnRef>
+          <a:fillRef idx="3">
+            <a:schemeClr val="accent1"/>
+          </a:fillRef>
+          <a:effectRef idx="2">
+            <a:schemeClr val="accent1"/>
+          </a:effectRef>
+          <a:fontRef idx="minor">
+            <a:schemeClr val="lt1"/>
+          </a:fontRef>
+        </p:style>
+        <p:txBody>
+          <a:bodyPr rtlCol="0" anchor="ctr"/>
+          <a:lstStyle/>
+          <a:p>
+            <a:pPr algn="ctr"/>
+          </a:p>
+        </p:txBody>
+      </p:sp>
+      <p:sp>
+        <p:nvSpPr>
+          <p:cNvPr id="50" name="Rounded Rectangle 49"/>
+          <p:cNvSpPr/>
+          <p:nvPr/>
+        </p:nvSpPr>
+        <p:spPr>
+          <a:xfrm>
+            <a:off x="658368" y="1682496"/>
+            <a:ext cx="1874519" cy="1170432"/>
+          </a:xfrm>
+          <a:prstGeom prst="roundRect">
+            <a:avLst/>
+          </a:prstGeom>
+          <a:solidFill>
+            <a:srgbClr val="028090"/>
+          </a:solidFill>
+          <a:ln>
+            <a:noFill/>
+          </a:ln>
+        </p:spPr>
+        <p:style>
+          <a:lnRef idx="1">
+            <a:schemeClr val="accent1"/>
+          </a:lnRef>
+          <a:fillRef idx="3">
+            <a:schemeClr val="accent1"/>
+          </a:fillRef>
+          <a:effectRef idx="2">
+            <a:schemeClr val="accent1"/>
+          </a:effectRef>
+          <a:fontRef idx="minor">
+            <a:schemeClr val="lt1"/>
+          </a:fontRef>
+        </p:style>
+        <p:txBody>
+          <a:bodyPr rtlCol="0" anchor="ctr"/>
+          <a:lstStyle/>
+          <a:p>
+            <a:pPr algn="ctr"/>
+          </a:p>
+        </p:txBody>
+      </p:sp>
+      <p:sp>
+        <p:nvSpPr>
+          <p:cNvPr id="51" name="TextBox 50"/>
+          <p:cNvSpPr txBox="1"/>
+          <p:nvPr/>
+        </p:nvSpPr>
+        <p:spPr>
+          <a:xfrm>
+            <a:off x="768096" y="1911095"/>
+            <a:ext cx="1645920" cy="182880"/>
+          </a:xfrm>
+          <a:prstGeom prst="rect">
+            <a:avLst/>
+          </a:prstGeom>
+          <a:noFill/>
+        </p:spPr>
+        <p:txBody>
+          <a:bodyPr wrap="square" lIns="0" rIns="0" tIns="0" bIns="0" anchor="t">
+            <a:spAutoFit/>
+          </a:bodyPr>
+          <a:lstStyle/>
+          <a:p>
+            <a:pPr algn="ctr"/>
+            <a:r>
+              <a:rPr sz="1440" b="1">
+                <a:solidFill>
+                  <a:srgbClr val="FFFFFF"/>
+                </a:solidFill>
+                <a:latin typeface="Calibri"/>
+              </a:rPr>
+              <a:t>Vue 前端</a:t>
+            </a:r>
+          </a:p>
+        </p:txBody>
+      </p:sp>
+      <p:sp>
+        <p:nvSpPr>
+          <p:cNvPr id="52" name="TextBox 51"/>
+          <p:cNvSpPr txBox="1"/>
+          <p:nvPr/>
+        </p:nvSpPr>
+        <p:spPr>
+          <a:xfrm>
+            <a:off x="795528" y="2249424"/>
+            <a:ext cx="1591056" cy="310896"/>
+          </a:xfrm>
+          <a:prstGeom prst="rect">
+            <a:avLst/>
+          </a:prstGeom>
+          <a:noFill/>
+        </p:spPr>
+        <p:txBody>
+          <a:bodyPr wrap="square" lIns="0" rIns="0" tIns="0" bIns="0" anchor="t">
+            <a:spAutoFit/>
+          </a:bodyPr>
+          <a:lstStyle/>
+          <a:p>
+            <a:pPr algn="ctr"/>
+            <a:r>
+              <a:rPr sz="1019" b="0">
+                <a:solidFill>
+                  <a:srgbClr val="FFFFFF"/>
+                </a:solidFill>
+                <a:latin typeface="Calibri"/>
+              </a:rPr>
+              <a:t>页面/对话/预览</a:t>
+            </a:r>
+          </a:p>
+        </p:txBody>
+      </p:sp>
+      <p:cxnSp>
+        <p:nvCxnSpPr>
+          <p:cNvPr id="53" name="Connector 52"/>
+          <p:cNvCxnSpPr/>
+          <p:nvPr/>
+        </p:nvCxnSpPr>
+        <p:spPr>
+          <a:xfrm>
+            <a:off x="2560320" y="2267712"/>
+            <a:ext cx="292608" cy="0"/>
+          </a:xfrm>
+          <a:prstGeom prst="line">
+            <a:avLst/>
+          </a:prstGeom>
+          <a:ln w="25400">
+            <a:solidFill>
+              <a:srgbClr val="1C7293"/>
+            </a:solidFill>
+          </a:ln>
+        </p:spPr>
+        <p:style>
+          <a:lnRef idx="2">
+            <a:schemeClr val="accent1"/>
+          </a:lnRef>
+          <a:fillRef idx="0">
+            <a:schemeClr val="accent1"/>
+          </a:fillRef>
+          <a:effectRef idx="1">
+            <a:schemeClr val="accent1"/>
+          </a:effectRef>
+          <a:fontRef idx="minor">
+            <a:schemeClr val="tx1"/>
+          </a:fontRef>
+        </p:style>
+      </p:cxnSp>
+      <p:sp>
+        <p:nvSpPr>
+          <p:cNvPr id="54" name="Rounded Rectangle 53"/>
+          <p:cNvSpPr/>
+          <p:nvPr/>
+        </p:nvSpPr>
+        <p:spPr>
+          <a:xfrm>
+            <a:off x="2944368" y="1682496"/>
+            <a:ext cx="1874519" cy="1170432"/>
+          </a:xfrm>
+          <a:prstGeom prst="roundRect">
+            <a:avLst/>
+          </a:prstGeom>
+          <a:solidFill>
+            <a:srgbClr val="1C7293"/>
+          </a:solidFill>
+          <a:ln>
+            <a:noFill/>
+          </a:ln>
+        </p:spPr>
+        <p:style>
+          <a:lnRef idx="1">
+            <a:schemeClr val="accent1"/>
+          </a:lnRef>
+          <a:fillRef idx="3">
+            <a:schemeClr val="accent1"/>
+          </a:fillRef>
+          <a:effectRef idx="2">
+            <a:schemeClr val="accent1"/>
+          </a:effectRef>
+          <a:fontRef idx="minor">
+            <a:schemeClr val="lt1"/>
+          </a:fontRef>
+        </p:style>
+        <p:txBody>
+          <a:bodyPr rtlCol="0" anchor="ctr"/>
+          <a:lstStyle/>
+          <a:p>
+            <a:pPr algn="ctr"/>
+          </a:p>
+        </p:txBody>
+      </p:sp>
+      <p:sp>
+        <p:nvSpPr>
+          <p:cNvPr id="55" name="TextBox 54"/>
+          <p:cNvSpPr txBox="1"/>
+          <p:nvPr/>
+        </p:nvSpPr>
+        <p:spPr>
+          <a:xfrm>
+            <a:off x="3054096" y="1911095"/>
+            <a:ext cx="1645920" cy="182880"/>
+          </a:xfrm>
+          <a:prstGeom prst="rect">
+            <a:avLst/>
+          </a:prstGeom>
+          <a:noFill/>
+        </p:spPr>
+        <p:txBody>
+          <a:bodyPr wrap="square" lIns="0" rIns="0" tIns="0" bIns="0" anchor="t">
+            <a:spAutoFit/>
+          </a:bodyPr>
+          <a:lstStyle/>
+          <a:p>
+            <a:pPr algn="ctr"/>
+            <a:r>
+              <a:rPr sz="1440" b="1">
+                <a:solidFill>
+                  <a:srgbClr val="FFFFFF"/>
+                </a:solidFill>
+                <a:latin typeface="Calibri"/>
+              </a:rPr>
+              <a:t>App 服务</a:t>
+            </a:r>
+          </a:p>
+        </p:txBody>
+      </p:sp>
+      <p:sp>
+        <p:nvSpPr>
+          <p:cNvPr id="56" name="TextBox 55"/>
+          <p:cNvSpPr txBox="1"/>
+          <p:nvPr/>
+        </p:nvSpPr>
+        <p:spPr>
+          <a:xfrm>
+            <a:off x="3081527" y="2249424"/>
+            <a:ext cx="1591056" cy="310896"/>
+          </a:xfrm>
+          <a:prstGeom prst="rect">
+            <a:avLst/>
+          </a:prstGeom>
+          <a:noFill/>
+        </p:spPr>
+        <p:txBody>
+          <a:bodyPr wrap="square" lIns="0" rIns="0" tIns="0" bIns="0" anchor="t">
+            <a:spAutoFit/>
+          </a:bodyPr>
+          <a:lstStyle/>
+          <a:p>
+            <a:pPr algn="ctr"/>
+            <a:r>
+              <a:rPr sz="1019" b="0">
+                <a:solidFill>
+                  <a:srgbClr val="FFFFFF"/>
+                </a:solidFill>
+                <a:latin typeface="Calibri"/>
+              </a:rPr>
+              <a:t>应用/聊天/API</a:t>
+            </a:r>
+          </a:p>
+        </p:txBody>
+      </p:sp>
+      <p:cxnSp>
+        <p:nvCxnSpPr>
+          <p:cNvPr id="57" name="Connector 56"/>
+          <p:cNvCxnSpPr/>
+          <p:nvPr/>
+        </p:nvCxnSpPr>
+        <p:spPr>
+          <a:xfrm>
+            <a:off x="4846320" y="2267712"/>
+            <a:ext cx="292607" cy="0"/>
+          </a:xfrm>
+          <a:prstGeom prst="line">
+            <a:avLst/>
+          </a:prstGeom>
+          <a:ln w="25400">
+            <a:solidFill>
+              <a:srgbClr val="1C7293"/>
+            </a:solidFill>
+          </a:ln>
+        </p:spPr>
+        <p:style>
+          <a:lnRef idx="2">
+            <a:schemeClr val="accent1"/>
+          </a:lnRef>
+          <a:fillRef idx="0">
+            <a:schemeClr val="accent1"/>
+          </a:fillRef>
+          <a:effectRef idx="1">
+            <a:schemeClr val="accent1"/>
+          </a:effectRef>
+          <a:fontRef idx="minor">
+            <a:schemeClr val="tx1"/>
+          </a:fontRef>
+        </p:style>
+      </p:cxnSp>
+      <p:sp>
+        <p:nvSpPr>
+          <p:cNvPr id="58" name="Rounded Rectangle 57"/>
+          <p:cNvSpPr/>
+          <p:nvPr/>
+        </p:nvSpPr>
+        <p:spPr>
+          <a:xfrm>
+            <a:off x="5230368" y="1682496"/>
+            <a:ext cx="1874519" cy="1170432"/>
+          </a:xfrm>
+          <a:prstGeom prst="roundRect">
+            <a:avLst/>
+          </a:prstGeom>
+          <a:solidFill>
+            <a:srgbClr val="21295C"/>
+          </a:solidFill>
+          <a:ln>
+            <a:noFill/>
+          </a:ln>
+        </p:spPr>
+        <p:style>
+          <a:lnRef idx="1">
+            <a:schemeClr val="accent1"/>
+          </a:lnRef>
+          <a:fillRef idx="3">
+            <a:schemeClr val="accent1"/>
+          </a:fillRef>
+          <a:effectRef idx="2">
+            <a:schemeClr val="accent1"/>
+          </a:effectRef>
+          <a:fontRef idx="minor">
+            <a:schemeClr val="lt1"/>
+          </a:fontRef>
+        </p:style>
+        <p:txBody>
+          <a:bodyPr rtlCol="0" anchor="ctr"/>
+          <a:lstStyle/>
+          <a:p>
+            <a:pPr algn="ctr"/>
+          </a:p>
+        </p:txBody>
+      </p:sp>
+      <p:sp>
+        <p:nvSpPr>
+          <p:cNvPr id="59" name="TextBox 58"/>
+          <p:cNvSpPr txBox="1"/>
+          <p:nvPr/>
+        </p:nvSpPr>
+        <p:spPr>
+          <a:xfrm>
+            <a:off x="5340096" y="1911095"/>
+            <a:ext cx="1645920" cy="182880"/>
+          </a:xfrm>
+          <a:prstGeom prst="rect">
+            <a:avLst/>
+          </a:prstGeom>
+          <a:noFill/>
+        </p:spPr>
+        <p:txBody>
+          <a:bodyPr wrap="square" lIns="0" rIns="0" tIns="0" bIns="0" anchor="t">
+            <a:spAutoFit/>
+          </a:bodyPr>
+          <a:lstStyle/>
+          <a:p>
+            <a:pPr algn="ctr"/>
+            <a:r>
+              <a:rPr sz="1440" b="1">
+                <a:solidFill>
+                  <a:srgbClr val="FFFFFF"/>
+                </a:solidFill>
+                <a:latin typeface="Calibri"/>
+              </a:rPr>
+              <a:t>AI 模块</a:t>
+            </a:r>
+          </a:p>
+        </p:txBody>
+      </p:sp>
+      <p:sp>
+        <p:nvSpPr>
+          <p:cNvPr id="60" name="TextBox 59"/>
+          <p:cNvSpPr txBox="1"/>
+          <p:nvPr/>
+        </p:nvSpPr>
+        <p:spPr>
+          <a:xfrm>
+            <a:off x="5367528" y="2249424"/>
+            <a:ext cx="1591056" cy="310896"/>
+          </a:xfrm>
+          <a:prstGeom prst="rect">
+            <a:avLst/>
+          </a:prstGeom>
+          <a:noFill/>
+        </p:spPr>
+        <p:txBody>
+          <a:bodyPr wrap="square" lIns="0" rIns="0" tIns="0" bIns="0" anchor="t">
+            <a:spAutoFit/>
+          </a:bodyPr>
+          <a:lstStyle/>
+          <a:p>
+            <a:pPr algn="ctr"/>
+            <a:r>
+              <a:rPr sz="1019" b="0">
+                <a:solidFill>
+                  <a:srgbClr val="FFFFFF"/>
+                </a:solidFill>
+                <a:latin typeface="Calibri"/>
+              </a:rPr>
+              <a:t>LangChain4j
+LangGraph4j</a:t>
+            </a:r>
+          </a:p>
+        </p:txBody>
+      </p:sp>
+      <p:cxnSp>
+        <p:nvCxnSpPr>
+          <p:cNvPr id="61" name="Connector 60"/>
+          <p:cNvCxnSpPr/>
+          <p:nvPr/>
+        </p:nvCxnSpPr>
+        <p:spPr>
+          <a:xfrm>
+            <a:off x="7132320" y="2267712"/>
+            <a:ext cx="292607" cy="0"/>
+          </a:xfrm>
+          <a:prstGeom prst="line">
+            <a:avLst/>
+          </a:prstGeom>
+          <a:ln w="25400">
+            <a:solidFill>
+              <a:srgbClr val="1C7293"/>
+            </a:solidFill>
+          </a:ln>
+        </p:spPr>
+        <p:style>
+          <a:lnRef idx="2">
+            <a:schemeClr val="accent1"/>
+          </a:lnRef>
+          <a:fillRef idx="0">
+            <a:schemeClr val="accent1"/>
+          </a:fillRef>
+          <a:effectRef idx="1">
+            <a:schemeClr val="accent1"/>
+          </a:effectRef>
+          <a:fontRef idx="minor">
+            <a:schemeClr val="tx1"/>
+          </a:fontRef>
+        </p:style>
+      </p:cxnSp>
+      <p:sp>
+        <p:nvSpPr>
+          <p:cNvPr id="62" name="Rounded Rectangle 61"/>
+          <p:cNvSpPr/>
+          <p:nvPr/>
+        </p:nvSpPr>
+        <p:spPr>
+          <a:xfrm>
+            <a:off x="7516368" y="1682496"/>
+            <a:ext cx="1874519" cy="1170432"/>
+          </a:xfrm>
+          <a:prstGeom prst="roundRect">
+            <a:avLst/>
+          </a:prstGeom>
+          <a:solidFill>
+            <a:srgbClr val="00A896"/>
+          </a:solidFill>
+          <a:ln>
+            <a:noFill/>
+          </a:ln>
+        </p:spPr>
+        <p:style>
+          <a:lnRef idx="1">
+            <a:schemeClr val="accent1"/>
+          </a:lnRef>
+          <a:fillRef idx="3">
+            <a:schemeClr val="accent1"/>
+          </a:fillRef>
+          <a:effectRef idx="2">
+            <a:schemeClr val="accent1"/>
+          </a:effectRef>
+          <a:fontRef idx="minor">
+            <a:schemeClr val="lt1"/>
+          </a:fontRef>
+        </p:style>
+        <p:txBody>
+          <a:bodyPr rtlCol="0" anchor="ctr"/>
+          <a:lstStyle/>
+          <a:p>
+            <a:pPr algn="ctr"/>
+          </a:p>
+        </p:txBody>
+      </p:sp>
+      <p:sp>
+        <p:nvSpPr>
+          <p:cNvPr id="63" name="TextBox 62"/>
+          <p:cNvSpPr txBox="1"/>
+          <p:nvPr/>
+        </p:nvSpPr>
+        <p:spPr>
+          <a:xfrm>
+            <a:off x="7626096" y="1911095"/>
+            <a:ext cx="1645920" cy="182880"/>
+          </a:xfrm>
+          <a:prstGeom prst="rect">
+            <a:avLst/>
+          </a:prstGeom>
+          <a:noFill/>
+        </p:spPr>
+        <p:txBody>
+          <a:bodyPr wrap="square" lIns="0" rIns="0" tIns="0" bIns="0" anchor="t">
+            <a:spAutoFit/>
+          </a:bodyPr>
+          <a:lstStyle/>
+          <a:p>
+            <a:pPr algn="ctr"/>
+            <a:r>
+              <a:rPr sz="1440" b="1">
+                <a:solidFill>
+                  <a:srgbClr val="FFFFFF"/>
+                </a:solidFill>
+                <a:latin typeface="Calibri"/>
+              </a:rPr>
+              <a:t>Screenshot</a:t>
+            </a:r>
+          </a:p>
+        </p:txBody>
+      </p:sp>
+      <p:sp>
+        <p:nvSpPr>
+          <p:cNvPr id="64" name="TextBox 63"/>
+          <p:cNvSpPr txBox="1"/>
+          <p:nvPr/>
+        </p:nvSpPr>
+        <p:spPr>
+          <a:xfrm>
+            <a:off x="7653528" y="2249424"/>
+            <a:ext cx="1591056" cy="310896"/>
+          </a:xfrm>
+          <a:prstGeom prst="rect">
+            <a:avLst/>
+          </a:prstGeom>
+          <a:noFill/>
+        </p:spPr>
+        <p:txBody>
+          <a:bodyPr wrap="square" lIns="0" rIns="0" tIns="0" bIns="0" anchor="t">
+            <a:spAutoFit/>
+          </a:bodyPr>
+          <a:lstStyle/>
+          <a:p>
+            <a:pPr algn="ctr"/>
+            <a:r>
+              <a:rPr sz="1019" b="0">
+                <a:solidFill>
+                  <a:srgbClr val="FFFFFF"/>
+                </a:solidFill>
+                <a:latin typeface="Calibri"/>
+              </a:rPr>
+              <a:t>Selenium 截图</a:t>
+            </a:r>
+          </a:p>
+        </p:txBody>
+      </p:sp>
+      <p:cxnSp>
+        <p:nvCxnSpPr>
+          <p:cNvPr id="65" name="Connector 64"/>
+          <p:cNvCxnSpPr/>
+          <p:nvPr/>
+        </p:nvCxnSpPr>
+        <p:spPr>
+          <a:xfrm>
+            <a:off x="9418320" y="2267712"/>
+            <a:ext cx="292608" cy="0"/>
+          </a:xfrm>
+          <a:prstGeom prst="line">
+            <a:avLst/>
+          </a:prstGeom>
+          <a:ln w="25400">
+            <a:solidFill>
+              <a:srgbClr val="1C7293"/>
+            </a:solidFill>
+          </a:ln>
+        </p:spPr>
+        <p:style>
+          <a:lnRef idx="2">
+            <a:schemeClr val="accent1"/>
+          </a:lnRef>
+          <a:fillRef idx="0">
+            <a:schemeClr val="accent1"/>
+          </a:fillRef>
+          <a:effectRef idx="1">
+            <a:schemeClr val="accent1"/>
+          </a:effectRef>
+          <a:fontRef idx="minor">
+            <a:schemeClr val="tx1"/>
+          </a:fontRef>
+        </p:style>
+      </p:cxnSp>
+      <p:sp>
+        <p:nvSpPr>
+          <p:cNvPr id="66" name="Rounded Rectangle 65"/>
+          <p:cNvSpPr/>
+          <p:nvPr/>
+        </p:nvSpPr>
+        <p:spPr>
+          <a:xfrm>
+            <a:off x="9802368" y="1682496"/>
+            <a:ext cx="1874519" cy="1170432"/>
+          </a:xfrm>
+          <a:prstGeom prst="roundRect">
+            <a:avLst/>
+          </a:prstGeom>
+          <a:solidFill>
+            <a:srgbClr val="F6A94A"/>
+          </a:solidFill>
+          <a:ln>
+            <a:noFill/>
+          </a:ln>
+        </p:spPr>
+        <p:style>
+          <a:lnRef idx="1">
+            <a:schemeClr val="accent1"/>
+          </a:lnRef>
+          <a:fillRef idx="3">
+            <a:schemeClr val="accent1"/>
+          </a:fillRef>
+          <a:effectRef idx="2">
+            <a:schemeClr val="accent1"/>
+          </a:effectRef>
+          <a:fontRef idx="minor">
+            <a:schemeClr val="lt1"/>
+          </a:fontRef>
+        </p:style>
+        <p:txBody>
+          <a:bodyPr rtlCol="0" anchor="ctr"/>
+          <a:lstStyle/>
+          <a:p>
+            <a:pPr algn="ctr"/>
+          </a:p>
+        </p:txBody>
+      </p:sp>
+      <p:sp>
+        <p:nvSpPr>
+          <p:cNvPr id="67" name="TextBox 66"/>
+          <p:cNvSpPr txBox="1"/>
+          <p:nvPr/>
+        </p:nvSpPr>
+        <p:spPr>
+          <a:xfrm>
+            <a:off x="9912096" y="1911095"/>
+            <a:ext cx="1645920" cy="182880"/>
+          </a:xfrm>
+          <a:prstGeom prst="rect">
+            <a:avLst/>
+          </a:prstGeom>
+          <a:noFill/>
+        </p:spPr>
+        <p:txBody>
+          <a:bodyPr wrap="square" lIns="0" rIns="0" tIns="0" bIns="0" anchor="t">
+            <a:spAutoFit/>
+          </a:bodyPr>
+          <a:lstStyle/>
+          <a:p>
+            <a:pPr algn="ctr"/>
+            <a:r>
+              <a:rPr sz="1440" b="1">
+                <a:solidFill>
+                  <a:srgbClr val="FFFFFF"/>
+                </a:solidFill>
+                <a:latin typeface="Calibri"/>
+              </a:rPr>
+              <a:t>基础设施</a:t>
+            </a:r>
+          </a:p>
+        </p:txBody>
+      </p:sp>
+      <p:sp>
+        <p:nvSpPr>
+          <p:cNvPr id="68" name="TextBox 67"/>
+          <p:cNvSpPr txBox="1"/>
+          <p:nvPr/>
+        </p:nvSpPr>
+        <p:spPr>
+          <a:xfrm>
+            <a:off x="9939528" y="2249424"/>
+            <a:ext cx="1591056" cy="310896"/>
+          </a:xfrm>
+          <a:prstGeom prst="rect">
+            <a:avLst/>
+          </a:prstGeom>
+          <a:noFill/>
+        </p:spPr>
+        <p:txBody>
+          <a:bodyPr wrap="square" lIns="0" rIns="0" tIns="0" bIns="0" anchor="t">
+            <a:spAutoFit/>
+          </a:bodyPr>
+          <a:lstStyle/>
+          <a:p>
+            <a:pPr algn="ctr"/>
+            <a:r>
+              <a:rPr sz="1019" b="0">
+                <a:solidFill>
+                  <a:srgbClr val="FFFFFF"/>
+                </a:solidFill>
+                <a:latin typeface="Calibri"/>
+              </a:rPr>
+              <a:t>MySQL/Redis/COS</a:t>
+            </a:r>
+          </a:p>
+        </p:txBody>
+      </p:sp>
+      <p:sp>
+        <p:nvSpPr>
+          <p:cNvPr id="69" name="Rounded Rectangle 68"/>
+          <p:cNvSpPr/>
+          <p:nvPr/>
+        </p:nvSpPr>
+        <p:spPr>
+          <a:xfrm>
+            <a:off x="713232" y="3520440"/>
+            <a:ext cx="1325880" cy="292608"/>
+          </a:xfrm>
+          <a:prstGeom prst="roundRect">
+            <a:avLst/>
+          </a:prstGeom>
+          <a:solidFill>
+            <a:srgbClr val="028090"/>
+          </a:solidFill>
+          <a:ln>
+            <a:noFill/>
+          </a:ln>
+        </p:spPr>
+        <p:style>
+          <a:lnRef idx="1">
+            <a:schemeClr val="accent1"/>
+          </a:lnRef>
+          <a:fillRef idx="3">
+            <a:schemeClr val="accent1"/>
+          </a:fillRef>
+          <a:effectRef idx="2">
+            <a:schemeClr val="accent1"/>
+          </a:effectRef>
+          <a:fontRef idx="minor">
+            <a:schemeClr val="lt1"/>
+          </a:fontRef>
+        </p:style>
+        <p:txBody>
+          <a:bodyPr rtlCol="0" anchor="ctr"/>
+          <a:lstStyle/>
+          <a:p>
+            <a:pPr algn="ctr"/>
+          </a:p>
+        </p:txBody>
+      </p:sp>
+      <p:sp>
+        <p:nvSpPr>
+          <p:cNvPr id="70" name="TextBox 69"/>
+          <p:cNvSpPr txBox="1"/>
+          <p:nvPr/>
+        </p:nvSpPr>
+        <p:spPr>
+          <a:xfrm>
+            <a:off x="822960" y="3584448"/>
+            <a:ext cx="1097280" cy="109728"/>
+          </a:xfrm>
+          <a:prstGeom prst="rect">
+            <a:avLst/>
+          </a:prstGeom>
+          <a:noFill/>
+        </p:spPr>
+        <p:txBody>
+          <a:bodyPr wrap="square" lIns="0" rIns="0" tIns="0" bIns="0" anchor="t">
+            <a:spAutoFit/>
+          </a:bodyPr>
+          <a:lstStyle/>
+          <a:p>
+            <a:pPr algn="ctr"/>
+            <a:r>
+              <a:rPr sz="950" b="1">
+                <a:solidFill>
+                  <a:srgbClr val="FFFFFF"/>
+                </a:solidFill>
+                <a:latin typeface="Calibri"/>
+              </a:rPr>
+              <a:t>微服务模块</a:t>
+            </a:r>
+          </a:p>
+        </p:txBody>
+      </p:sp>
+      <p:sp>
+        <p:nvSpPr>
+          <p:cNvPr id="71" name="Rounded Rectangle 70"/>
+          <p:cNvSpPr/>
+          <p:nvPr/>
+        </p:nvSpPr>
+        <p:spPr>
+          <a:xfrm>
+            <a:off x="713232" y="3968496"/>
+            <a:ext cx="2468880" cy="585216"/>
+          </a:xfrm>
+          <a:prstGeom prst="roundRect">
+            <a:avLst/>
+          </a:prstGeom>
+          <a:solidFill>
+            <a:srgbClr val="FFFFFF"/>
+          </a:solidFill>
+          <a:ln w="12700">
+            <a:solidFill>
+              <a:srgbClr val="CAE6EA"/>
+            </a:solidFill>
+          </a:ln>
+        </p:spPr>
+        <p:style>
+          <a:lnRef idx="1">
+            <a:schemeClr val="accent1"/>
+          </a:lnRef>
+          <a:fillRef idx="3">
+            <a:schemeClr val="accent1"/>
+          </a:fillRef>
+          <a:effectRef idx="2">
+            <a:schemeClr val="accent1"/>
+          </a:effectRef>
+          <a:fontRef idx="minor">
+            <a:schemeClr val="lt1"/>
+          </a:fontRef>
+        </p:style>
+        <p:txBody>
+          <a:bodyPr rtlCol="0" anchor="ctr"/>
+          <a:lstStyle/>
+          <a:p>
+            <a:pPr algn="ctr"/>
+          </a:p>
+        </p:txBody>
+      </p:sp>
+      <p:sp>
+        <p:nvSpPr>
+          <p:cNvPr id="72" name="TextBox 71"/>
+          <p:cNvSpPr txBox="1"/>
+          <p:nvPr/>
+        </p:nvSpPr>
+        <p:spPr>
+          <a:xfrm>
+            <a:off x="850392" y="4078224"/>
+            <a:ext cx="960120" cy="164592"/>
+          </a:xfrm>
+          <a:prstGeom prst="rect">
+            <a:avLst/>
+          </a:prstGeom>
+          <a:noFill/>
+        </p:spPr>
+        <p:txBody>
+          <a:bodyPr wrap="square" lIns="0" rIns="0" tIns="0" bIns="0" anchor="t">
+            <a:spAutoFit/>
+          </a:bodyPr>
+          <a:lstStyle/>
+          <a:p>
+            <a:pPr algn="l"/>
+            <a:r>
+              <a:rPr sz="1130" b="1">
+                <a:solidFill>
+                  <a:srgbClr val="065A82"/>
+                </a:solidFill>
+                <a:latin typeface="Georgia"/>
+              </a:rPr>
+              <a:t>common</a:t>
+            </a:r>
+          </a:p>
+        </p:txBody>
+      </p:sp>
+      <p:sp>
+        <p:nvSpPr>
+          <p:cNvPr id="73" name="TextBox 72"/>
+          <p:cNvSpPr txBox="1"/>
+          <p:nvPr/>
+        </p:nvSpPr>
+        <p:spPr>
+          <a:xfrm>
+            <a:off x="1856232" y="4087368"/>
+            <a:ext cx="1143000" cy="146304"/>
+          </a:xfrm>
+          <a:prstGeom prst="rect">
+            <a:avLst/>
+          </a:prstGeom>
+          <a:noFill/>
+        </p:spPr>
+        <p:txBody>
+          <a:bodyPr wrap="square" lIns="0" rIns="0" tIns="0" bIns="0" anchor="t">
+            <a:spAutoFit/>
+          </a:bodyPr>
+          <a:lstStyle/>
+          <a:p>
+            <a:pPr algn="l"/>
+            <a:r>
+              <a:rPr sz="880" b="0">
+                <a:solidFill>
+                  <a:srgbClr val="5B6B7A"/>
+                </a:solidFill>
+                <a:latin typeface="Calibri"/>
+              </a:rPr>
+              <a:t>通用响应/异常/工具</a:t>
+            </a:r>
+          </a:p>
+        </p:txBody>
+      </p:sp>
+      <p:sp>
+        <p:nvSpPr>
+          <p:cNvPr id="74" name="Rounded Rectangle 73"/>
+          <p:cNvSpPr/>
+          <p:nvPr/>
+        </p:nvSpPr>
+        <p:spPr>
+          <a:xfrm>
+            <a:off x="3493008" y="3968496"/>
+            <a:ext cx="2468880" cy="585216"/>
+          </a:xfrm>
+          <a:prstGeom prst="roundRect">
+            <a:avLst/>
+          </a:prstGeom>
+          <a:solidFill>
+            <a:srgbClr val="FFFFFF"/>
+          </a:solidFill>
+          <a:ln w="12700">
+            <a:solidFill>
+              <a:srgbClr val="CAE6EA"/>
+            </a:solidFill>
+          </a:ln>
+        </p:spPr>
+        <p:style>
+          <a:lnRef idx="1">
+            <a:schemeClr val="accent1"/>
+          </a:lnRef>
+          <a:fillRef idx="3">
+            <a:schemeClr val="accent1"/>
+          </a:fillRef>
+          <a:effectRef idx="2">
+            <a:schemeClr val="accent1"/>
+          </a:effectRef>
+          <a:fontRef idx="minor">
+            <a:schemeClr val="lt1"/>
+          </a:fontRef>
+        </p:style>
+        <p:txBody>
+          <a:bodyPr rtlCol="0" anchor="ctr"/>
+          <a:lstStyle/>
+          <a:p>
+            <a:pPr algn="ctr"/>
+          </a:p>
+        </p:txBody>
+      </p:sp>
+      <p:sp>
+        <p:nvSpPr>
+          <p:cNvPr id="75" name="TextBox 74"/>
+          <p:cNvSpPr txBox="1"/>
+          <p:nvPr/>
+        </p:nvSpPr>
+        <p:spPr>
+          <a:xfrm>
+            <a:off x="3630168" y="4078224"/>
+            <a:ext cx="960120" cy="164592"/>
+          </a:xfrm>
+          <a:prstGeom prst="rect">
+            <a:avLst/>
+          </a:prstGeom>
+          <a:noFill/>
+        </p:spPr>
+        <p:txBody>
+          <a:bodyPr wrap="square" lIns="0" rIns="0" tIns="0" bIns="0" anchor="t">
+            <a:spAutoFit/>
+          </a:bodyPr>
+          <a:lstStyle/>
+          <a:p>
+            <a:pPr algn="l"/>
+            <a:r>
+              <a:rPr sz="1130" b="1">
+                <a:solidFill>
+                  <a:srgbClr val="065A82"/>
+                </a:solidFill>
+                <a:latin typeface="Georgia"/>
+              </a:rPr>
+              <a:t>model</a:t>
+            </a:r>
+          </a:p>
+        </p:txBody>
+      </p:sp>
+      <p:sp>
+        <p:nvSpPr>
+          <p:cNvPr id="76" name="TextBox 75"/>
+          <p:cNvSpPr txBox="1"/>
+          <p:nvPr/>
+        </p:nvSpPr>
+        <p:spPr>
+          <a:xfrm>
+            <a:off x="4636008" y="4087368"/>
+            <a:ext cx="1143000" cy="146304"/>
+          </a:xfrm>
+          <a:prstGeom prst="rect">
+            <a:avLst/>
+          </a:prstGeom>
+          <a:noFill/>
+        </p:spPr>
+        <p:txBody>
+          <a:bodyPr wrap="square" lIns="0" rIns="0" tIns="0" bIns="0" anchor="t">
+            <a:spAutoFit/>
+          </a:bodyPr>
+          <a:lstStyle/>
+          <a:p>
+            <a:pPr algn="l"/>
+            <a:r>
+              <a:rPr sz="880" b="0">
+                <a:solidFill>
+                  <a:srgbClr val="5B6B7A"/>
+                </a:solidFill>
+                <a:latin typeface="Calibri"/>
+              </a:rPr>
+              <a:t>实体/DTO/VO/枚举</a:t>
+            </a:r>
+          </a:p>
+        </p:txBody>
+      </p:sp>
+      <p:sp>
+        <p:nvSpPr>
+          <p:cNvPr id="77" name="Rounded Rectangle 76"/>
+          <p:cNvSpPr/>
+          <p:nvPr/>
+        </p:nvSpPr>
+        <p:spPr>
+          <a:xfrm>
+            <a:off x="6272784" y="3968496"/>
+            <a:ext cx="2468880" cy="585216"/>
+          </a:xfrm>
+          <a:prstGeom prst="roundRect">
+            <a:avLst/>
+          </a:prstGeom>
+          <a:solidFill>
+            <a:srgbClr val="FFFFFF"/>
+          </a:solidFill>
+          <a:ln w="12700">
+            <a:solidFill>
+              <a:srgbClr val="CAE6EA"/>
+            </a:solidFill>
+          </a:ln>
+        </p:spPr>
+        <p:style>
+          <a:lnRef idx="1">
+            <a:schemeClr val="accent1"/>
+          </a:lnRef>
+          <a:fillRef idx="3">
+            <a:schemeClr val="accent1"/>
+          </a:fillRef>
+          <a:effectRef idx="2">
+            <a:schemeClr val="accent1"/>
+          </a:effectRef>
+          <a:fontRef idx="minor">
+            <a:schemeClr val="lt1"/>
+          </a:fontRef>
+        </p:style>
+        <p:txBody>
+          <a:bodyPr rtlCol="0" anchor="ctr"/>
+          <a:lstStyle/>
+          <a:p>
+            <a:pPr algn="ctr"/>
+          </a:p>
+        </p:txBody>
+      </p:sp>
+      <p:sp>
+        <p:nvSpPr>
+          <p:cNvPr id="78" name="TextBox 77"/>
+          <p:cNvSpPr txBox="1"/>
+          <p:nvPr/>
+        </p:nvSpPr>
+        <p:spPr>
+          <a:xfrm>
+            <a:off x="6409944" y="4078224"/>
+            <a:ext cx="960120" cy="164592"/>
+          </a:xfrm>
+          <a:prstGeom prst="rect">
+            <a:avLst/>
+          </a:prstGeom>
+          <a:noFill/>
+        </p:spPr>
+        <p:txBody>
+          <a:bodyPr wrap="square" lIns="0" rIns="0" tIns="0" bIns="0" anchor="t">
+            <a:spAutoFit/>
+          </a:bodyPr>
+          <a:lstStyle/>
+          <a:p>
+            <a:pPr algn="l"/>
+            <a:r>
+              <a:rPr sz="1130" b="1">
+                <a:solidFill>
+                  <a:srgbClr val="065A82"/>
+                </a:solidFill>
+                <a:latin typeface="Georgia"/>
+              </a:rPr>
+              <a:t>client</a:t>
+            </a:r>
+          </a:p>
+        </p:txBody>
+      </p:sp>
+      <p:sp>
+        <p:nvSpPr>
+          <p:cNvPr id="79" name="TextBox 78"/>
+          <p:cNvSpPr txBox="1"/>
+          <p:nvPr/>
+        </p:nvSpPr>
+        <p:spPr>
+          <a:xfrm>
+            <a:off x="7415783" y="4087368"/>
+            <a:ext cx="1143000" cy="146304"/>
+          </a:xfrm>
+          <a:prstGeom prst="rect">
+            <a:avLst/>
+          </a:prstGeom>
+          <a:noFill/>
+        </p:spPr>
+        <p:txBody>
+          <a:bodyPr wrap="square" lIns="0" rIns="0" tIns="0" bIns="0" anchor="t">
+            <a:spAutoFit/>
+          </a:bodyPr>
+          <a:lstStyle/>
+          <a:p>
+            <a:pPr algn="l"/>
+            <a:r>
+              <a:rPr sz="880" b="0">
+                <a:solidFill>
+                  <a:srgbClr val="5B6B7A"/>
+                </a:solidFill>
+                <a:latin typeface="Calibri"/>
+              </a:rPr>
+              <a:t>跨服务接口契约</a:t>
+            </a:r>
+          </a:p>
+        </p:txBody>
+      </p:sp>
+      <p:sp>
+        <p:nvSpPr>
+          <p:cNvPr id="80" name="Rounded Rectangle 79"/>
+          <p:cNvSpPr/>
+          <p:nvPr/>
+        </p:nvSpPr>
+        <p:spPr>
+          <a:xfrm>
+            <a:off x="9052560" y="3968496"/>
+            <a:ext cx="2468880" cy="585216"/>
+          </a:xfrm>
+          <a:prstGeom prst="roundRect">
+            <a:avLst/>
+          </a:prstGeom>
+          <a:solidFill>
+            <a:srgbClr val="FFFFFF"/>
+          </a:solidFill>
+          <a:ln w="12700">
+            <a:solidFill>
+              <a:srgbClr val="CAE6EA"/>
+            </a:solidFill>
+          </a:ln>
+        </p:spPr>
+        <p:style>
+          <a:lnRef idx="1">
+            <a:schemeClr val="accent1"/>
+          </a:lnRef>
+          <a:fillRef idx="3">
+            <a:schemeClr val="accent1"/>
+          </a:fillRef>
+          <a:effectRef idx="2">
+            <a:schemeClr val="accent1"/>
+          </a:effectRef>
+          <a:fontRef idx="minor">
+            <a:schemeClr val="lt1"/>
+          </a:fontRef>
+        </p:style>
+        <p:txBody>
+          <a:bodyPr rtlCol="0" anchor="ctr"/>
+          <a:lstStyle/>
+          <a:p>
+            <a:pPr algn="ctr"/>
+          </a:p>
+        </p:txBody>
+      </p:sp>
+      <p:sp>
+        <p:nvSpPr>
+          <p:cNvPr id="81" name="TextBox 80"/>
+          <p:cNvSpPr txBox="1"/>
+          <p:nvPr/>
+        </p:nvSpPr>
+        <p:spPr>
+          <a:xfrm>
+            <a:off x="9189720" y="4078224"/>
+            <a:ext cx="960120" cy="164592"/>
+          </a:xfrm>
+          <a:prstGeom prst="rect">
+            <a:avLst/>
+          </a:prstGeom>
+          <a:noFill/>
+        </p:spPr>
+        <p:txBody>
+          <a:bodyPr wrap="square" lIns="0" rIns="0" tIns="0" bIns="0" anchor="t">
+            <a:spAutoFit/>
+          </a:bodyPr>
+          <a:lstStyle/>
+          <a:p>
+            <a:pPr algn="l"/>
+            <a:r>
+              <a:rPr sz="1130" b="1">
+                <a:solidFill>
+                  <a:srgbClr val="065A82"/>
+                </a:solidFill>
+                <a:latin typeface="Georgia"/>
+              </a:rPr>
+              <a:t>user</a:t>
+            </a:r>
+          </a:p>
+        </p:txBody>
+      </p:sp>
+      <p:sp>
+        <p:nvSpPr>
+          <p:cNvPr id="82" name="TextBox 81"/>
+          <p:cNvSpPr txBox="1"/>
+          <p:nvPr/>
+        </p:nvSpPr>
+        <p:spPr>
+          <a:xfrm>
+            <a:off x="10195560" y="4087368"/>
+            <a:ext cx="1143000" cy="146304"/>
+          </a:xfrm>
+          <a:prstGeom prst="rect">
+            <a:avLst/>
+          </a:prstGeom>
+          <a:noFill/>
+        </p:spPr>
+        <p:txBody>
+          <a:bodyPr wrap="square" lIns="0" rIns="0" tIns="0" bIns="0" anchor="t">
+            <a:spAutoFit/>
+          </a:bodyPr>
+          <a:lstStyle/>
+          <a:p>
+            <a:pPr algn="l"/>
+            <a:r>
+              <a:rPr sz="880" b="0">
+                <a:solidFill>
+                  <a:srgbClr val="5B6B7A"/>
+                </a:solidFill>
+                <a:latin typeface="Calibri"/>
+              </a:rPr>
+              <a:t>用户与权限</a:t>
+            </a:r>
+          </a:p>
+        </p:txBody>
+      </p:sp>
+      <p:sp>
+        <p:nvSpPr>
+          <p:cNvPr id="83" name="Rounded Rectangle 82"/>
+          <p:cNvSpPr/>
+          <p:nvPr/>
+        </p:nvSpPr>
+        <p:spPr>
+          <a:xfrm>
+            <a:off x="713232" y="4773168"/>
+            <a:ext cx="2468880" cy="585216"/>
+          </a:xfrm>
+          <a:prstGeom prst="roundRect">
+            <a:avLst/>
+          </a:prstGeom>
+          <a:solidFill>
+            <a:srgbClr val="FFFFFF"/>
+          </a:solidFill>
+          <a:ln w="12700">
+            <a:solidFill>
+              <a:srgbClr val="CAE6EA"/>
+            </a:solidFill>
+          </a:ln>
+        </p:spPr>
+        <p:style>
+          <a:lnRef idx="1">
+            <a:schemeClr val="accent1"/>
+          </a:lnRef>
+          <a:fillRef idx="3">
+            <a:schemeClr val="accent1"/>
+          </a:fillRef>
+          <a:effectRef idx="2">
+            <a:schemeClr val="accent1"/>
+          </a:effectRef>
+          <a:fontRef idx="minor">
+            <a:schemeClr val="lt1"/>
+          </a:fontRef>
+        </p:style>
+        <p:txBody>
+          <a:bodyPr rtlCol="0" anchor="ctr"/>
+          <a:lstStyle/>
+          <a:p>
+            <a:pPr algn="ctr"/>
+          </a:p>
+        </p:txBody>
+      </p:sp>
+      <p:sp>
+        <p:nvSpPr>
+          <p:cNvPr id="84" name="TextBox 83"/>
+          <p:cNvSpPr txBox="1"/>
+          <p:nvPr/>
+        </p:nvSpPr>
+        <p:spPr>
+          <a:xfrm>
+            <a:off x="850392" y="4882896"/>
+            <a:ext cx="960120" cy="164592"/>
+          </a:xfrm>
+          <a:prstGeom prst="rect">
+            <a:avLst/>
+          </a:prstGeom>
+          <a:noFill/>
+        </p:spPr>
+        <p:txBody>
+          <a:bodyPr wrap="square" lIns="0" rIns="0" tIns="0" bIns="0" anchor="t">
+            <a:spAutoFit/>
+          </a:bodyPr>
+          <a:lstStyle/>
+          <a:p>
+            <a:pPr algn="l"/>
+            <a:r>
+              <a:rPr sz="1130" b="1">
+                <a:solidFill>
+                  <a:srgbClr val="065A82"/>
+                </a:solidFill>
+                <a:latin typeface="Georgia"/>
+              </a:rPr>
+              <a:t>app</a:t>
+            </a:r>
+          </a:p>
+        </p:txBody>
+      </p:sp>
+      <p:sp>
+        <p:nvSpPr>
+          <p:cNvPr id="85" name="TextBox 84"/>
+          <p:cNvSpPr txBox="1"/>
+          <p:nvPr/>
+        </p:nvSpPr>
+        <p:spPr>
+          <a:xfrm>
+            <a:off x="1856232" y="4892040"/>
+            <a:ext cx="1143000" cy="146304"/>
+          </a:xfrm>
+          <a:prstGeom prst="rect">
+            <a:avLst/>
+          </a:prstGeom>
+          <a:noFill/>
+        </p:spPr>
+        <p:txBody>
+          <a:bodyPr wrap="square" lIns="0" rIns="0" tIns="0" bIns="0" anchor="t">
+            <a:spAutoFit/>
+          </a:bodyPr>
+          <a:lstStyle/>
+          <a:p>
+            <a:pPr algn="l"/>
+            <a:r>
+              <a:rPr sz="880" b="0">
+                <a:solidFill>
+                  <a:srgbClr val="5B6B7A"/>
+                </a:solidFill>
+                <a:latin typeface="Calibri"/>
+              </a:rPr>
+              <a:t>应用与部署主流程</a:t>
+            </a:r>
+          </a:p>
+        </p:txBody>
+      </p:sp>
+      <p:sp>
+        <p:nvSpPr>
+          <p:cNvPr id="86" name="Rounded Rectangle 85"/>
+          <p:cNvSpPr/>
+          <p:nvPr/>
+        </p:nvSpPr>
+        <p:spPr>
+          <a:xfrm>
+            <a:off x="3493008" y="4773168"/>
+            <a:ext cx="2468880" cy="585216"/>
+          </a:xfrm>
+          <a:prstGeom prst="roundRect">
+            <a:avLst/>
+          </a:prstGeom>
+          <a:solidFill>
+            <a:srgbClr val="FFFFFF"/>
+          </a:solidFill>
+          <a:ln w="12700">
+            <a:solidFill>
+              <a:srgbClr val="CAE6EA"/>
+            </a:solidFill>
+          </a:ln>
+        </p:spPr>
+        <p:style>
+          <a:lnRef idx="1">
+            <a:schemeClr val="accent1"/>
+          </a:lnRef>
+          <a:fillRef idx="3">
+            <a:schemeClr val="accent1"/>
+          </a:fillRef>
+          <a:effectRef idx="2">
+            <a:schemeClr val="accent1"/>
+          </a:effectRef>
+          <a:fontRef idx="minor">
+            <a:schemeClr val="lt1"/>
+          </a:fontRef>
+        </p:style>
+        <p:txBody>
+          <a:bodyPr rtlCol="0" anchor="ctr"/>
+          <a:lstStyle/>
+          <a:p>
+            <a:pPr algn="ctr"/>
+          </a:p>
+        </p:txBody>
+      </p:sp>
+      <p:sp>
+        <p:nvSpPr>
+          <p:cNvPr id="87" name="TextBox 86"/>
+          <p:cNvSpPr txBox="1"/>
+          <p:nvPr/>
+        </p:nvSpPr>
+        <p:spPr>
+          <a:xfrm>
+            <a:off x="3630168" y="4882896"/>
+            <a:ext cx="960120" cy="164592"/>
+          </a:xfrm>
+          <a:prstGeom prst="rect">
+            <a:avLst/>
+          </a:prstGeom>
+          <a:noFill/>
+        </p:spPr>
+        <p:txBody>
+          <a:bodyPr wrap="square" lIns="0" rIns="0" tIns="0" bIns="0" anchor="t">
+            <a:spAutoFit/>
+          </a:bodyPr>
+          <a:lstStyle/>
+          <a:p>
+            <a:pPr algn="l"/>
+            <a:r>
+              <a:rPr sz="1130" b="1">
+                <a:solidFill>
+                  <a:srgbClr val="065A82"/>
+                </a:solidFill>
+                <a:latin typeface="Georgia"/>
+              </a:rPr>
+              <a:t>ai</a:t>
+            </a:r>
+          </a:p>
+        </p:txBody>
+      </p:sp>
+      <p:sp>
+        <p:nvSpPr>
+          <p:cNvPr id="88" name="TextBox 87"/>
+          <p:cNvSpPr txBox="1"/>
+          <p:nvPr/>
+        </p:nvSpPr>
+        <p:spPr>
+          <a:xfrm>
+            <a:off x="4636008" y="4892040"/>
+            <a:ext cx="1143000" cy="146304"/>
+          </a:xfrm>
+          <a:prstGeom prst="rect">
+            <a:avLst/>
+          </a:prstGeom>
+          <a:noFill/>
+        </p:spPr>
+        <p:txBody>
+          <a:bodyPr wrap="square" lIns="0" rIns="0" tIns="0" bIns="0" anchor="t">
+            <a:spAutoFit/>
+          </a:bodyPr>
+          <a:lstStyle/>
+          <a:p>
+            <a:pPr algn="l"/>
+            <a:r>
+              <a:rPr sz="880" b="0">
+                <a:solidFill>
+                  <a:srgbClr val="5B6B7A"/>
+                </a:solidFill>
+                <a:latin typeface="Calibri"/>
+              </a:rPr>
+              <a:t>模型/提示词/工具链</a:t>
+            </a:r>
+          </a:p>
+        </p:txBody>
+      </p:sp>
+      <p:sp>
+        <p:nvSpPr>
+          <p:cNvPr id="89" name="Rounded Rectangle 88"/>
+          <p:cNvSpPr/>
+          <p:nvPr/>
+        </p:nvSpPr>
+        <p:spPr>
+          <a:xfrm>
+            <a:off x="6272784" y="4773168"/>
+            <a:ext cx="2468880" cy="585216"/>
+          </a:xfrm>
+          <a:prstGeom prst="roundRect">
+            <a:avLst/>
+          </a:prstGeom>
+          <a:solidFill>
+            <a:srgbClr val="FFFFFF"/>
+          </a:solidFill>
+          <a:ln w="12700">
+            <a:solidFill>
+              <a:srgbClr val="CAE6EA"/>
+            </a:solidFill>
+          </a:ln>
+        </p:spPr>
+        <p:style>
+          <a:lnRef idx="1">
+            <a:schemeClr val="accent1"/>
+          </a:lnRef>
+          <a:fillRef idx="3">
+            <a:schemeClr val="accent1"/>
+          </a:fillRef>
+          <a:effectRef idx="2">
+            <a:schemeClr val="accent1"/>
+          </a:effectRef>
+          <a:fontRef idx="minor">
+            <a:schemeClr val="lt1"/>
+          </a:fontRef>
+        </p:style>
+        <p:txBody>
+          <a:bodyPr rtlCol="0" anchor="ctr"/>
+          <a:lstStyle/>
+          <a:p>
+            <a:pPr algn="ctr"/>
+          </a:p>
+        </p:txBody>
+      </p:sp>
+      <p:sp>
+        <p:nvSpPr>
+          <p:cNvPr id="90" name="TextBox 89"/>
+          <p:cNvSpPr txBox="1"/>
+          <p:nvPr/>
+        </p:nvSpPr>
+        <p:spPr>
+          <a:xfrm>
+            <a:off x="6409944" y="4882896"/>
+            <a:ext cx="960120" cy="164592"/>
+          </a:xfrm>
+          <a:prstGeom prst="rect">
+            <a:avLst/>
+          </a:prstGeom>
+          <a:noFill/>
+        </p:spPr>
+        <p:txBody>
+          <a:bodyPr wrap="square" lIns="0" rIns="0" tIns="0" bIns="0" anchor="t">
+            <a:spAutoFit/>
+          </a:bodyPr>
+          <a:lstStyle/>
+          <a:p>
+            <a:pPr algn="l"/>
+            <a:r>
+              <a:rPr sz="1130" b="1">
+                <a:solidFill>
+                  <a:srgbClr val="065A82"/>
+                </a:solidFill>
+                <a:latin typeface="Georgia"/>
+              </a:rPr>
+              <a:t>screenshot</a:t>
+            </a:r>
+          </a:p>
+        </p:txBody>
+      </p:sp>
+      <p:sp>
+        <p:nvSpPr>
+          <p:cNvPr id="91" name="TextBox 90"/>
+          <p:cNvSpPr txBox="1"/>
+          <p:nvPr/>
+        </p:nvSpPr>
+        <p:spPr>
+          <a:xfrm>
+            <a:off x="7415783" y="4892040"/>
+            <a:ext cx="1143000" cy="146304"/>
+          </a:xfrm>
+          <a:prstGeom prst="rect">
+            <a:avLst/>
+          </a:prstGeom>
+          <a:noFill/>
+        </p:spPr>
+        <p:txBody>
+          <a:bodyPr wrap="square" lIns="0" rIns="0" tIns="0" bIns="0" anchor="t">
+            <a:spAutoFit/>
+          </a:bodyPr>
+          <a:lstStyle/>
+          <a:p>
+            <a:pPr algn="l"/>
+            <a:r>
+              <a:rPr sz="880" b="0">
+                <a:solidFill>
+                  <a:srgbClr val="5B6B7A"/>
+                </a:solidFill>
+                <a:latin typeface="Calibri"/>
+              </a:rPr>
+              <a:t>截图服务</a:t>
             </a:r>
           </a:p>
         </p:txBody>

</xml_diff>

<commit_message>
docs: clean report slide text layers
Co-authored-by: 程序员鱼皮 <592789970@qq.com>
</commit_message>
<xml_diff>
--- a/docs/reports/project-status-2026-06-03.pptx
+++ b/docs/reports/project-status-2026-06-03.pptx
@@ -3150,162 +3150,6 @@
       </p:sp>
       <p:sp>
         <p:nvSpPr>
-          <p:cNvPr id="3" name="Oval 2"/>
-          <p:cNvSpPr/>
-          <p:nvPr/>
-        </p:nvSpPr>
-        <p:spPr>
-          <a:xfrm>
-            <a:off x="4754880" y="-822960"/>
-            <a:ext cx="8229600" cy="2743200"/>
-          </a:xfrm>
-          <a:prstGeom prst="ellipse">
-            <a:avLst/>
-          </a:prstGeom>
-          <a:solidFill>
-            <a:srgbClr val="028090"/>
-          </a:solidFill>
-          <a:ln>
-            <a:noFill/>
-          </a:ln>
-        </p:spPr>
-        <p:style>
-          <a:lnRef idx="1">
-            <a:schemeClr val="accent1"/>
-          </a:lnRef>
-          <a:fillRef idx="3">
-            <a:schemeClr val="accent1"/>
-          </a:fillRef>
-          <a:effectRef idx="2">
-            <a:schemeClr val="accent1"/>
-          </a:effectRef>
-          <a:fontRef idx="minor">
-            <a:schemeClr val="lt1"/>
-          </a:fontRef>
-        </p:style>
-        <p:txBody>
-          <a:bodyPr rtlCol="0" anchor="ctr"/>
-          <a:lstStyle/>
-          <a:p>
-            <a:pPr algn="ctr"/>
-          </a:p>
-        </p:txBody>
-      </p:sp>
-      <p:sp>
-        <p:nvSpPr>
-          <p:cNvPr id="4" name="Oval 3"/>
-          <p:cNvSpPr/>
-          <p:nvPr/>
-        </p:nvSpPr>
-        <p:spPr>
-          <a:xfrm>
-            <a:off x="8046720" y="4206240"/>
-            <a:ext cx="4389120" cy="2011680"/>
-          </a:xfrm>
-          <a:prstGeom prst="ellipse">
-            <a:avLst/>
-          </a:prstGeom>
-          <a:solidFill>
-            <a:srgbClr val="02C39A"/>
-          </a:solidFill>
-          <a:ln>
-            <a:noFill/>
-          </a:ln>
-        </p:spPr>
-        <p:style>
-          <a:lnRef idx="1">
-            <a:schemeClr val="accent1"/>
-          </a:lnRef>
-          <a:fillRef idx="3">
-            <a:schemeClr val="accent1"/>
-          </a:fillRef>
-          <a:effectRef idx="2">
-            <a:schemeClr val="accent1"/>
-          </a:effectRef>
-          <a:fontRef idx="minor">
-            <a:schemeClr val="lt1"/>
-          </a:fontRef>
-        </p:style>
-        <p:txBody>
-          <a:bodyPr rtlCol="0" anchor="ctr"/>
-          <a:lstStyle/>
-          <a:p>
-            <a:pPr algn="ctr"/>
-          </a:p>
-        </p:txBody>
-      </p:sp>
-      <p:sp>
-        <p:nvSpPr>
-          <p:cNvPr id="5" name="TextBox 4"/>
-          <p:cNvSpPr txBox="1"/>
-          <p:nvPr/>
-        </p:nvSpPr>
-        <p:spPr>
-          <a:xfrm>
-            <a:off x="749808" y="1508760"/>
-            <a:ext cx="7406640" cy="749808"/>
-          </a:xfrm>
-          <a:prstGeom prst="rect">
-            <a:avLst/>
-          </a:prstGeom>
-          <a:noFill/>
-        </p:spPr>
-        <p:txBody>
-          <a:bodyPr wrap="square" lIns="0" rIns="0" tIns="0" bIns="0" anchor="t">
-            <a:spAutoFit/>
-          </a:bodyPr>
-          <a:lstStyle/>
-          <a:p>
-            <a:pPr algn="l"/>
-            <a:r>
-              <a:rPr sz="4400" b="1" i="0">
-                <a:solidFill>
-                  <a:srgbClr val="FFFFFF"/>
-                </a:solidFill>
-                <a:latin typeface="Georgia"/>
-              </a:rPr>
-              <a:t>每日项目状态汇报</a:t>
-            </a:r>
-          </a:p>
-        </p:txBody>
-      </p:sp>
-      <p:sp>
-        <p:nvSpPr>
-          <p:cNvPr id="6" name="TextBox 5"/>
-          <p:cNvSpPr txBox="1"/>
-          <p:nvPr/>
-        </p:nvSpPr>
-        <p:spPr>
-          <a:xfrm>
-            <a:off x="804672" y="2340864"/>
-            <a:ext cx="7498079" cy="347472"/>
-          </a:xfrm>
-          <a:prstGeom prst="rect">
-            <a:avLst/>
-          </a:prstGeom>
-          <a:noFill/>
-        </p:spPr>
-        <p:txBody>
-          <a:bodyPr wrap="square" lIns="0" rIns="0" tIns="0" bIns="0" anchor="t">
-            <a:spAutoFit/>
-          </a:bodyPr>
-          <a:lstStyle/>
-          <a:p>
-            <a:pPr algn="l"/>
-            <a:r>
-              <a:rPr sz="1800" b="0" i="0">
-                <a:solidFill>
-                  <a:srgbClr val="D6F4EF"/>
-                </a:solidFill>
-                <a:latin typeface="Calibri"/>
-              </a:rPr>
-              <a:t>AI 零代码应用生成平台 · yu-ai-code-mother</a:t>
-            </a:r>
-          </a:p>
-        </p:txBody>
-      </p:sp>
-      <p:sp>
-        <p:nvSpPr>
           <p:cNvPr id="7" name="TextBox 6"/>
           <p:cNvSpPr txBox="1"/>
           <p:nvPr/>
@@ -3340,345 +3184,6 @@
               </a:rPr>
               <a:t>运行日：2026-06-03（北京时间）
 受众：项目维护者 / 团队</a:t>
-            </a:r>
-          </a:p>
-        </p:txBody>
-      </p:sp>
-      <p:sp>
-        <p:nvSpPr>
-          <p:cNvPr id="8" name="Rounded Rectangle 7"/>
-          <p:cNvSpPr/>
-          <p:nvPr/>
-        </p:nvSpPr>
-        <p:spPr>
-          <a:xfrm>
-            <a:off x="7909560" y="1207008"/>
-            <a:ext cx="2743200" cy="658368"/>
-          </a:xfrm>
-          <a:prstGeom prst="roundRect">
-            <a:avLst/>
-          </a:prstGeom>
-          <a:solidFill>
-            <a:srgbClr val="FFFFFF"/>
-          </a:solidFill>
-          <a:ln>
-            <a:noFill/>
-          </a:ln>
-        </p:spPr>
-        <p:style>
-          <a:lnRef idx="1">
-            <a:schemeClr val="accent1"/>
-          </a:lnRef>
-          <a:fillRef idx="3">
-            <a:schemeClr val="accent1"/>
-          </a:fillRef>
-          <a:effectRef idx="2">
-            <a:schemeClr val="accent1"/>
-          </a:effectRef>
-          <a:fontRef idx="minor">
-            <a:schemeClr val="lt1"/>
-          </a:fontRef>
-        </p:style>
-        <p:txBody>
-          <a:bodyPr rtlCol="0" anchor="ctr"/>
-          <a:lstStyle/>
-          <a:p>
-            <a:pPr algn="ctr"/>
-          </a:p>
-        </p:txBody>
-      </p:sp>
-      <p:sp>
-        <p:nvSpPr>
-          <p:cNvPr id="9" name="TextBox 8"/>
-          <p:cNvSpPr txBox="1"/>
-          <p:nvPr/>
-        </p:nvSpPr>
-        <p:spPr>
-          <a:xfrm>
-            <a:off x="8138160" y="1353312"/>
-            <a:ext cx="960120" cy="164592"/>
-          </a:xfrm>
-          <a:prstGeom prst="rect">
-            <a:avLst/>
-          </a:prstGeom>
-          <a:noFill/>
-        </p:spPr>
-        <p:txBody>
-          <a:bodyPr wrap="square" lIns="0" rIns="0" tIns="0" bIns="0" anchor="t">
-            <a:spAutoFit/>
-          </a:bodyPr>
-          <a:lstStyle/>
-          <a:p>
-            <a:pPr algn="l"/>
-            <a:r>
-              <a:rPr sz="950" b="1" i="0">
-                <a:solidFill>
-                  <a:srgbClr val="CFF6F0"/>
-                </a:solidFill>
-                <a:latin typeface="Calibri"/>
-              </a:rPr>
-              <a:t>代码生成</a:t>
-            </a:r>
-          </a:p>
-        </p:txBody>
-      </p:sp>
-      <p:sp>
-        <p:nvSpPr>
-          <p:cNvPr id="10" name="TextBox 9"/>
-          <p:cNvSpPr txBox="1"/>
-          <p:nvPr/>
-        </p:nvSpPr>
-        <p:spPr>
-          <a:xfrm>
-            <a:off x="9208008" y="1325880"/>
-            <a:ext cx="1188720" cy="237744"/>
-          </a:xfrm>
-          <a:prstGeom prst="rect">
-            <a:avLst/>
-          </a:prstGeom>
-          <a:noFill/>
-        </p:spPr>
-        <p:txBody>
-          <a:bodyPr wrap="square" lIns="0" rIns="0" tIns="0" bIns="0" anchor="t">
-            <a:spAutoFit/>
-          </a:bodyPr>
-          <a:lstStyle/>
-          <a:p>
-            <a:pPr algn="l"/>
-            <a:r>
-              <a:rPr sz="1600" b="1" i="0">
-                <a:solidFill>
-                  <a:srgbClr val="FFFFFF"/>
-                </a:solidFill>
-                <a:latin typeface="Calibri"/>
-              </a:rPr>
-              <a:t>AI</a:t>
-            </a:r>
-          </a:p>
-        </p:txBody>
-      </p:sp>
-      <p:sp>
-        <p:nvSpPr>
-          <p:cNvPr id="11" name="Rounded Rectangle 10"/>
-          <p:cNvSpPr/>
-          <p:nvPr/>
-        </p:nvSpPr>
-        <p:spPr>
-          <a:xfrm>
-            <a:off x="7909560" y="2167128"/>
-            <a:ext cx="2743200" cy="658368"/>
-          </a:xfrm>
-          <a:prstGeom prst="roundRect">
-            <a:avLst/>
-          </a:prstGeom>
-          <a:solidFill>
-            <a:srgbClr val="FFFFFF"/>
-          </a:solidFill>
-          <a:ln>
-            <a:noFill/>
-          </a:ln>
-        </p:spPr>
-        <p:style>
-          <a:lnRef idx="1">
-            <a:schemeClr val="accent1"/>
-          </a:lnRef>
-          <a:fillRef idx="3">
-            <a:schemeClr val="accent1"/>
-          </a:fillRef>
-          <a:effectRef idx="2">
-            <a:schemeClr val="accent1"/>
-          </a:effectRef>
-          <a:fontRef idx="minor">
-            <a:schemeClr val="lt1"/>
-          </a:fontRef>
-        </p:style>
-        <p:txBody>
-          <a:bodyPr rtlCol="0" anchor="ctr"/>
-          <a:lstStyle/>
-          <a:p>
-            <a:pPr algn="ctr"/>
-          </a:p>
-        </p:txBody>
-      </p:sp>
-      <p:sp>
-        <p:nvSpPr>
-          <p:cNvPr id="12" name="TextBox 11"/>
-          <p:cNvSpPr txBox="1"/>
-          <p:nvPr/>
-        </p:nvSpPr>
-        <p:spPr>
-          <a:xfrm>
-            <a:off x="8138160" y="2313432"/>
-            <a:ext cx="960120" cy="164592"/>
-          </a:xfrm>
-          <a:prstGeom prst="rect">
-            <a:avLst/>
-          </a:prstGeom>
-          <a:noFill/>
-        </p:spPr>
-        <p:txBody>
-          <a:bodyPr wrap="square" lIns="0" rIns="0" tIns="0" bIns="0" anchor="t">
-            <a:spAutoFit/>
-          </a:bodyPr>
-          <a:lstStyle/>
-          <a:p>
-            <a:pPr algn="l"/>
-            <a:r>
-              <a:rPr sz="950" b="1" i="0">
-                <a:solidFill>
-                  <a:srgbClr val="CFF6F0"/>
-                </a:solidFill>
-                <a:latin typeface="Calibri"/>
-              </a:rPr>
-              <a:t>架构阶段</a:t>
-            </a:r>
-          </a:p>
-        </p:txBody>
-      </p:sp>
-      <p:sp>
-        <p:nvSpPr>
-          <p:cNvPr id="13" name="TextBox 12"/>
-          <p:cNvSpPr txBox="1"/>
-          <p:nvPr/>
-        </p:nvSpPr>
-        <p:spPr>
-          <a:xfrm>
-            <a:off x="9208008" y="2286000"/>
-            <a:ext cx="1188720" cy="237744"/>
-          </a:xfrm>
-          <a:prstGeom prst="rect">
-            <a:avLst/>
-          </a:prstGeom>
-          <a:noFill/>
-        </p:spPr>
-        <p:txBody>
-          <a:bodyPr wrap="square" lIns="0" rIns="0" tIns="0" bIns="0" anchor="t">
-            <a:spAutoFit/>
-          </a:bodyPr>
-          <a:lstStyle/>
-          <a:p>
-            <a:pPr algn="l"/>
-            <a:r>
-              <a:rPr sz="1600" b="1" i="0">
-                <a:solidFill>
-                  <a:srgbClr val="FFFFFF"/>
-                </a:solidFill>
-                <a:latin typeface="Calibri"/>
-              </a:rPr>
-              <a:t>微服务</a:t>
-            </a:r>
-          </a:p>
-        </p:txBody>
-      </p:sp>
-      <p:sp>
-        <p:nvSpPr>
-          <p:cNvPr id="14" name="Rounded Rectangle 13"/>
-          <p:cNvSpPr/>
-          <p:nvPr/>
-        </p:nvSpPr>
-        <p:spPr>
-          <a:xfrm>
-            <a:off x="7909560" y="3127248"/>
-            <a:ext cx="2743200" cy="658368"/>
-          </a:xfrm>
-          <a:prstGeom prst="roundRect">
-            <a:avLst/>
-          </a:prstGeom>
-          <a:solidFill>
-            <a:srgbClr val="FFFFFF"/>
-          </a:solidFill>
-          <a:ln>
-            <a:noFill/>
-          </a:ln>
-        </p:spPr>
-        <p:style>
-          <a:lnRef idx="1">
-            <a:schemeClr val="accent1"/>
-          </a:lnRef>
-          <a:fillRef idx="3">
-            <a:schemeClr val="accent1"/>
-          </a:fillRef>
-          <a:effectRef idx="2">
-            <a:schemeClr val="accent1"/>
-          </a:effectRef>
-          <a:fontRef idx="minor">
-            <a:schemeClr val="lt1"/>
-          </a:fontRef>
-        </p:style>
-        <p:txBody>
-          <a:bodyPr rtlCol="0" anchor="ctr"/>
-          <a:lstStyle/>
-          <a:p>
-            <a:pPr algn="ctr"/>
-          </a:p>
-        </p:txBody>
-      </p:sp>
-      <p:sp>
-        <p:nvSpPr>
-          <p:cNvPr id="15" name="TextBox 14"/>
-          <p:cNvSpPr txBox="1"/>
-          <p:nvPr/>
-        </p:nvSpPr>
-        <p:spPr>
-          <a:xfrm>
-            <a:off x="8138160" y="3273552"/>
-            <a:ext cx="960120" cy="164592"/>
-          </a:xfrm>
-          <a:prstGeom prst="rect">
-            <a:avLst/>
-          </a:prstGeom>
-          <a:noFill/>
-        </p:spPr>
-        <p:txBody>
-          <a:bodyPr wrap="square" lIns="0" rIns="0" tIns="0" bIns="0" anchor="t">
-            <a:spAutoFit/>
-          </a:bodyPr>
-          <a:lstStyle/>
-          <a:p>
-            <a:pPr algn="l"/>
-            <a:r>
-              <a:rPr sz="950" b="1" i="0">
-                <a:solidFill>
-                  <a:srgbClr val="CFF6F0"/>
-                </a:solidFill>
-                <a:latin typeface="Calibri"/>
-              </a:rPr>
-              <a:t>验证重点</a:t>
-            </a:r>
-          </a:p>
-        </p:txBody>
-      </p:sp>
-      <p:sp>
-        <p:nvSpPr>
-          <p:cNvPr id="16" name="TextBox 15"/>
-          <p:cNvSpPr txBox="1"/>
-          <p:nvPr/>
-        </p:nvSpPr>
-        <p:spPr>
-          <a:xfrm>
-            <a:off x="9208008" y="3246120"/>
-            <a:ext cx="1188720" cy="237744"/>
-          </a:xfrm>
-          <a:prstGeom prst="rect">
-            <a:avLst/>
-          </a:prstGeom>
-          <a:noFill/>
-        </p:spPr>
-        <p:txBody>
-          <a:bodyPr wrap="square" lIns="0" rIns="0" tIns="0" bIns="0" anchor="t">
-            <a:spAutoFit/>
-          </a:bodyPr>
-          <a:lstStyle/>
-          <a:p>
-            <a:pPr algn="l"/>
-            <a:r>
-              <a:rPr sz="1600" b="1" i="0">
-                <a:solidFill>
-                  <a:srgbClr val="FFFFFF"/>
-                </a:solidFill>
-                <a:latin typeface="Calibri"/>
-              </a:rPr>
-              <a:t>质量</a:t>
             </a:r>
           </a:p>
         </p:txBody>
@@ -4206,49 +3711,6 @@
       <p:grpSpPr/>
       <p:sp>
         <p:nvSpPr>
-          <p:cNvPr id="2" name="Oval 1"/>
-          <p:cNvSpPr/>
-          <p:nvPr/>
-        </p:nvSpPr>
-        <p:spPr>
-          <a:xfrm>
-            <a:off x="-640080" y="5074920"/>
-            <a:ext cx="6583680" cy="2011680"/>
-          </a:xfrm>
-          <a:prstGeom prst="ellipse">
-            <a:avLst/>
-          </a:prstGeom>
-          <a:solidFill>
-            <a:srgbClr val="065A82"/>
-          </a:solidFill>
-          <a:ln>
-            <a:noFill/>
-          </a:ln>
-        </p:spPr>
-        <p:style>
-          <a:lnRef idx="1">
-            <a:schemeClr val="accent1"/>
-          </a:lnRef>
-          <a:fillRef idx="3">
-            <a:schemeClr val="accent1"/>
-          </a:fillRef>
-          <a:effectRef idx="2">
-            <a:schemeClr val="accent1"/>
-          </a:effectRef>
-          <a:fontRef idx="minor">
-            <a:schemeClr val="lt1"/>
-          </a:fontRef>
-        </p:style>
-        <p:txBody>
-          <a:bodyPr rtlCol="0" anchor="ctr"/>
-          <a:lstStyle/>
-          <a:p>
-            <a:pPr algn="ctr"/>
-          </a:p>
-        </p:txBody>
-      </p:sp>
-      <p:sp>
-        <p:nvSpPr>
           <p:cNvPr id="3" name="Oval 2"/>
           <p:cNvSpPr/>
           <p:nvPr/>
@@ -4292,49 +3754,6 @@
       </p:sp>
       <p:sp>
         <p:nvSpPr>
-          <p:cNvPr id="4" name="Oval 3"/>
-          <p:cNvSpPr/>
-          <p:nvPr/>
-        </p:nvSpPr>
-        <p:spPr>
-          <a:xfrm>
-            <a:off x="9509760" y="4937760"/>
-            <a:ext cx="3108960" cy="1645920"/>
-          </a:xfrm>
-          <a:prstGeom prst="ellipse">
-            <a:avLst/>
-          </a:prstGeom>
-          <a:solidFill>
-            <a:srgbClr val="02C39A"/>
-          </a:solidFill>
-          <a:ln>
-            <a:noFill/>
-          </a:ln>
-        </p:spPr>
-        <p:style>
-          <a:lnRef idx="1">
-            <a:schemeClr val="accent1"/>
-          </a:lnRef>
-          <a:fillRef idx="3">
-            <a:schemeClr val="accent1"/>
-          </a:fillRef>
-          <a:effectRef idx="2">
-            <a:schemeClr val="accent1"/>
-          </a:effectRef>
-          <a:fontRef idx="minor">
-            <a:schemeClr val="lt1"/>
-          </a:fontRef>
-        </p:style>
-        <p:txBody>
-          <a:bodyPr rtlCol="0" anchor="ctr"/>
-          <a:lstStyle/>
-          <a:p>
-            <a:pPr algn="ctr"/>
-          </a:p>
-        </p:txBody>
-      </p:sp>
-      <p:sp>
-        <p:nvSpPr>
           <p:cNvPr id="5" name="TextBox 4"/>
           <p:cNvSpPr txBox="1"/>
           <p:nvPr/>
@@ -4405,14 +3824,49 @@
       </p:sp>
       <p:sp>
         <p:nvSpPr>
-          <p:cNvPr id="7" name="Rounded Rectangle 6"/>
+          <p:cNvPr id="17" name="TextBox 16"/>
+          <p:cNvSpPr txBox="1"/>
+          <p:nvPr/>
+        </p:nvSpPr>
+        <p:spPr>
+          <a:xfrm>
+            <a:off x="658368" y="6473952"/>
+            <a:ext cx="4754880" cy="201168"/>
+          </a:xfrm>
+          <a:prstGeom prst="rect">
+            <a:avLst/>
+          </a:prstGeom>
+          <a:noFill/>
+        </p:spPr>
+        <p:txBody>
+          <a:bodyPr wrap="square" lIns="0" rIns="0" tIns="0" bIns="0" anchor="t">
+            <a:spAutoFit/>
+          </a:bodyPr>
+          <a:lstStyle/>
+          <a:p>
+            <a:pPr algn="l"/>
+            <a:r>
+              <a:rPr sz="950" b="0" i="0">
+                <a:solidFill>
+                  <a:srgbClr val="D4F7F1"/>
+                </a:solidFill>
+                <a:latin typeface="Calibri"/>
+              </a:rPr>
+              <a:t>yu-ai-code-mother · 每日项目状态 · 10</a:t>
+            </a:r>
+          </a:p>
+        </p:txBody>
+      </p:sp>
+      <p:sp>
+        <p:nvSpPr>
+          <p:cNvPr id="18" name="Rounded Rectangle 17"/>
           <p:cNvSpPr/>
           <p:nvPr/>
         </p:nvSpPr>
         <p:spPr>
           <a:xfrm>
-            <a:off x="914400" y="1874519"/>
-            <a:ext cx="9966960" cy="658368"/>
+            <a:off x="10908792" y="6428232"/>
+            <a:ext cx="612648" cy="128016"/>
           </a:xfrm>
           <a:prstGeom prst="roundRect">
             <a:avLst/>
@@ -4448,415 +3902,6 @@
       </p:sp>
       <p:sp>
         <p:nvSpPr>
-          <p:cNvPr id="8" name="TextBox 7"/>
-          <p:cNvSpPr txBox="1"/>
-          <p:nvPr/>
-        </p:nvSpPr>
-        <p:spPr>
-          <a:xfrm>
-            <a:off x="1207008" y="2075688"/>
-            <a:ext cx="658368" cy="164592"/>
-          </a:xfrm>
-          <a:prstGeom prst="rect">
-            <a:avLst/>
-          </a:prstGeom>
-          <a:noFill/>
-        </p:spPr>
-        <p:txBody>
-          <a:bodyPr wrap="square" lIns="0" rIns="0" tIns="0" bIns="0" anchor="t">
-            <a:spAutoFit/>
-          </a:bodyPr>
-          <a:lstStyle/>
-          <a:p>
-            <a:pPr algn="l"/>
-            <a:r>
-              <a:rPr sz="1500" b="1" i="0">
-                <a:solidFill>
-                  <a:srgbClr val="02C39A"/>
-                </a:solidFill>
-                <a:latin typeface="Georgia"/>
-              </a:rPr>
-              <a:t>能力</a:t>
-            </a:r>
-          </a:p>
-        </p:txBody>
-      </p:sp>
-      <p:sp>
-        <p:nvSpPr>
-          <p:cNvPr id="9" name="TextBox 8"/>
-          <p:cNvSpPr txBox="1"/>
-          <p:nvPr/>
-        </p:nvSpPr>
-        <p:spPr>
-          <a:xfrm>
-            <a:off x="2057400" y="2075688"/>
-            <a:ext cx="8138160" cy="173736"/>
-          </a:xfrm>
-          <a:prstGeom prst="rect">
-            <a:avLst/>
-          </a:prstGeom>
-          <a:noFill/>
-        </p:spPr>
-        <p:txBody>
-          <a:bodyPr wrap="square" lIns="0" rIns="0" tIns="0" bIns="0" anchor="t">
-            <a:spAutoFit/>
-          </a:bodyPr>
-          <a:lstStyle/>
-          <a:p>
-            <a:pPr algn="l"/>
-            <a:r>
-              <a:rPr sz="1340" b="0" i="0">
-                <a:solidFill>
-                  <a:srgbClr val="FFFFFF"/>
-                </a:solidFill>
-                <a:latin typeface="Calibri"/>
-              </a:rPr>
-              <a:t>AI 生成、编辑、部署、管理闭环已具备雏形，适合围绕用户主路径继续打磨体验。</a:t>
-            </a:r>
-          </a:p>
-        </p:txBody>
-      </p:sp>
-      <p:sp>
-        <p:nvSpPr>
-          <p:cNvPr id="10" name="Rounded Rectangle 9"/>
-          <p:cNvSpPr/>
-          <p:nvPr/>
-        </p:nvSpPr>
-        <p:spPr>
-          <a:xfrm>
-            <a:off x="914400" y="2834639"/>
-            <a:ext cx="9966960" cy="658368"/>
-          </a:xfrm>
-          <a:prstGeom prst="roundRect">
-            <a:avLst/>
-          </a:prstGeom>
-          <a:solidFill>
-            <a:srgbClr val="FFFFFF"/>
-          </a:solidFill>
-          <a:ln>
-            <a:noFill/>
-          </a:ln>
-        </p:spPr>
-        <p:style>
-          <a:lnRef idx="1">
-            <a:schemeClr val="accent1"/>
-          </a:lnRef>
-          <a:fillRef idx="3">
-            <a:schemeClr val="accent1"/>
-          </a:fillRef>
-          <a:effectRef idx="2">
-            <a:schemeClr val="accent1"/>
-          </a:effectRef>
-          <a:fontRef idx="minor">
-            <a:schemeClr val="lt1"/>
-          </a:fontRef>
-        </p:style>
-        <p:txBody>
-          <a:bodyPr rtlCol="0" anchor="ctr"/>
-          <a:lstStyle/>
-          <a:p>
-            <a:pPr algn="ctr"/>
-          </a:p>
-        </p:txBody>
-      </p:sp>
-      <p:sp>
-        <p:nvSpPr>
-          <p:cNvPr id="11" name="TextBox 10"/>
-          <p:cNvSpPr txBox="1"/>
-          <p:nvPr/>
-        </p:nvSpPr>
-        <p:spPr>
-          <a:xfrm>
-            <a:off x="1207008" y="3035808"/>
-            <a:ext cx="658368" cy="164592"/>
-          </a:xfrm>
-          <a:prstGeom prst="rect">
-            <a:avLst/>
-          </a:prstGeom>
-          <a:noFill/>
-        </p:spPr>
-        <p:txBody>
-          <a:bodyPr wrap="square" lIns="0" rIns="0" tIns="0" bIns="0" anchor="t">
-            <a:spAutoFit/>
-          </a:bodyPr>
-          <a:lstStyle/>
-          <a:p>
-            <a:pPr algn="l"/>
-            <a:r>
-              <a:rPr sz="1500" b="1" i="0">
-                <a:solidFill>
-                  <a:srgbClr val="02C39A"/>
-                </a:solidFill>
-                <a:latin typeface="Georgia"/>
-              </a:rPr>
-              <a:t>架构</a:t>
-            </a:r>
-          </a:p>
-        </p:txBody>
-      </p:sp>
-      <p:sp>
-        <p:nvSpPr>
-          <p:cNvPr id="12" name="TextBox 11"/>
-          <p:cNvSpPr txBox="1"/>
-          <p:nvPr/>
-        </p:nvSpPr>
-        <p:spPr>
-          <a:xfrm>
-            <a:off x="2057400" y="3035808"/>
-            <a:ext cx="8138160" cy="173736"/>
-          </a:xfrm>
-          <a:prstGeom prst="rect">
-            <a:avLst/>
-          </a:prstGeom>
-          <a:noFill/>
-        </p:spPr>
-        <p:txBody>
-          <a:bodyPr wrap="square" lIns="0" rIns="0" tIns="0" bIns="0" anchor="t">
-            <a:spAutoFit/>
-          </a:bodyPr>
-          <a:lstStyle/>
-          <a:p>
-            <a:pPr algn="l"/>
-            <a:r>
-              <a:rPr sz="1340" b="0" i="0">
-                <a:solidFill>
-                  <a:srgbClr val="FFFFFF"/>
-                </a:solidFill>
-                <a:latin typeface="Calibri"/>
-              </a:rPr>
-              <a:t>微服务拆分已经形成，需用文档、CI 与集成测试降低多依赖协作成本。</a:t>
-            </a:r>
-          </a:p>
-        </p:txBody>
-      </p:sp>
-      <p:sp>
-        <p:nvSpPr>
-          <p:cNvPr id="13" name="Rounded Rectangle 12"/>
-          <p:cNvSpPr/>
-          <p:nvPr/>
-        </p:nvSpPr>
-        <p:spPr>
-          <a:xfrm>
-            <a:off x="914400" y="3794760"/>
-            <a:ext cx="9966960" cy="658368"/>
-          </a:xfrm>
-          <a:prstGeom prst="roundRect">
-            <a:avLst/>
-          </a:prstGeom>
-          <a:solidFill>
-            <a:srgbClr val="FFFFFF"/>
-          </a:solidFill>
-          <a:ln>
-            <a:noFill/>
-          </a:ln>
-        </p:spPr>
-        <p:style>
-          <a:lnRef idx="1">
-            <a:schemeClr val="accent1"/>
-          </a:lnRef>
-          <a:fillRef idx="3">
-            <a:schemeClr val="accent1"/>
-          </a:fillRef>
-          <a:effectRef idx="2">
-            <a:schemeClr val="accent1"/>
-          </a:effectRef>
-          <a:fontRef idx="minor">
-            <a:schemeClr val="lt1"/>
-          </a:fontRef>
-        </p:style>
-        <p:txBody>
-          <a:bodyPr rtlCol="0" anchor="ctr"/>
-          <a:lstStyle/>
-          <a:p>
-            <a:pPr algn="ctr"/>
-          </a:p>
-        </p:txBody>
-      </p:sp>
-      <p:sp>
-        <p:nvSpPr>
-          <p:cNvPr id="14" name="TextBox 13"/>
-          <p:cNvSpPr txBox="1"/>
-          <p:nvPr/>
-        </p:nvSpPr>
-        <p:spPr>
-          <a:xfrm>
-            <a:off x="1207008" y="3995928"/>
-            <a:ext cx="658368" cy="164592"/>
-          </a:xfrm>
-          <a:prstGeom prst="rect">
-            <a:avLst/>
-          </a:prstGeom>
-          <a:noFill/>
-        </p:spPr>
-        <p:txBody>
-          <a:bodyPr wrap="square" lIns="0" rIns="0" tIns="0" bIns="0" anchor="t">
-            <a:spAutoFit/>
-          </a:bodyPr>
-          <a:lstStyle/>
-          <a:p>
-            <a:pPr algn="l"/>
-            <a:r>
-              <a:rPr sz="1500" b="1" i="0">
-                <a:solidFill>
-                  <a:srgbClr val="02C39A"/>
-                </a:solidFill>
-                <a:latin typeface="Georgia"/>
-              </a:rPr>
-              <a:t>重点</a:t>
-            </a:r>
-          </a:p>
-        </p:txBody>
-      </p:sp>
-      <p:sp>
-        <p:nvSpPr>
-          <p:cNvPr id="15" name="TextBox 14"/>
-          <p:cNvSpPr txBox="1"/>
-          <p:nvPr/>
-        </p:nvSpPr>
-        <p:spPr>
-          <a:xfrm>
-            <a:off x="2057400" y="3995928"/>
-            <a:ext cx="8138160" cy="173736"/>
-          </a:xfrm>
-          <a:prstGeom prst="rect">
-            <a:avLst/>
-          </a:prstGeom>
-          <a:noFill/>
-        </p:spPr>
-        <p:txBody>
-          <a:bodyPr wrap="square" lIns="0" rIns="0" tIns="0" bIns="0" anchor="t">
-            <a:spAutoFit/>
-          </a:bodyPr>
-          <a:lstStyle/>
-          <a:p>
-            <a:pPr algn="l"/>
-            <a:r>
-              <a:rPr sz="1340" b="0" i="0">
-                <a:solidFill>
-                  <a:srgbClr val="FFFFFF"/>
-                </a:solidFill>
-                <a:latin typeface="Calibri"/>
-              </a:rPr>
-              <a:t>优先补齐配置治理、自动化验证、监控告警与运行指标采集。</a:t>
-            </a:r>
-          </a:p>
-        </p:txBody>
-      </p:sp>
-      <p:sp>
-        <p:nvSpPr>
-          <p:cNvPr id="16" name="TextBox 15"/>
-          <p:cNvSpPr txBox="1"/>
-          <p:nvPr/>
-        </p:nvSpPr>
-        <p:spPr>
-          <a:xfrm>
-            <a:off x="914400" y="5742432"/>
-            <a:ext cx="6858000" cy="201168"/>
-          </a:xfrm>
-          <a:prstGeom prst="rect">
-            <a:avLst/>
-          </a:prstGeom>
-          <a:noFill/>
-        </p:spPr>
-        <p:txBody>
-          <a:bodyPr wrap="square" lIns="0" rIns="0" tIns="0" bIns="0" anchor="t">
-            <a:spAutoFit/>
-          </a:bodyPr>
-          <a:lstStyle/>
-          <a:p>
-            <a:pPr algn="l"/>
-            <a:r>
-              <a:rPr sz="1200" b="0" i="0">
-                <a:solidFill>
-                  <a:srgbClr val="D6F4EF"/>
-                </a:solidFill>
-                <a:latin typeface="Calibri"/>
-              </a:rPr>
-              <a:t>报告文件：docs/reports/project-status-2026-06-03.pptx</a:t>
-            </a:r>
-          </a:p>
-        </p:txBody>
-      </p:sp>
-      <p:sp>
-        <p:nvSpPr>
-          <p:cNvPr id="17" name="TextBox 16"/>
-          <p:cNvSpPr txBox="1"/>
-          <p:nvPr/>
-        </p:nvSpPr>
-        <p:spPr>
-          <a:xfrm>
-            <a:off x="658368" y="6473952"/>
-            <a:ext cx="4754880" cy="201168"/>
-          </a:xfrm>
-          <a:prstGeom prst="rect">
-            <a:avLst/>
-          </a:prstGeom>
-          <a:noFill/>
-        </p:spPr>
-        <p:txBody>
-          <a:bodyPr wrap="square" lIns="0" rIns="0" tIns="0" bIns="0" anchor="t">
-            <a:spAutoFit/>
-          </a:bodyPr>
-          <a:lstStyle/>
-          <a:p>
-            <a:pPr algn="l"/>
-            <a:r>
-              <a:rPr sz="950" b="0" i="0">
-                <a:solidFill>
-                  <a:srgbClr val="D4F7F1"/>
-                </a:solidFill>
-                <a:latin typeface="Calibri"/>
-              </a:rPr>
-              <a:t>yu-ai-code-mother · 每日项目状态 · 10</a:t>
-            </a:r>
-          </a:p>
-        </p:txBody>
-      </p:sp>
-      <p:sp>
-        <p:nvSpPr>
-          <p:cNvPr id="18" name="Rounded Rectangle 17"/>
-          <p:cNvSpPr/>
-          <p:nvPr/>
-        </p:nvSpPr>
-        <p:spPr>
-          <a:xfrm>
-            <a:off x="10908792" y="6428232"/>
-            <a:ext cx="612648" cy="128016"/>
-          </a:xfrm>
-          <a:prstGeom prst="roundRect">
-            <a:avLst/>
-          </a:prstGeom>
-          <a:solidFill>
-            <a:srgbClr val="FFFFFF"/>
-          </a:solidFill>
-          <a:ln>
-            <a:noFill/>
-          </a:ln>
-        </p:spPr>
-        <p:style>
-          <a:lnRef idx="1">
-            <a:schemeClr val="accent1"/>
-          </a:lnRef>
-          <a:fillRef idx="3">
-            <a:schemeClr val="accent1"/>
-          </a:fillRef>
-          <a:effectRef idx="2">
-            <a:schemeClr val="accent1"/>
-          </a:effectRef>
-          <a:fontRef idx="minor">
-            <a:schemeClr val="lt1"/>
-          </a:fontRef>
-        </p:style>
-        <p:txBody>
-          <a:bodyPr rtlCol="0" anchor="ctr"/>
-          <a:lstStyle/>
-          <a:p>
-            <a:pPr algn="ctr"/>
-          </a:p>
-        </p:txBody>
-      </p:sp>
-      <p:sp>
-        <p:nvSpPr>
           <p:cNvPr id="19" name="TextBox 18"/>
           <p:cNvSpPr txBox="1"/>
           <p:nvPr/>
@@ -4898,8 +3943,8 @@
         </p:nvSpPr>
         <p:spPr>
           <a:xfrm>
-            <a:off x="777240" y="1691640"/>
-            <a:ext cx="10332720" cy="4526280"/>
+            <a:off x="777240" y="1600200"/>
+            <a:ext cx="10424160" cy="4572000"/>
           </a:xfrm>
           <a:prstGeom prst="rect">
             <a:avLst/>
@@ -6043,13 +5088,13 @@
       </p:sp>
       <p:sp>
         <p:nvSpPr>
-          <p:cNvPr id="16" name="Rounded Rectangle 15"/>
+          <p:cNvPr id="21" name="Rounded Rectangle 20"/>
           <p:cNvSpPr/>
           <p:nvPr/>
         </p:nvSpPr>
         <p:spPr>
           <a:xfrm>
-            <a:off x="6291072" y="1810512"/>
+            <a:off x="9079991" y="1810512"/>
             <a:ext cx="2487168" cy="1325880"/>
           </a:xfrm>
           <a:prstGeom prst="roundRect">
@@ -6089,20 +5134,20 @@
       </p:sp>
       <p:sp>
         <p:nvSpPr>
-          <p:cNvPr id="17" name="Rounded Rectangle 16"/>
+          <p:cNvPr id="22" name="Rounded Rectangle 21"/>
           <p:cNvSpPr/>
           <p:nvPr/>
         </p:nvSpPr>
         <p:spPr>
           <a:xfrm>
-            <a:off x="6291072" y="1810512"/>
+            <a:off x="9079991" y="1810512"/>
             <a:ext cx="109728" cy="1325880"/>
           </a:xfrm>
           <a:prstGeom prst="roundRect">
             <a:avLst/>
           </a:prstGeom>
           <a:solidFill>
-            <a:srgbClr val="00A896"/>
+            <a:srgbClr val="F6A94A"/>
           </a:solidFill>
           <a:ln>
             <a:noFill/>
@@ -6132,13 +5177,13 @@
       </p:sp>
       <p:sp>
         <p:nvSpPr>
-          <p:cNvPr id="18" name="TextBox 17"/>
-          <p:cNvSpPr txBox="1"/>
-          <p:nvPr/>
-        </p:nvSpPr>
-        <p:spPr>
-          <a:xfrm>
-            <a:off x="6547104" y="2011680"/>
+          <p:cNvPr id="23" name="TextBox 22"/>
+          <p:cNvSpPr txBox="1"/>
+          <p:nvPr/>
+        </p:nvSpPr>
+        <p:spPr>
+          <a:xfrm>
+            <a:off x="9336023" y="2011680"/>
             <a:ext cx="2011680" cy="420624"/>
           </a:xfrm>
           <a:prstGeom prst="rect">
@@ -6156,24 +5201,24 @@
             <a:r>
               <a:rPr sz="2800" b="1" i="0">
                 <a:solidFill>
-                  <a:srgbClr val="00A896"/>
+                  <a:srgbClr val="F6A94A"/>
                 </a:solidFill>
                 <a:latin typeface="Georgia"/>
               </a:rPr>
-              <a:t>7</a:t>
-            </a:r>
-          </a:p>
-        </p:txBody>
-      </p:sp>
-      <p:sp>
-        <p:nvSpPr>
-          <p:cNvPr id="19" name="TextBox 18"/>
-          <p:cNvSpPr txBox="1"/>
-          <p:nvPr/>
-        </p:nvSpPr>
-        <p:spPr>
-          <a:xfrm>
-            <a:off x="6547104" y="2496312"/>
+              <a:t>15</a:t>
+            </a:r>
+          </a:p>
+        </p:txBody>
+      </p:sp>
+      <p:sp>
+        <p:nvSpPr>
+          <p:cNvPr id="24" name="TextBox 23"/>
+          <p:cNvSpPr txBox="1"/>
+          <p:nvPr/>
+        </p:nvSpPr>
+        <p:spPr>
+          <a:xfrm>
+            <a:off x="9336023" y="2496312"/>
             <a:ext cx="2011680" cy="256032"/>
           </a:xfrm>
           <a:prstGeom prst="rect">
@@ -6195,20 +5240,20 @@
                 </a:solidFill>
                 <a:latin typeface="Calibri"/>
               </a:rPr>
-              <a:t>微服务模块</a:t>
-            </a:r>
-          </a:p>
-        </p:txBody>
-      </p:sp>
-      <p:sp>
-        <p:nvSpPr>
-          <p:cNvPr id="20" name="TextBox 19"/>
-          <p:cNvSpPr txBox="1"/>
-          <p:nvPr/>
-        </p:nvSpPr>
-        <p:spPr>
-          <a:xfrm>
-            <a:off x="6547104" y="2834640"/>
+              <a:t>后端测试类</a:t>
+            </a:r>
+          </a:p>
+        </p:txBody>
+      </p:sp>
+      <p:sp>
+        <p:nvSpPr>
+          <p:cNvPr id="25" name="TextBox 24"/>
+          <p:cNvSpPr txBox="1"/>
+          <p:nvPr/>
+        </p:nvSpPr>
+        <p:spPr>
+          <a:xfrm>
+            <a:off x="9336023" y="2834640"/>
             <a:ext cx="2011680" cy="192023"/>
           </a:xfrm>
           <a:prstGeom prst="rect">
@@ -6230,20 +5275,176 @@
                 </a:solidFill>
                 <a:latin typeface="Calibri"/>
               </a:rPr>
-              <a:t>common / model / client / user / app / ai / screenshot</a:t>
-            </a:r>
-          </a:p>
-        </p:txBody>
-      </p:sp>
-      <p:sp>
-        <p:nvSpPr>
-          <p:cNvPr id="21" name="Rounded Rectangle 20"/>
+              <a:t>覆盖 AI、解析、工作流、截图等重点</a:t>
+            </a:r>
+          </a:p>
+        </p:txBody>
+      </p:sp>
+      <p:sp>
+        <p:nvSpPr>
+          <p:cNvPr id="32" name="TextBox 31"/>
+          <p:cNvSpPr txBox="1"/>
+          <p:nvPr/>
+        </p:nvSpPr>
+        <p:spPr>
+          <a:xfrm>
+            <a:off x="658368" y="6473952"/>
+            <a:ext cx="4754880" cy="201168"/>
+          </a:xfrm>
+          <a:prstGeom prst="rect">
+            <a:avLst/>
+          </a:prstGeom>
+          <a:noFill/>
+        </p:spPr>
+        <p:txBody>
+          <a:bodyPr wrap="square" lIns="0" rIns="0" tIns="0" bIns="0" anchor="t">
+            <a:spAutoFit/>
+          </a:bodyPr>
+          <a:lstStyle/>
+          <a:p>
+            <a:pPr algn="l"/>
+            <a:r>
+              <a:rPr sz="950" b="0" i="0">
+                <a:solidFill>
+                  <a:srgbClr val="5B6B7A"/>
+                </a:solidFill>
+                <a:latin typeface="Calibri"/>
+              </a:rPr>
+              <a:t>yu-ai-code-mother · 每日项目状态 · 02</a:t>
+            </a:r>
+          </a:p>
+        </p:txBody>
+      </p:sp>
+      <p:sp>
+        <p:nvSpPr>
+          <p:cNvPr id="33" name="Rounded Rectangle 32"/>
           <p:cNvSpPr/>
           <p:nvPr/>
         </p:nvSpPr>
         <p:spPr>
           <a:xfrm>
-            <a:off x="9079991" y="1810512"/>
+            <a:off x="10908792" y="6428232"/>
+            <a:ext cx="612648" cy="128016"/>
+          </a:xfrm>
+          <a:prstGeom prst="roundRect">
+            <a:avLst/>
+          </a:prstGeom>
+          <a:solidFill>
+            <a:srgbClr val="02C39A"/>
+          </a:solidFill>
+          <a:ln>
+            <a:noFill/>
+          </a:ln>
+        </p:spPr>
+        <p:style>
+          <a:lnRef idx="1">
+            <a:schemeClr val="accent1"/>
+          </a:lnRef>
+          <a:fillRef idx="3">
+            <a:schemeClr val="accent1"/>
+          </a:fillRef>
+          <a:effectRef idx="2">
+            <a:schemeClr val="accent1"/>
+          </a:effectRef>
+          <a:fontRef idx="minor">
+            <a:schemeClr val="lt1"/>
+          </a:fontRef>
+        </p:style>
+        <p:txBody>
+          <a:bodyPr rtlCol="0" anchor="ctr"/>
+          <a:lstStyle/>
+          <a:p>
+            <a:pPr algn="ctr"/>
+          </a:p>
+        </p:txBody>
+      </p:sp>
+      <p:sp>
+        <p:nvSpPr>
+          <p:cNvPr id="34" name="TextBox 33"/>
+          <p:cNvSpPr txBox="1"/>
+          <p:nvPr/>
+        </p:nvSpPr>
+        <p:spPr>
+          <a:xfrm>
+            <a:off x="11594592" y="6345936"/>
+            <a:ext cx="228600" cy="256032"/>
+          </a:xfrm>
+          <a:prstGeom prst="rect">
+            <a:avLst/>
+          </a:prstGeom>
+          <a:noFill/>
+        </p:spPr>
+        <p:txBody>
+          <a:bodyPr wrap="square" lIns="0" rIns="0" tIns="0" bIns="0" anchor="t">
+            <a:spAutoFit/>
+          </a:bodyPr>
+          <a:lstStyle/>
+          <a:p>
+            <a:pPr algn="r"/>
+            <a:r>
+              <a:rPr sz="1000" b="0" i="0">
+                <a:solidFill>
+                  <a:srgbClr val="5B6B7A"/>
+                </a:solidFill>
+                <a:latin typeface="Calibri"/>
+              </a:rPr>
+              <a:t>2</a:t>
+            </a:r>
+          </a:p>
+        </p:txBody>
+      </p:sp>
+      <p:sp>
+        <p:nvSpPr>
+          <p:cNvPr id="59" name="Rectangle 58"/>
+          <p:cNvSpPr/>
+          <p:nvPr/>
+        </p:nvSpPr>
+        <p:spPr>
+          <a:xfrm>
+            <a:off x="6144768" y="1691640"/>
+            <a:ext cx="2788920" cy="1600200"/>
+          </a:xfrm>
+          <a:prstGeom prst="rect">
+            <a:avLst/>
+          </a:prstGeom>
+          <a:solidFill>
+            <a:srgbClr val="F6FBFC"/>
+          </a:solidFill>
+          <a:ln>
+            <a:noFill/>
+          </a:ln>
+        </p:spPr>
+        <p:style>
+          <a:lnRef idx="1">
+            <a:schemeClr val="accent1"/>
+          </a:lnRef>
+          <a:fillRef idx="3">
+            <a:schemeClr val="accent1"/>
+          </a:fillRef>
+          <a:effectRef idx="2">
+            <a:schemeClr val="accent1"/>
+          </a:effectRef>
+          <a:fontRef idx="minor">
+            <a:schemeClr val="lt1"/>
+          </a:fontRef>
+        </p:style>
+        <p:txBody>
+          <a:bodyPr rtlCol="0" anchor="ctr"/>
+          <a:lstStyle/>
+          <a:p>
+            <a:pPr algn="ctr"/>
+          </a:p>
+        </p:txBody>
+      </p:sp>
+      <p:sp>
+        <p:nvSpPr>
+          <p:cNvPr id="60" name="Rounded Rectangle 59"/>
+          <p:cNvSpPr/>
+          <p:nvPr/>
+        </p:nvSpPr>
+        <p:spPr>
+          <a:xfrm>
+            <a:off x="6291072" y="1810512"/>
             <a:ext cx="2487168" cy="1325880"/>
           </a:xfrm>
           <a:prstGeom prst="roundRect">
@@ -6257,7 +5458,6 @@
               <a:srgbClr val="DCEBED"/>
             </a:solidFill>
           </a:ln>
-          <a:effectLst/>
         </p:spPr>
         <p:style>
           <a:lnRef idx="1">
@@ -6283,20 +5483,20 @@
       </p:sp>
       <p:sp>
         <p:nvSpPr>
-          <p:cNvPr id="22" name="Rounded Rectangle 21"/>
+          <p:cNvPr id="61" name="Rounded Rectangle 60"/>
           <p:cNvSpPr/>
           <p:nvPr/>
         </p:nvSpPr>
         <p:spPr>
           <a:xfrm>
-            <a:off x="9079991" y="1810512"/>
+            <a:off x="6291072" y="1810512"/>
             <a:ext cx="109728" cy="1325880"/>
           </a:xfrm>
           <a:prstGeom prst="roundRect">
             <a:avLst/>
           </a:prstGeom>
           <a:solidFill>
-            <a:srgbClr val="F6A94A"/>
+            <a:srgbClr val="00A896"/>
           </a:solidFill>
           <a:ln>
             <a:noFill/>
@@ -6326,14 +5526,14 @@
       </p:sp>
       <p:sp>
         <p:nvSpPr>
-          <p:cNvPr id="23" name="TextBox 22"/>
-          <p:cNvSpPr txBox="1"/>
-          <p:nvPr/>
-        </p:nvSpPr>
-        <p:spPr>
-          <a:xfrm>
-            <a:off x="9336023" y="2011680"/>
-            <a:ext cx="2011680" cy="420624"/>
+          <p:cNvPr id="62" name="TextBox 61"/>
+          <p:cNvSpPr txBox="1"/>
+          <p:nvPr/>
+        </p:nvSpPr>
+        <p:spPr>
+          <a:xfrm>
+            <a:off x="6565392" y="1993392"/>
+            <a:ext cx="1463040" cy="310896"/>
           </a:xfrm>
           <a:prstGeom prst="rect">
             <a:avLst/>
@@ -6348,27 +5548,27 @@
           <a:p>
             <a:pPr algn="l"/>
             <a:r>
-              <a:rPr sz="2800" b="1" i="0">
-                <a:solidFill>
-                  <a:srgbClr val="F6A94A"/>
+              <a:rPr sz="2800" b="1">
+                <a:solidFill>
+                  <a:srgbClr val="00A896"/>
                 </a:solidFill>
                 <a:latin typeface="Georgia"/>
               </a:rPr>
-              <a:t>15</a:t>
-            </a:r>
-          </a:p>
-        </p:txBody>
-      </p:sp>
-      <p:sp>
-        <p:nvSpPr>
-          <p:cNvPr id="24" name="TextBox 23"/>
-          <p:cNvSpPr txBox="1"/>
-          <p:nvPr/>
-        </p:nvSpPr>
-        <p:spPr>
-          <a:xfrm>
-            <a:off x="9336023" y="2496312"/>
-            <a:ext cx="2011680" cy="256032"/>
+              <a:t>7</a:t>
+            </a:r>
+          </a:p>
+        </p:txBody>
+      </p:sp>
+      <p:sp>
+        <p:nvSpPr>
+          <p:cNvPr id="63" name="TextBox 62"/>
+          <p:cNvSpPr txBox="1"/>
+          <p:nvPr/>
+        </p:nvSpPr>
+        <p:spPr>
+          <a:xfrm>
+            <a:off x="6565392" y="2487168"/>
+            <a:ext cx="1280160" cy="164592"/>
           </a:xfrm>
           <a:prstGeom prst="rect">
             <a:avLst/>
@@ -6383,27 +5583,27 @@
           <a:p>
             <a:pPr algn="l"/>
             <a:r>
-              <a:rPr sz="1250" b="1" i="0">
+              <a:rPr sz="1250" b="1">
                 <a:solidFill>
                   <a:srgbClr val="5B6B7A"/>
                 </a:solidFill>
                 <a:latin typeface="Calibri"/>
               </a:rPr>
-              <a:t>后端测试类</a:t>
-            </a:r>
-          </a:p>
-        </p:txBody>
-      </p:sp>
-      <p:sp>
-        <p:nvSpPr>
-          <p:cNvPr id="25" name="TextBox 24"/>
-          <p:cNvSpPr txBox="1"/>
-          <p:nvPr/>
-        </p:nvSpPr>
-        <p:spPr>
-          <a:xfrm>
-            <a:off x="9336023" y="2834640"/>
-            <a:ext cx="2011680" cy="192023"/>
+              <a:t>微服务模块</a:t>
+            </a:r>
+          </a:p>
+        </p:txBody>
+      </p:sp>
+      <p:sp>
+        <p:nvSpPr>
+          <p:cNvPr id="64" name="TextBox 63"/>
+          <p:cNvSpPr txBox="1"/>
+          <p:nvPr/>
+        </p:nvSpPr>
+        <p:spPr>
+          <a:xfrm>
+            <a:off x="6565392" y="2807208"/>
+            <a:ext cx="1874519" cy="329184"/>
           </a:xfrm>
           <a:prstGeom prst="rect">
             <a:avLst/>
@@ -6418,29 +5618,30 @@
           <a:p>
             <a:pPr algn="l"/>
             <a:r>
-              <a:rPr sz="1150" b="0" i="0">
+              <a:rPr sz="919" b="0">
                 <a:solidFill>
                   <a:srgbClr val="17324D"/>
                 </a:solidFill>
                 <a:latin typeface="Calibri"/>
               </a:rPr>
-              <a:t>覆盖 AI、解析、工作流、截图等重点</a:t>
-            </a:r>
-          </a:p>
-        </p:txBody>
-      </p:sp>
-      <p:sp>
-        <p:nvSpPr>
-          <p:cNvPr id="26" name="Rounded Rectangle 25"/>
+              <a:t>common / model / client / user
+app / ai / screenshot</a:t>
+            </a:r>
+          </a:p>
+        </p:txBody>
+      </p:sp>
+      <p:sp>
+        <p:nvSpPr>
+          <p:cNvPr id="65" name="Rectangle 64"/>
           <p:cNvSpPr/>
           <p:nvPr/>
         </p:nvSpPr>
         <p:spPr>
           <a:xfrm>
             <a:off x="713232" y="3493008"/>
-            <a:ext cx="5303520" cy="2176272"/>
-          </a:xfrm>
-          <a:prstGeom prst="roundRect">
+            <a:ext cx="5349240" cy="2176272"/>
+          </a:xfrm>
+          <a:prstGeom prst="rect">
             <a:avLst/>
           </a:prstGeom>
           <a:solidFill>
@@ -6474,638 +5675,7 @@
       </p:sp>
       <p:sp>
         <p:nvSpPr>
-          <p:cNvPr id="27" name="TextBox 26"/>
-          <p:cNvSpPr txBox="1"/>
-          <p:nvPr/>
-        </p:nvSpPr>
-        <p:spPr>
-          <a:xfrm>
-            <a:off x="1024128" y="3730752"/>
-            <a:ext cx="1097280" cy="256032"/>
-          </a:xfrm>
-          <a:prstGeom prst="rect">
-            <a:avLst/>
-          </a:prstGeom>
-          <a:noFill/>
-        </p:spPr>
-        <p:txBody>
-          <a:bodyPr wrap="square" lIns="0" rIns="0" tIns="0" bIns="0" anchor="t">
-            <a:spAutoFit/>
-          </a:bodyPr>
-          <a:lstStyle/>
-          <a:p>
-            <a:pPr algn="l"/>
-            <a:r>
-              <a:rPr sz="1800" b="1" i="0">
-                <a:solidFill>
-                  <a:srgbClr val="065A82"/>
-                </a:solidFill>
-                <a:latin typeface="Georgia"/>
-              </a:rPr>
-              <a:t>定位</a:t>
-            </a:r>
-          </a:p>
-        </p:txBody>
-      </p:sp>
-      <p:sp>
-        <p:nvSpPr>
-          <p:cNvPr id="28" name="TextBox 27"/>
-          <p:cNvSpPr txBox="1"/>
-          <p:nvPr/>
-        </p:nvSpPr>
-        <p:spPr>
-          <a:xfrm>
-            <a:off x="960120" y="4096512"/>
-            <a:ext cx="4617720" cy="1078992"/>
-          </a:xfrm>
-          <a:prstGeom prst="rect">
-            <a:avLst/>
-          </a:prstGeom>
-          <a:noFill/>
-        </p:spPr>
-        <p:txBody>
-          <a:bodyPr wrap="square" lIns="73152" rIns="73152" tIns="36576" bIns="36576">
-            <a:spAutoFit/>
-          </a:bodyPr>
-          <a:lstStyle/>
-          <a:p>
-            <a:pPr>
-              <a:buChar char="•"/>
-              <a:lnSpc>
-                <a:spcPct val="103000"/>
-              </a:lnSpc>
-              <a:spcAft>
-                <a:spcPts val="0"/>
-              </a:spcAft>
-              <a:defRPr sz="1430">
-                <a:solidFill>
-                  <a:srgbClr val="17324D"/>
-                </a:solidFill>
-                <a:latin typeface="Calibri"/>
-              </a:defRPr>
-            </a:pPr>
-            <a:r>
-              <a:t>面向用户提示词的 AI 应用/网站生成平台。</a:t>
-            </a:r>
-          </a:p>
-          <a:p>
-            <a:pPr>
-              <a:buChar char="•"/>
-              <a:lnSpc>
-                <a:spcPct val="103000"/>
-              </a:lnSpc>
-              <a:spcAft>
-                <a:spcPts val="0"/>
-              </a:spcAft>
-              <a:defRPr sz="1430">
-                <a:solidFill>
-                  <a:srgbClr val="17324D"/>
-                </a:solidFill>
-                <a:latin typeface="Calibri"/>
-              </a:defRPr>
-            </a:pPr>
-            <a:r>
-              <a:t>支持代码生成、实时预览、部署分享、源码下载与管理后台。</a:t>
-            </a:r>
-          </a:p>
-          <a:p>
-            <a:pPr>
-              <a:buChar char="•"/>
-              <a:lnSpc>
-                <a:spcPct val="103000"/>
-              </a:lnSpc>
-              <a:spcAft>
-                <a:spcPts val="0"/>
-              </a:spcAft>
-              <a:defRPr sz="1430">
-                <a:solidFill>
-                  <a:srgbClr val="17324D"/>
-                </a:solidFill>
-                <a:latin typeface="Calibri"/>
-              </a:defRPr>
-            </a:pPr>
-            <a:r>
-              <a:t>技术主线覆盖 AI 智能体、工作流、流式输出与企业级后端架构。</a:t>
-            </a:r>
-          </a:p>
-        </p:txBody>
-      </p:sp>
-      <p:sp>
-        <p:nvSpPr>
-          <p:cNvPr id="29" name="Rounded Rectangle 28"/>
-          <p:cNvSpPr/>
-          <p:nvPr/>
-        </p:nvSpPr>
-        <p:spPr>
-          <a:xfrm>
-            <a:off x="6309360" y="3493008"/>
-            <a:ext cx="5166360" cy="2176272"/>
-          </a:xfrm>
-          <a:prstGeom prst="roundRect">
-            <a:avLst/>
-          </a:prstGeom>
-          <a:solidFill>
-            <a:srgbClr val="FFFFFF"/>
-          </a:solidFill>
-          <a:ln>
-            <a:solidFill>
-              <a:srgbClr val="CCE8EA"/>
-            </a:solidFill>
-          </a:ln>
-        </p:spPr>
-        <p:style>
-          <a:lnRef idx="1">
-            <a:schemeClr val="accent1"/>
-          </a:lnRef>
-          <a:fillRef idx="3">
-            <a:schemeClr val="accent1"/>
-          </a:fillRef>
-          <a:effectRef idx="2">
-            <a:schemeClr val="accent1"/>
-          </a:effectRef>
-          <a:fontRef idx="minor">
-            <a:schemeClr val="lt1"/>
-          </a:fontRef>
-        </p:style>
-        <p:txBody>
-          <a:bodyPr rtlCol="0" anchor="ctr"/>
-          <a:lstStyle/>
-          <a:p>
-            <a:pPr algn="ctr"/>
-          </a:p>
-        </p:txBody>
-      </p:sp>
-      <p:sp>
-        <p:nvSpPr>
-          <p:cNvPr id="30" name="TextBox 29"/>
-          <p:cNvSpPr txBox="1"/>
-          <p:nvPr/>
-        </p:nvSpPr>
-        <p:spPr>
-          <a:xfrm>
-            <a:off x="6629400" y="3730752"/>
-            <a:ext cx="2194560" cy="256032"/>
-          </a:xfrm>
-          <a:prstGeom prst="rect">
-            <a:avLst/>
-          </a:prstGeom>
-          <a:noFill/>
-        </p:spPr>
-        <p:txBody>
-          <a:bodyPr wrap="square" lIns="0" rIns="0" tIns="0" bIns="0" anchor="t">
-            <a:spAutoFit/>
-          </a:bodyPr>
-          <a:lstStyle/>
-          <a:p>
-            <a:pPr algn="l"/>
-            <a:r>
-              <a:rPr sz="1800" b="1" i="0">
-                <a:solidFill>
-                  <a:srgbClr val="065A82"/>
-                </a:solidFill>
-                <a:latin typeface="Georgia"/>
-              </a:rPr>
-              <a:t>当前工程形态</a:t>
-            </a:r>
-          </a:p>
-        </p:txBody>
-      </p:sp>
-      <p:sp>
-        <p:nvSpPr>
-          <p:cNvPr id="31" name="TextBox 30"/>
-          <p:cNvSpPr txBox="1"/>
-          <p:nvPr/>
-        </p:nvSpPr>
-        <p:spPr>
-          <a:xfrm>
-            <a:off x="6565392" y="4096512"/>
-            <a:ext cx="4572000" cy="1078992"/>
-          </a:xfrm>
-          <a:prstGeom prst="rect">
-            <a:avLst/>
-          </a:prstGeom>
-          <a:noFill/>
-        </p:spPr>
-        <p:txBody>
-          <a:bodyPr wrap="square" lIns="73152" rIns="73152" tIns="36576" bIns="36576">
-            <a:spAutoFit/>
-          </a:bodyPr>
-          <a:lstStyle/>
-          <a:p>
-            <a:pPr>
-              <a:buChar char="•"/>
-              <a:lnSpc>
-                <a:spcPct val="103000"/>
-              </a:lnSpc>
-              <a:spcAft>
-                <a:spcPts val="0"/>
-              </a:spcAft>
-              <a:defRPr sz="1430">
-                <a:solidFill>
-                  <a:srgbClr val="17324D"/>
-                </a:solidFill>
-                <a:latin typeface="Calibri"/>
-              </a:defRPr>
-            </a:pPr>
-            <a:r>
-              <a:t>根目录保留单体 Spring Boot 项目，微服务目录已完成模块拆分。</a:t>
-            </a:r>
-          </a:p>
-          <a:p>
-            <a:pPr>
-              <a:buChar char="•"/>
-              <a:lnSpc>
-                <a:spcPct val="103000"/>
-              </a:lnSpc>
-              <a:spcAft>
-                <a:spcPts val="0"/>
-              </a:spcAft>
-              <a:defRPr sz="1430">
-                <a:solidFill>
-                  <a:srgbClr val="17324D"/>
-                </a:solidFill>
-                <a:latin typeface="Calibri"/>
-              </a:defRPr>
-            </a:pPr>
-            <a:r>
-              <a:t>前端单独维护，采用 Vue 3 + TypeScript + Ant Design Vue + Vite。</a:t>
-            </a:r>
-          </a:p>
-          <a:p>
-            <a:pPr>
-              <a:buChar char="•"/>
-              <a:lnSpc>
-                <a:spcPct val="103000"/>
-              </a:lnSpc>
-              <a:spcAft>
-                <a:spcPts val="0"/>
-              </a:spcAft>
-              <a:defRPr sz="1430">
-                <a:solidFill>
-                  <a:srgbClr val="17324D"/>
-                </a:solidFill>
-                <a:latin typeface="Calibri"/>
-              </a:defRPr>
-            </a:pPr>
-            <a:r>
-              <a:t>监控配置包含 Actuator / Prometheus / Grafana 相关资产。</a:t>
-            </a:r>
-          </a:p>
-        </p:txBody>
-      </p:sp>
-      <p:sp>
-        <p:nvSpPr>
-          <p:cNvPr id="32" name="TextBox 31"/>
-          <p:cNvSpPr txBox="1"/>
-          <p:nvPr/>
-        </p:nvSpPr>
-        <p:spPr>
-          <a:xfrm>
-            <a:off x="658368" y="6473952"/>
-            <a:ext cx="4754880" cy="201168"/>
-          </a:xfrm>
-          <a:prstGeom prst="rect">
-            <a:avLst/>
-          </a:prstGeom>
-          <a:noFill/>
-        </p:spPr>
-        <p:txBody>
-          <a:bodyPr wrap="square" lIns="0" rIns="0" tIns="0" bIns="0" anchor="t">
-            <a:spAutoFit/>
-          </a:bodyPr>
-          <a:lstStyle/>
-          <a:p>
-            <a:pPr algn="l"/>
-            <a:r>
-              <a:rPr sz="950" b="0" i="0">
-                <a:solidFill>
-                  <a:srgbClr val="5B6B7A"/>
-                </a:solidFill>
-                <a:latin typeface="Calibri"/>
-              </a:rPr>
-              <a:t>yu-ai-code-mother · 每日项目状态 · 02</a:t>
-            </a:r>
-          </a:p>
-        </p:txBody>
-      </p:sp>
-      <p:sp>
-        <p:nvSpPr>
-          <p:cNvPr id="33" name="Rounded Rectangle 32"/>
-          <p:cNvSpPr/>
-          <p:nvPr/>
-        </p:nvSpPr>
-        <p:spPr>
-          <a:xfrm>
-            <a:off x="10908792" y="6428232"/>
-            <a:ext cx="612648" cy="128016"/>
-          </a:xfrm>
-          <a:prstGeom prst="roundRect">
-            <a:avLst/>
-          </a:prstGeom>
-          <a:solidFill>
-            <a:srgbClr val="02C39A"/>
-          </a:solidFill>
-          <a:ln>
-            <a:noFill/>
-          </a:ln>
-        </p:spPr>
-        <p:style>
-          <a:lnRef idx="1">
-            <a:schemeClr val="accent1"/>
-          </a:lnRef>
-          <a:fillRef idx="3">
-            <a:schemeClr val="accent1"/>
-          </a:fillRef>
-          <a:effectRef idx="2">
-            <a:schemeClr val="accent1"/>
-          </a:effectRef>
-          <a:fontRef idx="minor">
-            <a:schemeClr val="lt1"/>
-          </a:fontRef>
-        </p:style>
-        <p:txBody>
-          <a:bodyPr rtlCol="0" anchor="ctr"/>
-          <a:lstStyle/>
-          <a:p>
-            <a:pPr algn="ctr"/>
-          </a:p>
-        </p:txBody>
-      </p:sp>
-      <p:sp>
-        <p:nvSpPr>
-          <p:cNvPr id="34" name="TextBox 33"/>
-          <p:cNvSpPr txBox="1"/>
-          <p:nvPr/>
-        </p:nvSpPr>
-        <p:spPr>
-          <a:xfrm>
-            <a:off x="11594592" y="6345936"/>
-            <a:ext cx="228600" cy="256032"/>
-          </a:xfrm>
-          <a:prstGeom prst="rect">
-            <a:avLst/>
-          </a:prstGeom>
-          <a:noFill/>
-        </p:spPr>
-        <p:txBody>
-          <a:bodyPr wrap="square" lIns="0" rIns="0" tIns="0" bIns="0" anchor="t">
-            <a:spAutoFit/>
-          </a:bodyPr>
-          <a:lstStyle/>
-          <a:p>
-            <a:pPr algn="r"/>
-            <a:r>
-              <a:rPr sz="1000" b="0" i="0">
-                <a:solidFill>
-                  <a:srgbClr val="5B6B7A"/>
-                </a:solidFill>
-                <a:latin typeface="Calibri"/>
-              </a:rPr>
-              <a:t>2</a:t>
-            </a:r>
-          </a:p>
-        </p:txBody>
-      </p:sp>
-      <p:sp>
-        <p:nvSpPr>
-          <p:cNvPr id="35" name="Rectangle 34"/>
-          <p:cNvSpPr/>
-          <p:nvPr/>
-        </p:nvSpPr>
-        <p:spPr>
-          <a:xfrm>
-            <a:off x="6199632" y="1719072"/>
-            <a:ext cx="2697480" cy="1508760"/>
-          </a:xfrm>
-          <a:prstGeom prst="rect">
-            <a:avLst/>
-          </a:prstGeom>
-          <a:solidFill>
-            <a:srgbClr val="F6FBFC"/>
-          </a:solidFill>
-          <a:ln>
-            <a:noFill/>
-          </a:ln>
-        </p:spPr>
-        <p:style>
-          <a:lnRef idx="1">
-            <a:schemeClr val="accent1"/>
-          </a:lnRef>
-          <a:fillRef idx="3">
-            <a:schemeClr val="accent1"/>
-          </a:fillRef>
-          <a:effectRef idx="2">
-            <a:schemeClr val="accent1"/>
-          </a:effectRef>
-          <a:fontRef idx="minor">
-            <a:schemeClr val="lt1"/>
-          </a:fontRef>
-        </p:style>
-        <p:txBody>
-          <a:bodyPr rtlCol="0" anchor="ctr"/>
-          <a:lstStyle/>
-          <a:p>
-            <a:pPr algn="ctr"/>
-          </a:p>
-        </p:txBody>
-      </p:sp>
-      <p:sp>
-        <p:nvSpPr>
-          <p:cNvPr id="36" name="Rounded Rectangle 35"/>
-          <p:cNvSpPr/>
-          <p:nvPr/>
-        </p:nvSpPr>
-        <p:spPr>
-          <a:xfrm>
-            <a:off x="6291072" y="1810512"/>
-            <a:ext cx="2487168" cy="1325880"/>
-          </a:xfrm>
-          <a:prstGeom prst="roundRect">
-            <a:avLst/>
-          </a:prstGeom>
-          <a:solidFill>
-            <a:srgbClr val="FFFFFF"/>
-          </a:solidFill>
-          <a:ln w="12700">
-            <a:solidFill>
-              <a:srgbClr val="DCEBED"/>
-            </a:solidFill>
-          </a:ln>
-        </p:spPr>
-        <p:style>
-          <a:lnRef idx="1">
-            <a:schemeClr val="accent1"/>
-          </a:lnRef>
-          <a:fillRef idx="3">
-            <a:schemeClr val="accent1"/>
-          </a:fillRef>
-          <a:effectRef idx="2">
-            <a:schemeClr val="accent1"/>
-          </a:effectRef>
-          <a:fontRef idx="minor">
-            <a:schemeClr val="lt1"/>
-          </a:fontRef>
-        </p:style>
-        <p:txBody>
-          <a:bodyPr rtlCol="0" anchor="ctr"/>
-          <a:lstStyle/>
-          <a:p>
-            <a:pPr algn="ctr"/>
-          </a:p>
-        </p:txBody>
-      </p:sp>
-      <p:sp>
-        <p:nvSpPr>
-          <p:cNvPr id="37" name="Rounded Rectangle 36"/>
-          <p:cNvSpPr/>
-          <p:nvPr/>
-        </p:nvSpPr>
-        <p:spPr>
-          <a:xfrm>
-            <a:off x="6291072" y="1810512"/>
-            <a:ext cx="109728" cy="1325880"/>
-          </a:xfrm>
-          <a:prstGeom prst="roundRect">
-            <a:avLst/>
-          </a:prstGeom>
-          <a:solidFill>
-            <a:srgbClr val="00A896"/>
-          </a:solidFill>
-          <a:ln>
-            <a:noFill/>
-          </a:ln>
-        </p:spPr>
-        <p:style>
-          <a:lnRef idx="1">
-            <a:schemeClr val="accent1"/>
-          </a:lnRef>
-          <a:fillRef idx="3">
-            <a:schemeClr val="accent1"/>
-          </a:fillRef>
-          <a:effectRef idx="2">
-            <a:schemeClr val="accent1"/>
-          </a:effectRef>
-          <a:fontRef idx="minor">
-            <a:schemeClr val="lt1"/>
-          </a:fontRef>
-        </p:style>
-        <p:txBody>
-          <a:bodyPr rtlCol="0" anchor="ctr"/>
-          <a:lstStyle/>
-          <a:p>
-            <a:pPr algn="ctr"/>
-          </a:p>
-        </p:txBody>
-      </p:sp>
-      <p:sp>
-        <p:nvSpPr>
-          <p:cNvPr id="38" name="TextBox 37"/>
-          <p:cNvSpPr txBox="1"/>
-          <p:nvPr/>
-        </p:nvSpPr>
-        <p:spPr>
-          <a:xfrm>
-            <a:off x="6565392" y="1993392"/>
-            <a:ext cx="1463040" cy="310896"/>
-          </a:xfrm>
-          <a:prstGeom prst="rect">
-            <a:avLst/>
-          </a:prstGeom>
-          <a:noFill/>
-        </p:spPr>
-        <p:txBody>
-          <a:bodyPr wrap="square" lIns="0" rIns="0" tIns="0" bIns="0" anchor="t">
-            <a:spAutoFit/>
-          </a:bodyPr>
-          <a:lstStyle/>
-          <a:p>
-            <a:pPr algn="l"/>
-            <a:r>
-              <a:rPr sz="2800" b="1">
-                <a:solidFill>
-                  <a:srgbClr val="00A896"/>
-                </a:solidFill>
-                <a:latin typeface="Georgia"/>
-              </a:rPr>
-              <a:t>7</a:t>
-            </a:r>
-          </a:p>
-        </p:txBody>
-      </p:sp>
-      <p:sp>
-        <p:nvSpPr>
-          <p:cNvPr id="39" name="TextBox 38"/>
-          <p:cNvSpPr txBox="1"/>
-          <p:nvPr/>
-        </p:nvSpPr>
-        <p:spPr>
-          <a:xfrm>
-            <a:off x="6565392" y="2487168"/>
-            <a:ext cx="1280160" cy="164592"/>
-          </a:xfrm>
-          <a:prstGeom prst="rect">
-            <a:avLst/>
-          </a:prstGeom>
-          <a:noFill/>
-        </p:spPr>
-        <p:txBody>
-          <a:bodyPr wrap="square" lIns="0" rIns="0" tIns="0" bIns="0" anchor="t">
-            <a:spAutoFit/>
-          </a:bodyPr>
-          <a:lstStyle/>
-          <a:p>
-            <a:pPr algn="l"/>
-            <a:r>
-              <a:rPr sz="1250" b="1">
-                <a:solidFill>
-                  <a:srgbClr val="5B6B7A"/>
-                </a:solidFill>
-                <a:latin typeface="Calibri"/>
-              </a:rPr>
-              <a:t>微服务模块</a:t>
-            </a:r>
-          </a:p>
-        </p:txBody>
-      </p:sp>
-      <p:sp>
-        <p:nvSpPr>
-          <p:cNvPr id="40" name="TextBox 39"/>
-          <p:cNvSpPr txBox="1"/>
-          <p:nvPr/>
-        </p:nvSpPr>
-        <p:spPr>
-          <a:xfrm>
-            <a:off x="6565392" y="2807208"/>
-            <a:ext cx="1874519" cy="329184"/>
-          </a:xfrm>
-          <a:prstGeom prst="rect">
-            <a:avLst/>
-          </a:prstGeom>
-          <a:noFill/>
-        </p:spPr>
-        <p:txBody>
-          <a:bodyPr wrap="square" lIns="0" rIns="0" tIns="0" bIns="0" anchor="t">
-            <a:spAutoFit/>
-          </a:bodyPr>
-          <a:lstStyle/>
-          <a:p>
-            <a:pPr algn="l"/>
-            <a:r>
-              <a:rPr sz="919" b="0">
-                <a:solidFill>
-                  <a:srgbClr val="17324D"/>
-                </a:solidFill>
-                <a:latin typeface="Calibri"/>
-              </a:rPr>
-              <a:t>common / model / client / user
-app / ai / screenshot</a:t>
-            </a:r>
-          </a:p>
-        </p:txBody>
-      </p:sp>
-      <p:sp>
-        <p:nvSpPr>
-          <p:cNvPr id="41" name="Rectangle 40"/>
+          <p:cNvPr id="66" name="Rounded Rectangle 65"/>
           <p:cNvSpPr/>
           <p:nvPr/>
         </p:nvSpPr>
@@ -7114,7 +5684,7 @@
             <a:off x="713232" y="3493008"/>
             <a:ext cx="5349240" cy="2176272"/>
           </a:xfrm>
-          <a:prstGeom prst="rect">
+          <a:prstGeom prst="roundRect">
             <a:avLst/>
           </a:prstGeom>
           <a:solidFill>
@@ -7148,50 +5718,7 @@
       </p:sp>
       <p:sp>
         <p:nvSpPr>
-          <p:cNvPr id="42" name="Rounded Rectangle 41"/>
-          <p:cNvSpPr/>
-          <p:nvPr/>
-        </p:nvSpPr>
-        <p:spPr>
-          <a:xfrm>
-            <a:off x="713232" y="3493008"/>
-            <a:ext cx="5349240" cy="2176272"/>
-          </a:xfrm>
-          <a:prstGeom prst="roundRect">
-            <a:avLst/>
-          </a:prstGeom>
-          <a:solidFill>
-            <a:srgbClr val="E7F3F8"/>
-          </a:solidFill>
-          <a:ln>
-            <a:noFill/>
-          </a:ln>
-        </p:spPr>
-        <p:style>
-          <a:lnRef idx="1">
-            <a:schemeClr val="accent1"/>
-          </a:lnRef>
-          <a:fillRef idx="3">
-            <a:schemeClr val="accent1"/>
-          </a:fillRef>
-          <a:effectRef idx="2">
-            <a:schemeClr val="accent1"/>
-          </a:effectRef>
-          <a:fontRef idx="minor">
-            <a:schemeClr val="lt1"/>
-          </a:fontRef>
-        </p:style>
-        <p:txBody>
-          <a:bodyPr rtlCol="0" anchor="ctr"/>
-          <a:lstStyle/>
-          <a:p>
-            <a:pPr algn="ctr"/>
-          </a:p>
-        </p:txBody>
-      </p:sp>
-      <p:sp>
-        <p:nvSpPr>
-          <p:cNvPr id="43" name="TextBox 42"/>
+          <p:cNvPr id="67" name="TextBox 66"/>
           <p:cNvSpPr txBox="1"/>
           <p:nvPr/>
         </p:nvSpPr>
@@ -7226,7 +5753,7 @@
       </p:sp>
       <p:sp>
         <p:nvSpPr>
-          <p:cNvPr id="44" name="Oval 43"/>
+          <p:cNvPr id="68" name="Oval 67"/>
           <p:cNvSpPr/>
           <p:nvPr/>
         </p:nvSpPr>
@@ -7269,7 +5796,7 @@
       </p:sp>
       <p:sp>
         <p:nvSpPr>
-          <p:cNvPr id="45" name="TextBox 44"/>
+          <p:cNvPr id="69" name="TextBox 68"/>
           <p:cNvSpPr txBox="1"/>
           <p:nvPr/>
         </p:nvSpPr>
@@ -7304,7 +5831,7 @@
       </p:sp>
       <p:sp>
         <p:nvSpPr>
-          <p:cNvPr id="46" name="Oval 45"/>
+          <p:cNvPr id="70" name="Oval 69"/>
           <p:cNvSpPr/>
           <p:nvPr/>
         </p:nvSpPr>
@@ -7347,7 +5874,7 @@
       </p:sp>
       <p:sp>
         <p:nvSpPr>
-          <p:cNvPr id="47" name="TextBox 46"/>
+          <p:cNvPr id="71" name="TextBox 70"/>
           <p:cNvSpPr txBox="1"/>
           <p:nvPr/>
         </p:nvSpPr>
@@ -7382,7 +5909,7 @@
       </p:sp>
       <p:sp>
         <p:nvSpPr>
-          <p:cNvPr id="48" name="Oval 47"/>
+          <p:cNvPr id="72" name="Oval 71"/>
           <p:cNvSpPr/>
           <p:nvPr/>
         </p:nvSpPr>
@@ -7425,7 +5952,7 @@
       </p:sp>
       <p:sp>
         <p:nvSpPr>
-          <p:cNvPr id="49" name="TextBox 48"/>
+          <p:cNvPr id="73" name="TextBox 72"/>
           <p:cNvSpPr txBox="1"/>
           <p:nvPr/>
         </p:nvSpPr>
@@ -7460,7 +5987,7 @@
       </p:sp>
       <p:sp>
         <p:nvSpPr>
-          <p:cNvPr id="50" name="Rectangle 49"/>
+          <p:cNvPr id="74" name="Rectangle 73"/>
           <p:cNvSpPr/>
           <p:nvPr/>
         </p:nvSpPr>
@@ -7503,7 +6030,7 @@
       </p:sp>
       <p:sp>
         <p:nvSpPr>
-          <p:cNvPr id="51" name="Rounded Rectangle 50"/>
+          <p:cNvPr id="75" name="Rounded Rectangle 74"/>
           <p:cNvSpPr/>
           <p:nvPr/>
         </p:nvSpPr>
@@ -7548,7 +6075,7 @@
       </p:sp>
       <p:sp>
         <p:nvSpPr>
-          <p:cNvPr id="52" name="TextBox 51"/>
+          <p:cNvPr id="76" name="TextBox 75"/>
           <p:cNvSpPr txBox="1"/>
           <p:nvPr/>
         </p:nvSpPr>
@@ -7583,7 +6110,7 @@
       </p:sp>
       <p:sp>
         <p:nvSpPr>
-          <p:cNvPr id="53" name="Oval 52"/>
+          <p:cNvPr id="77" name="Oval 76"/>
           <p:cNvSpPr/>
           <p:nvPr/>
         </p:nvSpPr>
@@ -7626,7 +6153,7 @@
       </p:sp>
       <p:sp>
         <p:nvSpPr>
-          <p:cNvPr id="54" name="TextBox 53"/>
+          <p:cNvPr id="78" name="TextBox 77"/>
           <p:cNvSpPr txBox="1"/>
           <p:nvPr/>
         </p:nvSpPr>
@@ -7661,7 +6188,7 @@
       </p:sp>
       <p:sp>
         <p:nvSpPr>
-          <p:cNvPr id="55" name="Oval 54"/>
+          <p:cNvPr id="79" name="Oval 78"/>
           <p:cNvSpPr/>
           <p:nvPr/>
         </p:nvSpPr>
@@ -7704,7 +6231,7 @@
       </p:sp>
       <p:sp>
         <p:nvSpPr>
-          <p:cNvPr id="56" name="TextBox 55"/>
+          <p:cNvPr id="80" name="TextBox 79"/>
           <p:cNvSpPr txBox="1"/>
           <p:nvPr/>
         </p:nvSpPr>
@@ -7739,7 +6266,7 @@
       </p:sp>
       <p:sp>
         <p:nvSpPr>
-          <p:cNvPr id="57" name="Oval 56"/>
+          <p:cNvPr id="81" name="Oval 80"/>
           <p:cNvSpPr/>
           <p:nvPr/>
         </p:nvSpPr>
@@ -7782,7 +6309,7 @@
       </p:sp>
       <p:sp>
         <p:nvSpPr>
-          <p:cNvPr id="58" name="TextBox 57"/>
+          <p:cNvPr id="82" name="TextBox 81"/>
           <p:cNvSpPr txBox="1"/>
           <p:nvPr/>
         </p:nvSpPr>
@@ -8988,1594 +7515,6 @@
       </p:sp>
       <p:sp>
         <p:nvSpPr>
-          <p:cNvPr id="4" name="Rounded Rectangle 3"/>
-          <p:cNvSpPr/>
-          <p:nvPr/>
-        </p:nvSpPr>
-        <p:spPr>
-          <a:xfrm>
-            <a:off x="603504" y="1664208"/>
-            <a:ext cx="1874519" cy="1225296"/>
-          </a:xfrm>
-          <a:prstGeom prst="roundRect">
-            <a:avLst/>
-          </a:prstGeom>
-          <a:solidFill>
-            <a:srgbClr val="028090"/>
-          </a:solidFill>
-          <a:ln>
-            <a:noFill/>
-          </a:ln>
-        </p:spPr>
-        <p:style>
-          <a:lnRef idx="1">
-            <a:schemeClr val="accent1"/>
-          </a:lnRef>
-          <a:fillRef idx="3">
-            <a:schemeClr val="accent1"/>
-          </a:fillRef>
-          <a:effectRef idx="2">
-            <a:schemeClr val="accent1"/>
-          </a:effectRef>
-          <a:fontRef idx="minor">
-            <a:schemeClr val="lt1"/>
-          </a:fontRef>
-        </p:style>
-        <p:txBody>
-          <a:bodyPr rtlCol="0" anchor="ctr"/>
-          <a:lstStyle/>
-          <a:p>
-            <a:pPr algn="ctr"/>
-          </a:p>
-        </p:txBody>
-      </p:sp>
-      <p:sp>
-        <p:nvSpPr>
-          <p:cNvPr id="5" name="TextBox 4"/>
-          <p:cNvSpPr txBox="1"/>
-          <p:nvPr/>
-        </p:nvSpPr>
-        <p:spPr>
-          <a:xfrm>
-            <a:off x="740664" y="1920240"/>
-            <a:ext cx="1600200" cy="210312"/>
-          </a:xfrm>
-          <a:prstGeom prst="rect">
-            <a:avLst/>
-          </a:prstGeom>
-          <a:noFill/>
-        </p:spPr>
-        <p:txBody>
-          <a:bodyPr wrap="square" lIns="0" rIns="0" tIns="0" bIns="0" anchor="t">
-            <a:spAutoFit/>
-          </a:bodyPr>
-          <a:lstStyle/>
-          <a:p>
-            <a:pPr algn="ctr"/>
-            <a:r>
-              <a:rPr sz="1450" b="1" i="0">
-                <a:solidFill>
-                  <a:srgbClr val="FFFFFF"/>
-                </a:solidFill>
-                <a:latin typeface="Calibri"/>
-              </a:rPr>
-              <a:t>Vue 3 前端</a:t>
-            </a:r>
-          </a:p>
-        </p:txBody>
-      </p:sp>
-      <p:sp>
-        <p:nvSpPr>
-          <p:cNvPr id="6" name="TextBox 5"/>
-          <p:cNvSpPr txBox="1"/>
-          <p:nvPr/>
-        </p:nvSpPr>
-        <p:spPr>
-          <a:xfrm>
-            <a:off x="768096" y="2267712"/>
-            <a:ext cx="1536192" cy="329184"/>
-          </a:xfrm>
-          <a:prstGeom prst="rect">
-            <a:avLst/>
-          </a:prstGeom>
-          <a:noFill/>
-        </p:spPr>
-        <p:txBody>
-          <a:bodyPr wrap="square" lIns="0" rIns="0" tIns="0" bIns="0" anchor="t">
-            <a:spAutoFit/>
-          </a:bodyPr>
-          <a:lstStyle/>
-          <a:p>
-            <a:pPr algn="ctr"/>
-            <a:r>
-              <a:rPr sz="960" b="0" i="0">
-                <a:solidFill>
-                  <a:srgbClr val="FFFFFF"/>
-                </a:solidFill>
-                <a:latin typeface="Calibri"/>
-              </a:rPr>
-              <a:t>页面、对话、预览、管理后台</a:t>
-            </a:r>
-          </a:p>
-        </p:txBody>
-      </p:sp>
-      <p:cxnSp>
-        <p:nvCxnSpPr>
-          <p:cNvPr id="7" name="Connector 6"/>
-          <p:cNvCxnSpPr/>
-          <p:nvPr/>
-        </p:nvCxnSpPr>
-        <p:spPr>
-          <a:xfrm>
-            <a:off x="2505456" y="2276856"/>
-            <a:ext cx="338328" cy="0"/>
-          </a:xfrm>
-          <a:prstGeom prst="line">
-            <a:avLst/>
-          </a:prstGeom>
-          <a:ln w="25400">
-            <a:solidFill>
-              <a:srgbClr val="1C7293"/>
-            </a:solidFill>
-          </a:ln>
-        </p:spPr>
-        <p:style>
-          <a:lnRef idx="2">
-            <a:schemeClr val="accent1"/>
-          </a:lnRef>
-          <a:fillRef idx="0">
-            <a:schemeClr val="accent1"/>
-          </a:fillRef>
-          <a:effectRef idx="1">
-            <a:schemeClr val="accent1"/>
-          </a:effectRef>
-          <a:fontRef idx="minor">
-            <a:schemeClr val="tx1"/>
-          </a:fontRef>
-        </p:style>
-      </p:cxnSp>
-      <p:sp>
-        <p:nvSpPr>
-          <p:cNvPr id="8" name="Rounded Rectangle 7"/>
-          <p:cNvSpPr/>
-          <p:nvPr/>
-        </p:nvSpPr>
-        <p:spPr>
-          <a:xfrm>
-            <a:off x="2907792" y="1664208"/>
-            <a:ext cx="1874519" cy="1225296"/>
-          </a:xfrm>
-          <a:prstGeom prst="roundRect">
-            <a:avLst/>
-          </a:prstGeom>
-          <a:solidFill>
-            <a:srgbClr val="1C7293"/>
-          </a:solidFill>
-          <a:ln>
-            <a:noFill/>
-          </a:ln>
-        </p:spPr>
-        <p:style>
-          <a:lnRef idx="1">
-            <a:schemeClr val="accent1"/>
-          </a:lnRef>
-          <a:fillRef idx="3">
-            <a:schemeClr val="accent1"/>
-          </a:fillRef>
-          <a:effectRef idx="2">
-            <a:schemeClr val="accent1"/>
-          </a:effectRef>
-          <a:fontRef idx="minor">
-            <a:schemeClr val="lt1"/>
-          </a:fontRef>
-        </p:style>
-        <p:txBody>
-          <a:bodyPr rtlCol="0" anchor="ctr"/>
-          <a:lstStyle/>
-          <a:p>
-            <a:pPr algn="ctr"/>
-          </a:p>
-        </p:txBody>
-      </p:sp>
-      <p:sp>
-        <p:nvSpPr>
-          <p:cNvPr id="9" name="TextBox 8"/>
-          <p:cNvSpPr txBox="1"/>
-          <p:nvPr/>
-        </p:nvSpPr>
-        <p:spPr>
-          <a:xfrm>
-            <a:off x="3044952" y="1920240"/>
-            <a:ext cx="1600200" cy="210312"/>
-          </a:xfrm>
-          <a:prstGeom prst="rect">
-            <a:avLst/>
-          </a:prstGeom>
-          <a:noFill/>
-        </p:spPr>
-        <p:txBody>
-          <a:bodyPr wrap="square" lIns="0" rIns="0" tIns="0" bIns="0" anchor="t">
-            <a:spAutoFit/>
-          </a:bodyPr>
-          <a:lstStyle/>
-          <a:p>
-            <a:pPr algn="ctr"/>
-            <a:r>
-              <a:rPr sz="1450" b="1" i="0">
-                <a:solidFill>
-                  <a:srgbClr val="FFFFFF"/>
-                </a:solidFill>
-                <a:latin typeface="Calibri"/>
-              </a:rPr>
-              <a:t>App 服务</a:t>
-            </a:r>
-          </a:p>
-        </p:txBody>
-      </p:sp>
-      <p:sp>
-        <p:nvSpPr>
-          <p:cNvPr id="10" name="TextBox 9"/>
-          <p:cNvSpPr txBox="1"/>
-          <p:nvPr/>
-        </p:nvSpPr>
-        <p:spPr>
-          <a:xfrm>
-            <a:off x="3072384" y="2267712"/>
-            <a:ext cx="1536192" cy="329184"/>
-          </a:xfrm>
-          <a:prstGeom prst="rect">
-            <a:avLst/>
-          </a:prstGeom>
-          <a:noFill/>
-        </p:spPr>
-        <p:txBody>
-          <a:bodyPr wrap="square" lIns="0" rIns="0" tIns="0" bIns="0" anchor="t">
-            <a:spAutoFit/>
-          </a:bodyPr>
-          <a:lstStyle/>
-          <a:p>
-            <a:pPr algn="ctr"/>
-            <a:r>
-              <a:rPr sz="960" b="0" i="0">
-                <a:solidFill>
-                  <a:srgbClr val="FFFFFF"/>
-                </a:solidFill>
-                <a:latin typeface="Calibri"/>
-              </a:rPr>
-              <a:t>应用/聊天/部署/API 聚合</a:t>
-            </a:r>
-          </a:p>
-        </p:txBody>
-      </p:sp>
-      <p:cxnSp>
-        <p:nvCxnSpPr>
-          <p:cNvPr id="11" name="Connector 10"/>
-          <p:cNvCxnSpPr/>
-          <p:nvPr/>
-        </p:nvCxnSpPr>
-        <p:spPr>
-          <a:xfrm>
-            <a:off x="4809744" y="2276856"/>
-            <a:ext cx="338328" cy="0"/>
-          </a:xfrm>
-          <a:prstGeom prst="line">
-            <a:avLst/>
-          </a:prstGeom>
-          <a:ln w="25400">
-            <a:solidFill>
-              <a:srgbClr val="1C7293"/>
-            </a:solidFill>
-          </a:ln>
-        </p:spPr>
-        <p:style>
-          <a:lnRef idx="2">
-            <a:schemeClr val="accent1"/>
-          </a:lnRef>
-          <a:fillRef idx="0">
-            <a:schemeClr val="accent1"/>
-          </a:fillRef>
-          <a:effectRef idx="1">
-            <a:schemeClr val="accent1"/>
-          </a:effectRef>
-          <a:fontRef idx="minor">
-            <a:schemeClr val="tx1"/>
-          </a:fontRef>
-        </p:style>
-      </p:cxnSp>
-      <p:sp>
-        <p:nvSpPr>
-          <p:cNvPr id="12" name="Rounded Rectangle 11"/>
-          <p:cNvSpPr/>
-          <p:nvPr/>
-        </p:nvSpPr>
-        <p:spPr>
-          <a:xfrm>
-            <a:off x="5212080" y="1664208"/>
-            <a:ext cx="1874519" cy="1225296"/>
-          </a:xfrm>
-          <a:prstGeom prst="roundRect">
-            <a:avLst/>
-          </a:prstGeom>
-          <a:solidFill>
-            <a:srgbClr val="21295C"/>
-          </a:solidFill>
-          <a:ln>
-            <a:noFill/>
-          </a:ln>
-        </p:spPr>
-        <p:style>
-          <a:lnRef idx="1">
-            <a:schemeClr val="accent1"/>
-          </a:lnRef>
-          <a:fillRef idx="3">
-            <a:schemeClr val="accent1"/>
-          </a:fillRef>
-          <a:effectRef idx="2">
-            <a:schemeClr val="accent1"/>
-          </a:effectRef>
-          <a:fontRef idx="minor">
-            <a:schemeClr val="lt1"/>
-          </a:fontRef>
-        </p:style>
-        <p:txBody>
-          <a:bodyPr rtlCol="0" anchor="ctr"/>
-          <a:lstStyle/>
-          <a:p>
-            <a:pPr algn="ctr"/>
-          </a:p>
-        </p:txBody>
-      </p:sp>
-      <p:sp>
-        <p:nvSpPr>
-          <p:cNvPr id="13" name="TextBox 12"/>
-          <p:cNvSpPr txBox="1"/>
-          <p:nvPr/>
-        </p:nvSpPr>
-        <p:spPr>
-          <a:xfrm>
-            <a:off x="5349240" y="1920240"/>
-            <a:ext cx="1600200" cy="210312"/>
-          </a:xfrm>
-          <a:prstGeom prst="rect">
-            <a:avLst/>
-          </a:prstGeom>
-          <a:noFill/>
-        </p:spPr>
-        <p:txBody>
-          <a:bodyPr wrap="square" lIns="0" rIns="0" tIns="0" bIns="0" anchor="t">
-            <a:spAutoFit/>
-          </a:bodyPr>
-          <a:lstStyle/>
-          <a:p>
-            <a:pPr algn="ctr"/>
-            <a:r>
-              <a:rPr sz="1450" b="1" i="0">
-                <a:solidFill>
-                  <a:srgbClr val="FFFFFF"/>
-                </a:solidFill>
-                <a:latin typeface="Calibri"/>
-              </a:rPr>
-              <a:t>AI 模块</a:t>
-            </a:r>
-          </a:p>
-        </p:txBody>
-      </p:sp>
-      <p:sp>
-        <p:nvSpPr>
-          <p:cNvPr id="14" name="TextBox 13"/>
-          <p:cNvSpPr txBox="1"/>
-          <p:nvPr/>
-        </p:nvSpPr>
-        <p:spPr>
-          <a:xfrm>
-            <a:off x="5376672" y="2267712"/>
-            <a:ext cx="1536192" cy="329184"/>
-          </a:xfrm>
-          <a:prstGeom prst="rect">
-            <a:avLst/>
-          </a:prstGeom>
-          <a:noFill/>
-        </p:spPr>
-        <p:txBody>
-          <a:bodyPr wrap="square" lIns="0" rIns="0" tIns="0" bIns="0" anchor="t">
-            <a:spAutoFit/>
-          </a:bodyPr>
-          <a:lstStyle/>
-          <a:p>
-            <a:pPr algn="ctr"/>
-            <a:r>
-              <a:rPr sz="960" b="0" i="0">
-                <a:solidFill>
-                  <a:srgbClr val="FFFFFF"/>
-                </a:solidFill>
-                <a:latin typeface="Calibri"/>
-              </a:rPr>
-              <a:t>LangChain4j、LangGraph4j、工具调用</a:t>
-            </a:r>
-          </a:p>
-        </p:txBody>
-      </p:sp>
-      <p:cxnSp>
-        <p:nvCxnSpPr>
-          <p:cNvPr id="15" name="Connector 14"/>
-          <p:cNvCxnSpPr/>
-          <p:nvPr/>
-        </p:nvCxnSpPr>
-        <p:spPr>
-          <a:xfrm>
-            <a:off x="7114032" y="2276856"/>
-            <a:ext cx="338328" cy="0"/>
-          </a:xfrm>
-          <a:prstGeom prst="line">
-            <a:avLst/>
-          </a:prstGeom>
-          <a:ln w="25400">
-            <a:solidFill>
-              <a:srgbClr val="1C7293"/>
-            </a:solidFill>
-          </a:ln>
-        </p:spPr>
-        <p:style>
-          <a:lnRef idx="2">
-            <a:schemeClr val="accent1"/>
-          </a:lnRef>
-          <a:fillRef idx="0">
-            <a:schemeClr val="accent1"/>
-          </a:fillRef>
-          <a:effectRef idx="1">
-            <a:schemeClr val="accent1"/>
-          </a:effectRef>
-          <a:fontRef idx="minor">
-            <a:schemeClr val="tx1"/>
-          </a:fontRef>
-        </p:style>
-      </p:cxnSp>
-      <p:sp>
-        <p:nvSpPr>
-          <p:cNvPr id="16" name="Rounded Rectangle 15"/>
-          <p:cNvSpPr/>
-          <p:nvPr/>
-        </p:nvSpPr>
-        <p:spPr>
-          <a:xfrm>
-            <a:off x="7516368" y="1664208"/>
-            <a:ext cx="1874519" cy="1225296"/>
-          </a:xfrm>
-          <a:prstGeom prst="roundRect">
-            <a:avLst/>
-          </a:prstGeom>
-          <a:solidFill>
-            <a:srgbClr val="00A896"/>
-          </a:solidFill>
-          <a:ln>
-            <a:noFill/>
-          </a:ln>
-        </p:spPr>
-        <p:style>
-          <a:lnRef idx="1">
-            <a:schemeClr val="accent1"/>
-          </a:lnRef>
-          <a:fillRef idx="3">
-            <a:schemeClr val="accent1"/>
-          </a:fillRef>
-          <a:effectRef idx="2">
-            <a:schemeClr val="accent1"/>
-          </a:effectRef>
-          <a:fontRef idx="minor">
-            <a:schemeClr val="lt1"/>
-          </a:fontRef>
-        </p:style>
-        <p:txBody>
-          <a:bodyPr rtlCol="0" anchor="ctr"/>
-          <a:lstStyle/>
-          <a:p>
-            <a:pPr algn="ctr"/>
-          </a:p>
-        </p:txBody>
-      </p:sp>
-      <p:sp>
-        <p:nvSpPr>
-          <p:cNvPr id="17" name="TextBox 16"/>
-          <p:cNvSpPr txBox="1"/>
-          <p:nvPr/>
-        </p:nvSpPr>
-        <p:spPr>
-          <a:xfrm>
-            <a:off x="7653528" y="1920240"/>
-            <a:ext cx="1600200" cy="210312"/>
-          </a:xfrm>
-          <a:prstGeom prst="rect">
-            <a:avLst/>
-          </a:prstGeom>
-          <a:noFill/>
-        </p:spPr>
-        <p:txBody>
-          <a:bodyPr wrap="square" lIns="0" rIns="0" tIns="0" bIns="0" anchor="t">
-            <a:spAutoFit/>
-          </a:bodyPr>
-          <a:lstStyle/>
-          <a:p>
-            <a:pPr algn="ctr"/>
-            <a:r>
-              <a:rPr sz="1450" b="1" i="0">
-                <a:solidFill>
-                  <a:srgbClr val="FFFFFF"/>
-                </a:solidFill>
-                <a:latin typeface="Calibri"/>
-              </a:rPr>
-              <a:t>Screenshot</a:t>
-            </a:r>
-          </a:p>
-        </p:txBody>
-      </p:sp>
-      <p:sp>
-        <p:nvSpPr>
-          <p:cNvPr id="18" name="TextBox 17"/>
-          <p:cNvSpPr txBox="1"/>
-          <p:nvPr/>
-        </p:nvSpPr>
-        <p:spPr>
-          <a:xfrm>
-            <a:off x="7680960" y="2267712"/>
-            <a:ext cx="1536192" cy="329184"/>
-          </a:xfrm>
-          <a:prstGeom prst="rect">
-            <a:avLst/>
-          </a:prstGeom>
-          <a:noFill/>
-        </p:spPr>
-        <p:txBody>
-          <a:bodyPr wrap="square" lIns="0" rIns="0" tIns="0" bIns="0" anchor="t">
-            <a:spAutoFit/>
-          </a:bodyPr>
-          <a:lstStyle/>
-          <a:p>
-            <a:pPr algn="ctr"/>
-            <a:r>
-              <a:rPr sz="960" b="0" i="0">
-                <a:solidFill>
-                  <a:srgbClr val="FFFFFF"/>
-                </a:solidFill>
-                <a:latin typeface="Calibri"/>
-              </a:rPr>
-              <a:t>Selenium 截图与封面生成</a:t>
-            </a:r>
-          </a:p>
-        </p:txBody>
-      </p:sp>
-      <p:cxnSp>
-        <p:nvCxnSpPr>
-          <p:cNvPr id="19" name="Connector 18"/>
-          <p:cNvCxnSpPr/>
-          <p:nvPr/>
-        </p:nvCxnSpPr>
-        <p:spPr>
-          <a:xfrm>
-            <a:off x="9418320" y="2276856"/>
-            <a:ext cx="338328" cy="0"/>
-          </a:xfrm>
-          <a:prstGeom prst="line">
-            <a:avLst/>
-          </a:prstGeom>
-          <a:ln w="25400">
-            <a:solidFill>
-              <a:srgbClr val="1C7293"/>
-            </a:solidFill>
-          </a:ln>
-        </p:spPr>
-        <p:style>
-          <a:lnRef idx="2">
-            <a:schemeClr val="accent1"/>
-          </a:lnRef>
-          <a:fillRef idx="0">
-            <a:schemeClr val="accent1"/>
-          </a:fillRef>
-          <a:effectRef idx="1">
-            <a:schemeClr val="accent1"/>
-          </a:effectRef>
-          <a:fontRef idx="minor">
-            <a:schemeClr val="tx1"/>
-          </a:fontRef>
-        </p:style>
-      </p:cxnSp>
-      <p:sp>
-        <p:nvSpPr>
-          <p:cNvPr id="20" name="Rounded Rectangle 19"/>
-          <p:cNvSpPr/>
-          <p:nvPr/>
-        </p:nvSpPr>
-        <p:spPr>
-          <a:xfrm>
-            <a:off x="9820656" y="1664208"/>
-            <a:ext cx="1874519" cy="1225296"/>
-          </a:xfrm>
-          <a:prstGeom prst="roundRect">
-            <a:avLst/>
-          </a:prstGeom>
-          <a:solidFill>
-            <a:srgbClr val="F6A94A"/>
-          </a:solidFill>
-          <a:ln>
-            <a:noFill/>
-          </a:ln>
-        </p:spPr>
-        <p:style>
-          <a:lnRef idx="1">
-            <a:schemeClr val="accent1"/>
-          </a:lnRef>
-          <a:fillRef idx="3">
-            <a:schemeClr val="accent1"/>
-          </a:fillRef>
-          <a:effectRef idx="2">
-            <a:schemeClr val="accent1"/>
-          </a:effectRef>
-          <a:fontRef idx="minor">
-            <a:schemeClr val="lt1"/>
-          </a:fontRef>
-        </p:style>
-        <p:txBody>
-          <a:bodyPr rtlCol="0" anchor="ctr"/>
-          <a:lstStyle/>
-          <a:p>
-            <a:pPr algn="ctr"/>
-          </a:p>
-        </p:txBody>
-      </p:sp>
-      <p:sp>
-        <p:nvSpPr>
-          <p:cNvPr id="21" name="TextBox 20"/>
-          <p:cNvSpPr txBox="1"/>
-          <p:nvPr/>
-        </p:nvSpPr>
-        <p:spPr>
-          <a:xfrm>
-            <a:off x="9957816" y="1920240"/>
-            <a:ext cx="1600200" cy="210312"/>
-          </a:xfrm>
-          <a:prstGeom prst="rect">
-            <a:avLst/>
-          </a:prstGeom>
-          <a:noFill/>
-        </p:spPr>
-        <p:txBody>
-          <a:bodyPr wrap="square" lIns="0" rIns="0" tIns="0" bIns="0" anchor="t">
-            <a:spAutoFit/>
-          </a:bodyPr>
-          <a:lstStyle/>
-          <a:p>
-            <a:pPr algn="ctr"/>
-            <a:r>
-              <a:rPr sz="1450" b="1" i="0">
-                <a:solidFill>
-                  <a:srgbClr val="FFFFFF"/>
-                </a:solidFill>
-                <a:latin typeface="Calibri"/>
-              </a:rPr>
-              <a:t>基础设施</a:t>
-            </a:r>
-          </a:p>
-        </p:txBody>
-      </p:sp>
-      <p:sp>
-        <p:nvSpPr>
-          <p:cNvPr id="22" name="TextBox 21"/>
-          <p:cNvSpPr txBox="1"/>
-          <p:nvPr/>
-        </p:nvSpPr>
-        <p:spPr>
-          <a:xfrm>
-            <a:off x="9985248" y="2267712"/>
-            <a:ext cx="1536192" cy="329184"/>
-          </a:xfrm>
-          <a:prstGeom prst="rect">
-            <a:avLst/>
-          </a:prstGeom>
-          <a:noFill/>
-        </p:spPr>
-        <p:txBody>
-          <a:bodyPr wrap="square" lIns="0" rIns="0" tIns="0" bIns="0" anchor="t">
-            <a:spAutoFit/>
-          </a:bodyPr>
-          <a:lstStyle/>
-          <a:p>
-            <a:pPr algn="ctr"/>
-            <a:r>
-              <a:rPr sz="960" b="0" i="0">
-                <a:solidFill>
-                  <a:srgbClr val="FFFFFF"/>
-                </a:solidFill>
-                <a:latin typeface="Calibri"/>
-              </a:rPr>
-              <a:t>MySQL / Redis / COS / Prometheus</a:t>
-            </a:r>
-          </a:p>
-        </p:txBody>
-      </p:sp>
-      <p:sp>
-        <p:nvSpPr>
-          <p:cNvPr id="23" name="Rounded Rectangle 22"/>
-          <p:cNvSpPr/>
-          <p:nvPr/>
-        </p:nvSpPr>
-        <p:spPr>
-          <a:xfrm>
-            <a:off x="713232" y="3520440"/>
-            <a:ext cx="1325880" cy="292608"/>
-          </a:xfrm>
-          <a:prstGeom prst="roundRect">
-            <a:avLst/>
-          </a:prstGeom>
-          <a:solidFill>
-            <a:srgbClr val="028090"/>
-          </a:solidFill>
-          <a:ln>
-            <a:noFill/>
-          </a:ln>
-        </p:spPr>
-        <p:style>
-          <a:lnRef idx="1">
-            <a:schemeClr val="accent1"/>
-          </a:lnRef>
-          <a:fillRef idx="3">
-            <a:schemeClr val="accent1"/>
-          </a:fillRef>
-          <a:effectRef idx="2">
-            <a:schemeClr val="accent1"/>
-          </a:effectRef>
-          <a:fontRef idx="minor">
-            <a:schemeClr val="lt1"/>
-          </a:fontRef>
-        </p:style>
-        <p:txBody>
-          <a:bodyPr rtlCol="0" anchor="ctr"/>
-          <a:lstStyle/>
-          <a:p>
-            <a:pPr algn="ctr"/>
-          </a:p>
-        </p:txBody>
-      </p:sp>
-      <p:sp>
-        <p:nvSpPr>
-          <p:cNvPr id="24" name="TextBox 23"/>
-          <p:cNvSpPr txBox="1"/>
-          <p:nvPr/>
-        </p:nvSpPr>
-        <p:spPr>
-          <a:xfrm>
-            <a:off x="822960" y="3584448"/>
-            <a:ext cx="1097280" cy="128016"/>
-          </a:xfrm>
-          <a:prstGeom prst="rect">
-            <a:avLst/>
-          </a:prstGeom>
-          <a:noFill/>
-        </p:spPr>
-        <p:txBody>
-          <a:bodyPr wrap="square" lIns="0" rIns="0" tIns="0" bIns="0" anchor="t">
-            <a:spAutoFit/>
-          </a:bodyPr>
-          <a:lstStyle/>
-          <a:p>
-            <a:pPr algn="ctr"/>
-            <a:r>
-              <a:rPr sz="950" b="1" i="0">
-                <a:solidFill>
-                  <a:srgbClr val="FFFFFF"/>
-                </a:solidFill>
-                <a:latin typeface="Calibri"/>
-              </a:rPr>
-              <a:t>微服务模块</a:t>
-            </a:r>
-          </a:p>
-        </p:txBody>
-      </p:sp>
-      <p:sp>
-        <p:nvSpPr>
-          <p:cNvPr id="25" name="Rounded Rectangle 24"/>
-          <p:cNvSpPr/>
-          <p:nvPr/>
-        </p:nvSpPr>
-        <p:spPr>
-          <a:xfrm>
-            <a:off x="713232" y="3950208"/>
-            <a:ext cx="2377440" cy="566928"/>
-          </a:xfrm>
-          <a:prstGeom prst="roundRect">
-            <a:avLst/>
-          </a:prstGeom>
-          <a:solidFill>
-            <a:srgbClr val="FFFFFF"/>
-          </a:solidFill>
-          <a:ln>
-            <a:solidFill>
-              <a:srgbClr val="CAE6EA"/>
-            </a:solidFill>
-          </a:ln>
-        </p:spPr>
-        <p:style>
-          <a:lnRef idx="1">
-            <a:schemeClr val="accent1"/>
-          </a:lnRef>
-          <a:fillRef idx="3">
-            <a:schemeClr val="accent1"/>
-          </a:fillRef>
-          <a:effectRef idx="2">
-            <a:schemeClr val="accent1"/>
-          </a:effectRef>
-          <a:fontRef idx="minor">
-            <a:schemeClr val="lt1"/>
-          </a:fontRef>
-        </p:style>
-        <p:txBody>
-          <a:bodyPr rtlCol="0" anchor="ctr"/>
-          <a:lstStyle/>
-          <a:p>
-            <a:pPr algn="ctr"/>
-          </a:p>
-        </p:txBody>
-      </p:sp>
-      <p:sp>
-        <p:nvSpPr>
-          <p:cNvPr id="26" name="TextBox 25"/>
-          <p:cNvSpPr txBox="1"/>
-          <p:nvPr/>
-        </p:nvSpPr>
-        <p:spPr>
-          <a:xfrm>
-            <a:off x="868680" y="4059936"/>
-            <a:ext cx="777240" cy="146304"/>
-          </a:xfrm>
-          <a:prstGeom prst="rect">
-            <a:avLst/>
-          </a:prstGeom>
-          <a:noFill/>
-        </p:spPr>
-        <p:txBody>
-          <a:bodyPr wrap="square" lIns="0" rIns="0" tIns="0" bIns="0" anchor="t">
-            <a:spAutoFit/>
-          </a:bodyPr>
-          <a:lstStyle/>
-          <a:p>
-            <a:pPr algn="l"/>
-            <a:r>
-              <a:rPr sz="1200" b="1" i="0">
-                <a:solidFill>
-                  <a:srgbClr val="065A82"/>
-                </a:solidFill>
-                <a:latin typeface="Georgia"/>
-              </a:rPr>
-              <a:t>common</a:t>
-            </a:r>
-          </a:p>
-        </p:txBody>
-      </p:sp>
-      <p:sp>
-        <p:nvSpPr>
-          <p:cNvPr id="27" name="TextBox 26"/>
-          <p:cNvSpPr txBox="1"/>
-          <p:nvPr/>
-        </p:nvSpPr>
-        <p:spPr>
-          <a:xfrm>
-            <a:off x="1645920" y="4069080"/>
-            <a:ext cx="1280160" cy="137160"/>
-          </a:xfrm>
-          <a:prstGeom prst="rect">
-            <a:avLst/>
-          </a:prstGeom>
-          <a:noFill/>
-        </p:spPr>
-        <p:txBody>
-          <a:bodyPr wrap="square" lIns="0" rIns="0" tIns="0" bIns="0" anchor="t">
-            <a:spAutoFit/>
-          </a:bodyPr>
-          <a:lstStyle/>
-          <a:p>
-            <a:pPr algn="l"/>
-            <a:r>
-              <a:rPr sz="919" b="0" i="0">
-                <a:solidFill>
-                  <a:srgbClr val="5B6B7A"/>
-                </a:solidFill>
-                <a:latin typeface="Calibri"/>
-              </a:rPr>
-              <a:t>通用响应、异常、工具</a:t>
-            </a:r>
-          </a:p>
-        </p:txBody>
-      </p:sp>
-      <p:sp>
-        <p:nvSpPr>
-          <p:cNvPr id="28" name="Rounded Rectangle 27"/>
-          <p:cNvSpPr/>
-          <p:nvPr/>
-        </p:nvSpPr>
-        <p:spPr>
-          <a:xfrm>
-            <a:off x="3493008" y="3950208"/>
-            <a:ext cx="2377440" cy="566928"/>
-          </a:xfrm>
-          <a:prstGeom prst="roundRect">
-            <a:avLst/>
-          </a:prstGeom>
-          <a:solidFill>
-            <a:srgbClr val="FFFFFF"/>
-          </a:solidFill>
-          <a:ln>
-            <a:solidFill>
-              <a:srgbClr val="CAE6EA"/>
-            </a:solidFill>
-          </a:ln>
-        </p:spPr>
-        <p:style>
-          <a:lnRef idx="1">
-            <a:schemeClr val="accent1"/>
-          </a:lnRef>
-          <a:fillRef idx="3">
-            <a:schemeClr val="accent1"/>
-          </a:fillRef>
-          <a:effectRef idx="2">
-            <a:schemeClr val="accent1"/>
-          </a:effectRef>
-          <a:fontRef idx="minor">
-            <a:schemeClr val="lt1"/>
-          </a:fontRef>
-        </p:style>
-        <p:txBody>
-          <a:bodyPr rtlCol="0" anchor="ctr"/>
-          <a:lstStyle/>
-          <a:p>
-            <a:pPr algn="ctr"/>
-          </a:p>
-        </p:txBody>
-      </p:sp>
-      <p:sp>
-        <p:nvSpPr>
-          <p:cNvPr id="29" name="TextBox 28"/>
-          <p:cNvSpPr txBox="1"/>
-          <p:nvPr/>
-        </p:nvSpPr>
-        <p:spPr>
-          <a:xfrm>
-            <a:off x="3648456" y="4059936"/>
-            <a:ext cx="777240" cy="146304"/>
-          </a:xfrm>
-          <a:prstGeom prst="rect">
-            <a:avLst/>
-          </a:prstGeom>
-          <a:noFill/>
-        </p:spPr>
-        <p:txBody>
-          <a:bodyPr wrap="square" lIns="0" rIns="0" tIns="0" bIns="0" anchor="t">
-            <a:spAutoFit/>
-          </a:bodyPr>
-          <a:lstStyle/>
-          <a:p>
-            <a:pPr algn="l"/>
-            <a:r>
-              <a:rPr sz="1200" b="1" i="0">
-                <a:solidFill>
-                  <a:srgbClr val="065A82"/>
-                </a:solidFill>
-                <a:latin typeface="Georgia"/>
-              </a:rPr>
-              <a:t>model</a:t>
-            </a:r>
-          </a:p>
-        </p:txBody>
-      </p:sp>
-      <p:sp>
-        <p:nvSpPr>
-          <p:cNvPr id="30" name="TextBox 29"/>
-          <p:cNvSpPr txBox="1"/>
-          <p:nvPr/>
-        </p:nvSpPr>
-        <p:spPr>
-          <a:xfrm>
-            <a:off x="4425696" y="4069080"/>
-            <a:ext cx="1280160" cy="137160"/>
-          </a:xfrm>
-          <a:prstGeom prst="rect">
-            <a:avLst/>
-          </a:prstGeom>
-          <a:noFill/>
-        </p:spPr>
-        <p:txBody>
-          <a:bodyPr wrap="square" lIns="0" rIns="0" tIns="0" bIns="0" anchor="t">
-            <a:spAutoFit/>
-          </a:bodyPr>
-          <a:lstStyle/>
-          <a:p>
-            <a:pPr algn="l"/>
-            <a:r>
-              <a:rPr sz="919" b="0" i="0">
-                <a:solidFill>
-                  <a:srgbClr val="5B6B7A"/>
-                </a:solidFill>
-                <a:latin typeface="Calibri"/>
-              </a:rPr>
-              <a:t>实体、DTO、VO、枚举</a:t>
-            </a:r>
-          </a:p>
-        </p:txBody>
-      </p:sp>
-      <p:sp>
-        <p:nvSpPr>
-          <p:cNvPr id="31" name="Rounded Rectangle 30"/>
-          <p:cNvSpPr/>
-          <p:nvPr/>
-        </p:nvSpPr>
-        <p:spPr>
-          <a:xfrm>
-            <a:off x="6272784" y="3950208"/>
-            <a:ext cx="2377440" cy="566928"/>
-          </a:xfrm>
-          <a:prstGeom prst="roundRect">
-            <a:avLst/>
-          </a:prstGeom>
-          <a:solidFill>
-            <a:srgbClr val="FFFFFF"/>
-          </a:solidFill>
-          <a:ln>
-            <a:solidFill>
-              <a:srgbClr val="CAE6EA"/>
-            </a:solidFill>
-          </a:ln>
-        </p:spPr>
-        <p:style>
-          <a:lnRef idx="1">
-            <a:schemeClr val="accent1"/>
-          </a:lnRef>
-          <a:fillRef idx="3">
-            <a:schemeClr val="accent1"/>
-          </a:fillRef>
-          <a:effectRef idx="2">
-            <a:schemeClr val="accent1"/>
-          </a:effectRef>
-          <a:fontRef idx="minor">
-            <a:schemeClr val="lt1"/>
-          </a:fontRef>
-        </p:style>
-        <p:txBody>
-          <a:bodyPr rtlCol="0" anchor="ctr"/>
-          <a:lstStyle/>
-          <a:p>
-            <a:pPr algn="ctr"/>
-          </a:p>
-        </p:txBody>
-      </p:sp>
-      <p:sp>
-        <p:nvSpPr>
-          <p:cNvPr id="32" name="TextBox 31"/>
-          <p:cNvSpPr txBox="1"/>
-          <p:nvPr/>
-        </p:nvSpPr>
-        <p:spPr>
-          <a:xfrm>
-            <a:off x="6428232" y="4059936"/>
-            <a:ext cx="777240" cy="146304"/>
-          </a:xfrm>
-          <a:prstGeom prst="rect">
-            <a:avLst/>
-          </a:prstGeom>
-          <a:noFill/>
-        </p:spPr>
-        <p:txBody>
-          <a:bodyPr wrap="square" lIns="0" rIns="0" tIns="0" bIns="0" anchor="t">
-            <a:spAutoFit/>
-          </a:bodyPr>
-          <a:lstStyle/>
-          <a:p>
-            <a:pPr algn="l"/>
-            <a:r>
-              <a:rPr sz="1200" b="1" i="0">
-                <a:solidFill>
-                  <a:srgbClr val="065A82"/>
-                </a:solidFill>
-                <a:latin typeface="Georgia"/>
-              </a:rPr>
-              <a:t>client</a:t>
-            </a:r>
-          </a:p>
-        </p:txBody>
-      </p:sp>
-      <p:sp>
-        <p:nvSpPr>
-          <p:cNvPr id="33" name="TextBox 32"/>
-          <p:cNvSpPr txBox="1"/>
-          <p:nvPr/>
-        </p:nvSpPr>
-        <p:spPr>
-          <a:xfrm>
-            <a:off x="7205472" y="4069080"/>
-            <a:ext cx="1280160" cy="137160"/>
-          </a:xfrm>
-          <a:prstGeom prst="rect">
-            <a:avLst/>
-          </a:prstGeom>
-          <a:noFill/>
-        </p:spPr>
-        <p:txBody>
-          <a:bodyPr wrap="square" lIns="0" rIns="0" tIns="0" bIns="0" anchor="t">
-            <a:spAutoFit/>
-          </a:bodyPr>
-          <a:lstStyle/>
-          <a:p>
-            <a:pPr algn="l"/>
-            <a:r>
-              <a:rPr sz="919" b="0" i="0">
-                <a:solidFill>
-                  <a:srgbClr val="5B6B7A"/>
-                </a:solidFill>
-                <a:latin typeface="Calibri"/>
-              </a:rPr>
-              <a:t>跨服务接口契约</a:t>
-            </a:r>
-          </a:p>
-        </p:txBody>
-      </p:sp>
-      <p:sp>
-        <p:nvSpPr>
-          <p:cNvPr id="34" name="Rounded Rectangle 33"/>
-          <p:cNvSpPr/>
-          <p:nvPr/>
-        </p:nvSpPr>
-        <p:spPr>
-          <a:xfrm>
-            <a:off x="9052560" y="3950208"/>
-            <a:ext cx="2377440" cy="566928"/>
-          </a:xfrm>
-          <a:prstGeom prst="roundRect">
-            <a:avLst/>
-          </a:prstGeom>
-          <a:solidFill>
-            <a:srgbClr val="FFFFFF"/>
-          </a:solidFill>
-          <a:ln>
-            <a:solidFill>
-              <a:srgbClr val="CAE6EA"/>
-            </a:solidFill>
-          </a:ln>
-        </p:spPr>
-        <p:style>
-          <a:lnRef idx="1">
-            <a:schemeClr val="accent1"/>
-          </a:lnRef>
-          <a:fillRef idx="3">
-            <a:schemeClr val="accent1"/>
-          </a:fillRef>
-          <a:effectRef idx="2">
-            <a:schemeClr val="accent1"/>
-          </a:effectRef>
-          <a:fontRef idx="minor">
-            <a:schemeClr val="lt1"/>
-          </a:fontRef>
-        </p:style>
-        <p:txBody>
-          <a:bodyPr rtlCol="0" anchor="ctr"/>
-          <a:lstStyle/>
-          <a:p>
-            <a:pPr algn="ctr"/>
-          </a:p>
-        </p:txBody>
-      </p:sp>
-      <p:sp>
-        <p:nvSpPr>
-          <p:cNvPr id="35" name="TextBox 34"/>
-          <p:cNvSpPr txBox="1"/>
-          <p:nvPr/>
-        </p:nvSpPr>
-        <p:spPr>
-          <a:xfrm>
-            <a:off x="9208008" y="4059936"/>
-            <a:ext cx="777240" cy="146304"/>
-          </a:xfrm>
-          <a:prstGeom prst="rect">
-            <a:avLst/>
-          </a:prstGeom>
-          <a:noFill/>
-        </p:spPr>
-        <p:txBody>
-          <a:bodyPr wrap="square" lIns="0" rIns="0" tIns="0" bIns="0" anchor="t">
-            <a:spAutoFit/>
-          </a:bodyPr>
-          <a:lstStyle/>
-          <a:p>
-            <a:pPr algn="l"/>
-            <a:r>
-              <a:rPr sz="1200" b="1" i="0">
-                <a:solidFill>
-                  <a:srgbClr val="065A82"/>
-                </a:solidFill>
-                <a:latin typeface="Georgia"/>
-              </a:rPr>
-              <a:t>user</a:t>
-            </a:r>
-          </a:p>
-        </p:txBody>
-      </p:sp>
-      <p:sp>
-        <p:nvSpPr>
-          <p:cNvPr id="36" name="TextBox 35"/>
-          <p:cNvSpPr txBox="1"/>
-          <p:nvPr/>
-        </p:nvSpPr>
-        <p:spPr>
-          <a:xfrm>
-            <a:off x="9985248" y="4069080"/>
-            <a:ext cx="1280160" cy="137160"/>
-          </a:xfrm>
-          <a:prstGeom prst="rect">
-            <a:avLst/>
-          </a:prstGeom>
-          <a:noFill/>
-        </p:spPr>
-        <p:txBody>
-          <a:bodyPr wrap="square" lIns="0" rIns="0" tIns="0" bIns="0" anchor="t">
-            <a:spAutoFit/>
-          </a:bodyPr>
-          <a:lstStyle/>
-          <a:p>
-            <a:pPr algn="l"/>
-            <a:r>
-              <a:rPr sz="919" b="0" i="0">
-                <a:solidFill>
-                  <a:srgbClr val="5B6B7A"/>
-                </a:solidFill>
-                <a:latin typeface="Calibri"/>
-              </a:rPr>
-              <a:t>用户与权限</a:t>
-            </a:r>
-          </a:p>
-        </p:txBody>
-      </p:sp>
-      <p:sp>
-        <p:nvSpPr>
-          <p:cNvPr id="37" name="Rounded Rectangle 36"/>
-          <p:cNvSpPr/>
-          <p:nvPr/>
-        </p:nvSpPr>
-        <p:spPr>
-          <a:xfrm>
-            <a:off x="713232" y="4754880"/>
-            <a:ext cx="2377440" cy="566928"/>
-          </a:xfrm>
-          <a:prstGeom prst="roundRect">
-            <a:avLst/>
-          </a:prstGeom>
-          <a:solidFill>
-            <a:srgbClr val="FFFFFF"/>
-          </a:solidFill>
-          <a:ln>
-            <a:solidFill>
-              <a:srgbClr val="CAE6EA"/>
-            </a:solidFill>
-          </a:ln>
-        </p:spPr>
-        <p:style>
-          <a:lnRef idx="1">
-            <a:schemeClr val="accent1"/>
-          </a:lnRef>
-          <a:fillRef idx="3">
-            <a:schemeClr val="accent1"/>
-          </a:fillRef>
-          <a:effectRef idx="2">
-            <a:schemeClr val="accent1"/>
-          </a:effectRef>
-          <a:fontRef idx="minor">
-            <a:schemeClr val="lt1"/>
-          </a:fontRef>
-        </p:style>
-        <p:txBody>
-          <a:bodyPr rtlCol="0" anchor="ctr"/>
-          <a:lstStyle/>
-          <a:p>
-            <a:pPr algn="ctr"/>
-          </a:p>
-        </p:txBody>
-      </p:sp>
-      <p:sp>
-        <p:nvSpPr>
-          <p:cNvPr id="38" name="TextBox 37"/>
-          <p:cNvSpPr txBox="1"/>
-          <p:nvPr/>
-        </p:nvSpPr>
-        <p:spPr>
-          <a:xfrm>
-            <a:off x="868680" y="4864608"/>
-            <a:ext cx="777240" cy="146304"/>
-          </a:xfrm>
-          <a:prstGeom prst="rect">
-            <a:avLst/>
-          </a:prstGeom>
-          <a:noFill/>
-        </p:spPr>
-        <p:txBody>
-          <a:bodyPr wrap="square" lIns="0" rIns="0" tIns="0" bIns="0" anchor="t">
-            <a:spAutoFit/>
-          </a:bodyPr>
-          <a:lstStyle/>
-          <a:p>
-            <a:pPr algn="l"/>
-            <a:r>
-              <a:rPr sz="1200" b="1" i="0">
-                <a:solidFill>
-                  <a:srgbClr val="065A82"/>
-                </a:solidFill>
-                <a:latin typeface="Georgia"/>
-              </a:rPr>
-              <a:t>app</a:t>
-            </a:r>
-          </a:p>
-        </p:txBody>
-      </p:sp>
-      <p:sp>
-        <p:nvSpPr>
-          <p:cNvPr id="39" name="TextBox 38"/>
-          <p:cNvSpPr txBox="1"/>
-          <p:nvPr/>
-        </p:nvSpPr>
-        <p:spPr>
-          <a:xfrm>
-            <a:off x="1645920" y="4873752"/>
-            <a:ext cx="1280160" cy="137160"/>
-          </a:xfrm>
-          <a:prstGeom prst="rect">
-            <a:avLst/>
-          </a:prstGeom>
-          <a:noFill/>
-        </p:spPr>
-        <p:txBody>
-          <a:bodyPr wrap="square" lIns="0" rIns="0" tIns="0" bIns="0" anchor="t">
-            <a:spAutoFit/>
-          </a:bodyPr>
-          <a:lstStyle/>
-          <a:p>
-            <a:pPr algn="l"/>
-            <a:r>
-              <a:rPr sz="919" b="0" i="0">
-                <a:solidFill>
-                  <a:srgbClr val="5B6B7A"/>
-                </a:solidFill>
-                <a:latin typeface="Calibri"/>
-              </a:rPr>
-              <a:t>应用与部署主流程</a:t>
-            </a:r>
-          </a:p>
-        </p:txBody>
-      </p:sp>
-      <p:sp>
-        <p:nvSpPr>
-          <p:cNvPr id="40" name="Rounded Rectangle 39"/>
-          <p:cNvSpPr/>
-          <p:nvPr/>
-        </p:nvSpPr>
-        <p:spPr>
-          <a:xfrm>
-            <a:off x="3493008" y="4754880"/>
-            <a:ext cx="2377440" cy="566928"/>
-          </a:xfrm>
-          <a:prstGeom prst="roundRect">
-            <a:avLst/>
-          </a:prstGeom>
-          <a:solidFill>
-            <a:srgbClr val="FFFFFF"/>
-          </a:solidFill>
-          <a:ln>
-            <a:solidFill>
-              <a:srgbClr val="CAE6EA"/>
-            </a:solidFill>
-          </a:ln>
-        </p:spPr>
-        <p:style>
-          <a:lnRef idx="1">
-            <a:schemeClr val="accent1"/>
-          </a:lnRef>
-          <a:fillRef idx="3">
-            <a:schemeClr val="accent1"/>
-          </a:fillRef>
-          <a:effectRef idx="2">
-            <a:schemeClr val="accent1"/>
-          </a:effectRef>
-          <a:fontRef idx="minor">
-            <a:schemeClr val="lt1"/>
-          </a:fontRef>
-        </p:style>
-        <p:txBody>
-          <a:bodyPr rtlCol="0" anchor="ctr"/>
-          <a:lstStyle/>
-          <a:p>
-            <a:pPr algn="ctr"/>
-          </a:p>
-        </p:txBody>
-      </p:sp>
-      <p:sp>
-        <p:nvSpPr>
-          <p:cNvPr id="41" name="TextBox 40"/>
-          <p:cNvSpPr txBox="1"/>
-          <p:nvPr/>
-        </p:nvSpPr>
-        <p:spPr>
-          <a:xfrm>
-            <a:off x="3648456" y="4864608"/>
-            <a:ext cx="777240" cy="146304"/>
-          </a:xfrm>
-          <a:prstGeom prst="rect">
-            <a:avLst/>
-          </a:prstGeom>
-          <a:noFill/>
-        </p:spPr>
-        <p:txBody>
-          <a:bodyPr wrap="square" lIns="0" rIns="0" tIns="0" bIns="0" anchor="t">
-            <a:spAutoFit/>
-          </a:bodyPr>
-          <a:lstStyle/>
-          <a:p>
-            <a:pPr algn="l"/>
-            <a:r>
-              <a:rPr sz="1200" b="1" i="0">
-                <a:solidFill>
-                  <a:srgbClr val="065A82"/>
-                </a:solidFill>
-                <a:latin typeface="Georgia"/>
-              </a:rPr>
-              <a:t>ai</a:t>
-            </a:r>
-          </a:p>
-        </p:txBody>
-      </p:sp>
-      <p:sp>
-        <p:nvSpPr>
-          <p:cNvPr id="42" name="TextBox 41"/>
-          <p:cNvSpPr txBox="1"/>
-          <p:nvPr/>
-        </p:nvSpPr>
-        <p:spPr>
-          <a:xfrm>
-            <a:off x="4425696" y="4873752"/>
-            <a:ext cx="1280160" cy="137160"/>
-          </a:xfrm>
-          <a:prstGeom prst="rect">
-            <a:avLst/>
-          </a:prstGeom>
-          <a:noFill/>
-        </p:spPr>
-        <p:txBody>
-          <a:bodyPr wrap="square" lIns="0" rIns="0" tIns="0" bIns="0" anchor="t">
-            <a:spAutoFit/>
-          </a:bodyPr>
-          <a:lstStyle/>
-          <a:p>
-            <a:pPr algn="l"/>
-            <a:r>
-              <a:rPr sz="919" b="0" i="0">
-                <a:solidFill>
-                  <a:srgbClr val="5B6B7A"/>
-                </a:solidFill>
-                <a:latin typeface="Calibri"/>
-              </a:rPr>
-              <a:t>模型、提示词、工具链</a:t>
-            </a:r>
-          </a:p>
-        </p:txBody>
-      </p:sp>
-      <p:sp>
-        <p:nvSpPr>
-          <p:cNvPr id="43" name="Rounded Rectangle 42"/>
-          <p:cNvSpPr/>
-          <p:nvPr/>
-        </p:nvSpPr>
-        <p:spPr>
-          <a:xfrm>
-            <a:off x="6272784" y="4754880"/>
-            <a:ext cx="2377440" cy="566928"/>
-          </a:xfrm>
-          <a:prstGeom prst="roundRect">
-            <a:avLst/>
-          </a:prstGeom>
-          <a:solidFill>
-            <a:srgbClr val="FFFFFF"/>
-          </a:solidFill>
-          <a:ln>
-            <a:solidFill>
-              <a:srgbClr val="CAE6EA"/>
-            </a:solidFill>
-          </a:ln>
-        </p:spPr>
-        <p:style>
-          <a:lnRef idx="1">
-            <a:schemeClr val="accent1"/>
-          </a:lnRef>
-          <a:fillRef idx="3">
-            <a:schemeClr val="accent1"/>
-          </a:fillRef>
-          <a:effectRef idx="2">
-            <a:schemeClr val="accent1"/>
-          </a:effectRef>
-          <a:fontRef idx="minor">
-            <a:schemeClr val="lt1"/>
-          </a:fontRef>
-        </p:style>
-        <p:txBody>
-          <a:bodyPr rtlCol="0" anchor="ctr"/>
-          <a:lstStyle/>
-          <a:p>
-            <a:pPr algn="ctr"/>
-          </a:p>
-        </p:txBody>
-      </p:sp>
-      <p:sp>
-        <p:nvSpPr>
-          <p:cNvPr id="44" name="TextBox 43"/>
-          <p:cNvSpPr txBox="1"/>
-          <p:nvPr/>
-        </p:nvSpPr>
-        <p:spPr>
-          <a:xfrm>
-            <a:off x="6428232" y="4864608"/>
-            <a:ext cx="777240" cy="146304"/>
-          </a:xfrm>
-          <a:prstGeom prst="rect">
-            <a:avLst/>
-          </a:prstGeom>
-          <a:noFill/>
-        </p:spPr>
-        <p:txBody>
-          <a:bodyPr wrap="square" lIns="0" rIns="0" tIns="0" bIns="0" anchor="t">
-            <a:spAutoFit/>
-          </a:bodyPr>
-          <a:lstStyle/>
-          <a:p>
-            <a:pPr algn="l"/>
-            <a:r>
-              <a:rPr sz="1200" b="1" i="0">
-                <a:solidFill>
-                  <a:srgbClr val="065A82"/>
-                </a:solidFill>
-                <a:latin typeface="Georgia"/>
-              </a:rPr>
-              <a:t>screenshot</a:t>
-            </a:r>
-          </a:p>
-        </p:txBody>
-      </p:sp>
-      <p:sp>
-        <p:nvSpPr>
-          <p:cNvPr id="45" name="TextBox 44"/>
-          <p:cNvSpPr txBox="1"/>
-          <p:nvPr/>
-        </p:nvSpPr>
-        <p:spPr>
-          <a:xfrm>
-            <a:off x="7205472" y="4873752"/>
-            <a:ext cx="1280160" cy="137160"/>
-          </a:xfrm>
-          <a:prstGeom prst="rect">
-            <a:avLst/>
-          </a:prstGeom>
-          <a:noFill/>
-        </p:spPr>
-        <p:txBody>
-          <a:bodyPr wrap="square" lIns="0" rIns="0" tIns="0" bIns="0" anchor="t">
-            <a:spAutoFit/>
-          </a:bodyPr>
-          <a:lstStyle/>
-          <a:p>
-            <a:pPr algn="l"/>
-            <a:r>
-              <a:rPr sz="919" b="0" i="0">
-                <a:solidFill>
-                  <a:srgbClr val="5B6B7A"/>
-                </a:solidFill>
-                <a:latin typeface="Calibri"/>
-              </a:rPr>
-              <a:t>截图服务</a:t>
-            </a:r>
-          </a:p>
-        </p:txBody>
-      </p:sp>
-      <p:sp>
-        <p:nvSpPr>
           <p:cNvPr id="46" name="TextBox 45"/>
           <p:cNvSpPr txBox="1"/>
           <p:nvPr/>
@@ -10695,8 +7634,8 @@
         </p:nvSpPr>
         <p:spPr>
           <a:xfrm>
-            <a:off x="457200" y="1508760"/>
-            <a:ext cx="11201400" cy="4005072"/>
+            <a:off x="411480" y="1417320"/>
+            <a:ext cx="11384280" cy="4251960"/>
           </a:xfrm>
           <a:prstGeom prst="rect">
             <a:avLst/>

</xml_diff>

<commit_message>
docs: restore report cover title
Co-authored-by: 程序员鱼皮 <592789970@qq.com>
</commit_message>
<xml_diff>
--- a/docs/reports/project-status-2026-06-03.pptx
+++ b/docs/reports/project-status-2026-06-03.pptx
@@ -3679,6 +3679,76 @@
                 <a:latin typeface="Calibri"/>
               </a:rPr>
               <a:t>质量与可运行性</a:t>
+            </a:r>
+          </a:p>
+        </p:txBody>
+      </p:sp>
+      <p:sp>
+        <p:nvSpPr>
+          <p:cNvPr id="30" name="TextBox 29"/>
+          <p:cNvSpPr txBox="1"/>
+          <p:nvPr/>
+        </p:nvSpPr>
+        <p:spPr>
+          <a:xfrm>
+            <a:off x="749808" y="1508760"/>
+            <a:ext cx="6629400" cy="749808"/>
+          </a:xfrm>
+          <a:prstGeom prst="rect">
+            <a:avLst/>
+          </a:prstGeom>
+          <a:noFill/>
+        </p:spPr>
+        <p:txBody>
+          <a:bodyPr wrap="square" lIns="0" rIns="0" tIns="0" bIns="0" anchor="t">
+            <a:spAutoFit/>
+          </a:bodyPr>
+          <a:lstStyle/>
+          <a:p>
+            <a:pPr algn="l"/>
+            <a:r>
+              <a:rPr sz="4400" b="1">
+                <a:solidFill>
+                  <a:srgbClr val="FFFFFF"/>
+                </a:solidFill>
+                <a:latin typeface="Georgia"/>
+              </a:rPr>
+              <a:t>每日项目状态汇报</a:t>
+            </a:r>
+          </a:p>
+        </p:txBody>
+      </p:sp>
+      <p:sp>
+        <p:nvSpPr>
+          <p:cNvPr id="31" name="TextBox 30"/>
+          <p:cNvSpPr txBox="1"/>
+          <p:nvPr/>
+        </p:nvSpPr>
+        <p:spPr>
+          <a:xfrm>
+            <a:off x="804672" y="2340864"/>
+            <a:ext cx="6400800" cy="347472"/>
+          </a:xfrm>
+          <a:prstGeom prst="rect">
+            <a:avLst/>
+          </a:prstGeom>
+          <a:noFill/>
+        </p:spPr>
+        <p:txBody>
+          <a:bodyPr wrap="square" lIns="0" rIns="0" tIns="0" bIns="0" anchor="t">
+            <a:spAutoFit/>
+          </a:bodyPr>
+          <a:lstStyle/>
+          <a:p>
+            <a:pPr algn="l"/>
+            <a:r>
+              <a:rPr sz="1800" b="0">
+                <a:solidFill>
+                  <a:srgbClr val="D6F4EF"/>
+                </a:solidFill>
+                <a:latin typeface="Calibri"/>
+              </a:rPr>
+              <a:t>AI 零代码应用生成平台 · yu-ai-code-mother</a:t>
             </a:r>
           </a:p>
         </p:txBody>

</xml_diff>